<commit_message>
Module 6 deck: verifier fixes (sourced claims, chart ratings, word count, references)
Co-Authored-By: Claude Opus 5.5 <noreply@anthropic.com>
</commit_message>
<xml_diff>
--- a/module-06-adversarial-attacks/Bandari_Ruthvik_Nath_Module6_Adversarial_Attack_Analysis.pptx
+++ b/module-06-adversarial-attacks/Bandari_Ruthvik_Nath_Module6_Adversarial_Attack_Analysis.pptx
@@ -578,7 +578,7 @@
           <a:lstStyle/>
           <a:p>
             <a:r>
-              <a:t>An adversarial attack makes an AI system decide wrongly on purpose. The four techniques in the brief are evasion, where a crafted input fools a trained model; poisoning, where the training data or model is corrupted; prompt injection, where hidden instructions take over an AI assistant; and deepfakes, where AI-generated faces and voices impersonate real people. The impact is financial. In January 2024 one deepfake video call cost a Hong Kong firm 25 million US dollars, and Deloitte projects that generative AI could push US fraud losses to 40 billion dollars by 2027, growing 32 percent a year. The camera fooled by tape in the McAfee test is used in more than 40 million vehicles. Deepfake fraud is the fastest-growing technique against people, and prompt injection is the main attack on AI assistants. The most exposed industries are autonomous vehicles, finance and healthcare, because a single wrong decision there costs lives or money.</a:t>
+              <a:t>An adversarial attack makes an AI system decide wrongly on purpose. The four techniques are evasion, where a crafted input fools a trained model; poisoning, where the training data or model is corrupted; prompt injection, where hidden instructions take over an AI assistant; and deepfakes, where AI-generated faces and voices impersonate real people. The impact is financial. In January 2024 one deepfake video call cost a Hong Kong firm 25 million US dollars. Deloitte projects that generative AI could push US fraud losses to 40 billion dollars by 2027, growing 32 percent a year, and reports that deepfake incidents in fintech rose 700 percent in 2023. The techniques used most are deepfake fraud against people and prompt injection against AI assistants, which is the attack Google, Microsoft and Meta now build dedicated defenses for. The most exposed industries are autonomous vehicles and finance, and healthcare wherever models make clinical decisions.</a:t>
             </a:r>
           </a:p>
         </p:txBody>
@@ -648,7 +648,7 @@
           <a:lstStyle/>
           <a:p>
             <a:r>
-              <a:t>Three cases show the threat across industries. In 2020, McAfee researchers put about two inches of black tape on a 35 mile-per-hour sign; the MobilEye camera on a 2016 Tesla read it as 85, and with cruise control on the car began accelerating toward 85 before the researchers braked. That camera is in more than 40 million vehicles. In January 2024, an employee of a Hong Kong firm joined a video call in which the chief financial officer and other colleagues were deepfakes, and sent 25 million US dollars to the fraudsters. In June 2025, Microsoft disclosed EchoLeak, a critical prompt-injection flaw rated 9.3 in which a crafted email could make Microsoft 365 Copilot leak data without the user clicking anything. Microsoft fixed it on the server side, and no exploitation was reported, which makes it an example of an attack stopped before it caused damage.</a:t>
+              <a:t>Three cases show the threat across industries. In 2020, McAfee researchers put about two inches of black tape on a 35 mile-per-hour sign; the MobilEye EyeQ3 camera on a 2016 Tesla read it as 85, and with cruise control on the car began accelerating toward 85 before the researchers braked. A 2020 camera did not appear vulnerable in limited tests, but McAfee notes the vulnerable camera remains in a sizeable share of Teslas. In January 2024, an employee of a Hong Kong firm joined a video call in which the chief financial officer and other colleagues were deepfakes, and sent 25 million US dollars to the fraudsters; in my view a call-back check on a known number would have stopped it. In June 2025, Microsoft disclosed a critical prompt-injection flaw in Microsoft 365 Copilot, CVE-2025-32711, rated 9.3, that needed no user interaction. Microsoft fully mitigated it on the server side and reported no exploitation, so this attack was stopped before it caused damage.</a:t>
             </a:r>
           </a:p>
         </p:txBody>
@@ -718,7 +718,7 @@
           <a:lstStyle/>
           <a:p>
             <a:r>
-              <a:t>Industry leaders use three complementary defenses. Microsoft's AI Red Team has attacked more than 100 of its own generative AI products before release; its lessons are that attackers do not need gradients or deep math to break a system, that automation helps but human testers remain crucial, and that the work is never complete. That is how companies test for vulnerabilities. Google defends Gemini with layers, and reports that training the model on adversarial examples of prompt injection significantly improved its resistance, backed by machine learning classifiers that detect malicious instructions, removal of suspicious links and asking the user to confirm risky actions. Meta released LlamaFirewall as an open-source guardrail for AI agents, with PromptGuard 2 to detect jailbreaks, an alignment check that audits the agent's reasoning, and CodeShield to block insecure code. Across all three, the message is the same: no single defense is enough, so the most effective strategy is layered.</a:t>
+              <a:t>Industry leaders use complementary defenses. Microsoft's AI Red Team has attacked more than 100 of its own generative AI products; its lessons are that attackers do not need gradients to break a system, that automation helps but human testers remain crucial, and that the work is never complete. That is how companies test for vulnerabilities: red teams and automated tools attack the model before release and after every change. Google defends Gemini in layers and reports that training the model on adversarial prompt-injection data significantly enhanced its defenses, backed by classifiers that detect malicious instructions, redaction of suspicious links and user confirmation of risky actions. Meta released LlamaFirewall, an open-source guardrail for AI agents, with PromptGuard 2 to detect jailbreaks, AlignmentCheck to audit the agent's reasoning, and CodeShield to block insecure code. Across all three, no single defense is enough, so the most effective strategy is layered, and the Copilot case shows it can stop an attack before harm.</a:t>
             </a:r>
           </a:p>
         </p:txBody>
@@ -788,7 +788,7 @@
           <a:lstStyle/>
           <a:p>
             <a:r>
-              <a:t>This chart compares the four attack types with five defense strategies, and names the industry each attack hits hardest. Evasion attacks, like the tape on the speed sign, matter most for autonomous vehicles; adversarial training and robustness testing make the model harder to fool, and anomaly detection can flag an input that does not fit, such as an 85 mile-per-hour reading in a 35 zone. Poisoning threatens healthcare and finance models that retrain on new data; testing and screening training data for outliers help most. Prompt injection threatens enterprise AI assistants, where every layer helps, which is why Google and Meta stack them. Deepfakes hit finance; the model cannot be retrained against them, so anomaly checks on payments and human call-back verification work best. The ratings are my assessment from the cases and the companies' published defenses.</a:t>
+              <a:t>This chart compares the four attack types with five defense strategies and names the industry each attack hits hardest. The ratings are my assessment from the cases and the companies' published defenses. Evasion, like the tape on the speed sign, matters most for autonomous vehicles; red teaming and anomaly detection, which can flag an 85 reading in a 35 zone, fit best, while adversarial training only partly helps because attackers adapt. Poisoning threatens any model that retrains on new data; testing and screening new data for outliers help most. Prompt injection threatens enterprise AI assistants, where every layer helps, which is why Google and Meta stack them. Deepfakes hit finance; a model cannot be retrained against them, so human call-back verification works best.</a:t>
             </a:r>
           </a:p>
         </p:txBody>
@@ -858,7 +858,7 @@
           <a:lstStyle/>
           <a:p>
             <a:r>
-              <a:t>Chapter 5 of the textbook, Network Anomaly Detection with AI, teaches a model of normal behaviour that flags anything that does not fit. The same idea is a practical defense against adversarial attacks. A speed reading of 85 on a 35 road is out of distribution, so the car should slow down and alert the driver. A large, urgent transfer right after one video call is unusual, so the payment should be held and confirmed by phone. Outliers in new training data can be screened before retraining, which blocks poisoning, and an AI assistant that suddenly sends data to an outside link can be stopped. The current trend is AI governance. Article 15 of the EU AI Act requires high-risk AI systems to resist attempts to alter their outputs, names data poisoning, model poisoning and adversarial examples, and requires measures to prevent, detect and respond to them. Together they turn robustness testing and anomaly detection from good practice into a legal duty.</a:t>
+              <a:t>Chapter 5 of the textbook, Network Anomaly Detection with AI, teaches a model of normal behaviour that flags anything that does not fit. The same idea is a practical defense against adversarial attacks. A speed reading of 85 on a 35 road is out of range, so the car should slow down and alert the driver. A large, urgent transfer right after one video call is unusual, so the payment should be held and confirmed by phone. Outliers in new training data can be screened before retraining, which blocks poisoning, and an AI assistant that suddenly sends data outside can be stopped. The current trend is AI governance. Article 15 of the EU AI Act requires high-risk AI systems to resist attempts to alter their outputs, names data poisoning, model poisoning and adversarial examples, and requires measures to prevent, detect and respond to them. That turns robustness testing and anomaly detection from good practice into a legal duty for high-risk systems.</a:t>
             </a:r>
           </a:p>
         </p:txBody>
@@ -4110,13 +4110,13 @@
               </a:spcAft>
             </a:pPr>
             <a:r>
-              <a:rPr sz="2000" b="0" i="0">
+              <a:rPr sz="2100" b="0" i="0">
                 <a:solidFill>
                   <a:srgbClr val="C9D3E0"/>
                 </a:solidFill>
                 <a:latin typeface="Calibri"/>
               </a:rPr>
-              <a:t>One threat, adversarial manipulation of AI systems, traced through three real cases, three company defenses and the rules now taking shape</a:t>
+              <a:t>One threat, three real cases, three company defenses</a:t>
             </a:r>
           </a:p>
         </p:txBody>
@@ -4354,7 +4354,7 @@
         <p:spPr>
           <a:xfrm>
             <a:off x="548640" y="1691640"/>
-            <a:ext cx="2624328" cy="1417320"/>
+            <a:ext cx="2624328" cy="1188720"/>
           </a:xfrm>
           <a:prstGeom prst="roundRect">
             <a:avLst>
@@ -4482,7 +4482,7 @@
         <p:spPr>
           <a:xfrm>
             <a:off x="731520" y="2286000"/>
-            <a:ext cx="2286000" cy="777240"/>
+            <a:ext cx="2286000" cy="548640"/>
           </a:xfrm>
           <a:prstGeom prst="rect">
             <a:avLst/>
@@ -4510,7 +4510,7 @@
                 </a:solidFill>
                 <a:latin typeface="Calibri"/>
               </a:rPr>
-              <a:t>Altered input fools a trained model (a sign, an image)</a:t>
+              <a:t>Altered input fools a model</a:t>
             </a:r>
           </a:p>
         </p:txBody>
@@ -4524,7 +4524,7 @@
         <p:spPr>
           <a:xfrm>
             <a:off x="3355848" y="1691640"/>
-            <a:ext cx="2624328" cy="1417320"/>
+            <a:ext cx="2624328" cy="1188720"/>
           </a:xfrm>
           <a:prstGeom prst="roundRect">
             <a:avLst>
@@ -4652,7 +4652,7 @@
         <p:spPr>
           <a:xfrm>
             <a:off x="3538728" y="2286000"/>
-            <a:ext cx="2286000" cy="777240"/>
+            <a:ext cx="2286000" cy="548640"/>
           </a:xfrm>
           <a:prstGeom prst="rect">
             <a:avLst/>
@@ -4680,7 +4680,7 @@
                 </a:solidFill>
                 <a:latin typeface="Calibri"/>
               </a:rPr>
-              <a:t>Corrupted training data or model components</a:t>
+              <a:t>Corrupted training data or model</a:t>
             </a:r>
           </a:p>
         </p:txBody>
@@ -4694,7 +4694,7 @@
         <p:spPr>
           <a:xfrm>
             <a:off x="6163055" y="1691640"/>
-            <a:ext cx="2624328" cy="1417320"/>
+            <a:ext cx="2624328" cy="1188720"/>
           </a:xfrm>
           <a:prstGeom prst="roundRect">
             <a:avLst>
@@ -4822,7 +4822,7 @@
         <p:spPr>
           <a:xfrm>
             <a:off x="6345936" y="2286000"/>
-            <a:ext cx="2286000" cy="777240"/>
+            <a:ext cx="2286000" cy="548640"/>
           </a:xfrm>
           <a:prstGeom prst="rect">
             <a:avLst/>
@@ -4864,7 +4864,7 @@
         <p:spPr>
           <a:xfrm>
             <a:off x="8970263" y="1691640"/>
-            <a:ext cx="2624328" cy="1417320"/>
+            <a:ext cx="2624328" cy="1188720"/>
           </a:xfrm>
           <a:prstGeom prst="roundRect">
             <a:avLst>
@@ -4992,7 +4992,7 @@
         <p:spPr>
           <a:xfrm>
             <a:off x="9153143" y="2286000"/>
-            <a:ext cx="2286000" cy="777240"/>
+            <a:ext cx="2286000" cy="548640"/>
           </a:xfrm>
           <a:prstGeom prst="rect">
             <a:avLst/>
@@ -5020,7 +5020,7 @@
                 </a:solidFill>
                 <a:latin typeface="Calibri"/>
               </a:rPr>
-              <a:t>AI-faked faces and voices fool people and checks</a:t>
+              <a:t>Faked faces and voices fool people</a:t>
             </a:r>
           </a:p>
         </p:txBody>
@@ -5033,7 +5033,7 @@
         </p:nvSpPr>
         <p:spPr>
           <a:xfrm>
-            <a:off x="548640" y="3429000"/>
+            <a:off x="548640" y="3200400"/>
             <a:ext cx="3566160" cy="1234440"/>
           </a:xfrm>
           <a:prstGeom prst="roundRect">
@@ -5077,7 +5077,7 @@
         </p:nvSpPr>
         <p:spPr>
           <a:xfrm>
-            <a:off x="548640" y="3429000"/>
+            <a:off x="548640" y="3200400"/>
             <a:ext cx="73152" cy="1234440"/>
           </a:xfrm>
           <a:prstGeom prst="rect">
@@ -5119,7 +5119,7 @@
         </p:nvSpPr>
         <p:spPr>
           <a:xfrm>
-            <a:off x="822959" y="3557016"/>
+            <a:off x="822959" y="3328416"/>
             <a:ext cx="3154679" cy="548640"/>
           </a:xfrm>
           <a:prstGeom prst="rect">
@@ -5161,7 +5161,7 @@
         </p:nvSpPr>
         <p:spPr>
           <a:xfrm>
-            <a:off x="822959" y="4142232"/>
+            <a:off x="822959" y="3913632"/>
             <a:ext cx="3154679" cy="502920"/>
           </a:xfrm>
           <a:prstGeom prst="rect">
@@ -5190,7 +5190,7 @@
                 </a:solidFill>
                 <a:latin typeface="Calibri"/>
               </a:rPr>
-              <a:t>lost in one deepfake video call, Hong Kong, January 2024</a:t>
+              <a:t>lost in one deepfake video call (Hong Kong, 2024)</a:t>
             </a:r>
           </a:p>
         </p:txBody>
@@ -5203,7 +5203,7 @@
         </p:nvSpPr>
         <p:spPr>
           <a:xfrm>
-            <a:off x="4315968" y="3429000"/>
+            <a:off x="4315968" y="3200400"/>
             <a:ext cx="3566160" cy="1234440"/>
           </a:xfrm>
           <a:prstGeom prst="roundRect">
@@ -5247,7 +5247,7 @@
         </p:nvSpPr>
         <p:spPr>
           <a:xfrm>
-            <a:off x="4315968" y="3429000"/>
+            <a:off x="4315968" y="3200400"/>
             <a:ext cx="73152" cy="1234440"/>
           </a:xfrm>
           <a:prstGeom prst="rect">
@@ -5289,7 +5289,7 @@
         </p:nvSpPr>
         <p:spPr>
           <a:xfrm>
-            <a:off x="4590288" y="3557016"/>
+            <a:off x="4590288" y="3328416"/>
             <a:ext cx="3154679" cy="548640"/>
           </a:xfrm>
           <a:prstGeom prst="rect">
@@ -5331,7 +5331,7 @@
         </p:nvSpPr>
         <p:spPr>
           <a:xfrm>
-            <a:off x="4590288" y="4142232"/>
+            <a:off x="4590288" y="3913632"/>
             <a:ext cx="3154679" cy="502920"/>
           </a:xfrm>
           <a:prstGeom prst="rect">
@@ -5360,7 +5360,7 @@
                 </a:solidFill>
                 <a:latin typeface="Calibri"/>
               </a:rPr>
-              <a:t>projected US fraud losses enabled by generative AI by 2027 (32% a year)</a:t>
+              <a:t>projected US fraud losses from generative AI by 2027</a:t>
             </a:r>
           </a:p>
         </p:txBody>
@@ -5373,7 +5373,7 @@
         </p:nvSpPr>
         <p:spPr>
           <a:xfrm>
-            <a:off x="8083296" y="3429000"/>
+            <a:off x="8083296" y="3200400"/>
             <a:ext cx="3566160" cy="1234440"/>
           </a:xfrm>
           <a:prstGeom prst="roundRect">
@@ -5417,7 +5417,7 @@
         </p:nvSpPr>
         <p:spPr>
           <a:xfrm>
-            <a:off x="8083296" y="3429000"/>
+            <a:off x="8083296" y="3200400"/>
             <a:ext cx="73152" cy="1234440"/>
           </a:xfrm>
           <a:prstGeom prst="rect">
@@ -5459,7 +5459,7 @@
         </p:nvSpPr>
         <p:spPr>
           <a:xfrm>
-            <a:off x="8357616" y="3557016"/>
+            <a:off x="8357616" y="3328416"/>
             <a:ext cx="3154679" cy="548640"/>
           </a:xfrm>
           <a:prstGeom prst="rect">
@@ -5488,7 +5488,7 @@
                 </a:solidFill>
                 <a:latin typeface="Calibri"/>
               </a:rPr>
-              <a:t>40+ million</a:t>
+              <a:t>+700%</a:t>
             </a:r>
           </a:p>
         </p:txBody>
@@ -5501,7 +5501,7 @@
         </p:nvSpPr>
         <p:spPr>
           <a:xfrm>
-            <a:off x="8357616" y="4142232"/>
+            <a:off x="8357616" y="3913632"/>
             <a:ext cx="3154679" cy="502920"/>
           </a:xfrm>
           <a:prstGeom prst="rect">
@@ -5530,7 +5530,7 @@
                 </a:solidFill>
                 <a:latin typeface="Calibri"/>
               </a:rPr>
-              <a:t>vehicles use the camera that a strip of tape fooled</a:t>
+              <a:t>deepfake incidents in fintech in 2023</a:t>
             </a:r>
           </a:p>
         </p:txBody>
@@ -5543,8 +5543,132 @@
         </p:nvSpPr>
         <p:spPr>
           <a:xfrm>
-            <a:off x="548640" y="4983480"/>
-            <a:ext cx="11064240" cy="1097280"/>
+            <a:off x="548640" y="4709160"/>
+            <a:ext cx="11064240" cy="1463040"/>
+          </a:xfrm>
+          <a:prstGeom prst="rect">
+            <a:avLst/>
+          </a:prstGeom>
+          <a:noFill/>
+        </p:spPr>
+        <p:txBody>
+          <a:bodyPr wrap="square" lIns="0" rIns="0" tIns="0" bIns="0">
+            <a:spAutoFit/>
+          </a:bodyPr>
+          <a:lstStyle/>
+          <a:p>
+            <a:pPr marL="256032" indent="-256032">
+              <a:lnSpc>
+                <a:spcPct val="110000"/>
+              </a:lnSpc>
+              <a:spcAft>
+                <a:spcPts val="600"/>
+              </a:spcAft>
+              <a:buClr>
+                <a:srgbClr val="1F5FAD"/>
+              </a:buClr>
+              <a:buFont typeface="Arial"/>
+              <a:buChar char="■"/>
+            </a:pPr>
+            <a:r>
+              <a:rPr sz="1500" b="1" i="0">
+                <a:solidFill>
+                  <a:srgbClr val="1F2937"/>
+                </a:solidFill>
+                <a:latin typeface="Calibri"/>
+              </a:rPr>
+              <a:t>Used most:</a:t>
+            </a:r>
+            <a:r>
+              <a:rPr sz="1500" b="0" i="0">
+                <a:solidFill>
+                  <a:srgbClr val="1F2937"/>
+                </a:solidFill>
+                <a:latin typeface="Calibri"/>
+              </a:rPr>
+              <a:t> deepfake fraud against people, and prompt injection against AI assistants, the attack Google, Microsoft and Meta now build defenses for.</a:t>
+            </a:r>
+          </a:p>
+          <a:p>
+            <a:pPr marL="256032" indent="-256032">
+              <a:lnSpc>
+                <a:spcPct val="110000"/>
+              </a:lnSpc>
+              <a:spcAft>
+                <a:spcPts val="600"/>
+              </a:spcAft>
+              <a:buClr>
+                <a:srgbClr val="1F5FAD"/>
+              </a:buClr>
+              <a:buFont typeface="Arial"/>
+              <a:buChar char="■"/>
+            </a:pPr>
+            <a:r>
+              <a:rPr sz="1500" b="1" i="0">
+                <a:solidFill>
+                  <a:srgbClr val="1F2937"/>
+                </a:solidFill>
+                <a:latin typeface="Calibri"/>
+              </a:rPr>
+              <a:t>Most exposed:</a:t>
+            </a:r>
+            <a:r>
+              <a:rPr sz="1500" b="0" i="0">
+                <a:solidFill>
+                  <a:srgbClr val="1F2937"/>
+                </a:solidFill>
+                <a:latin typeface="Calibri"/>
+              </a:rPr>
+              <a:t> autonomous vehicles, finance and, wherever models make clinical calls, healthcare.</a:t>
+            </a:r>
+          </a:p>
+        </p:txBody>
+      </p:sp>
+      <p:cxnSp>
+        <p:nvCxnSpPr>
+          <p:cNvPr id="34" name="Connector 33"/>
+          <p:cNvCxnSpPr/>
+          <p:nvPr/>
+        </p:nvCxnSpPr>
+        <p:spPr>
+          <a:xfrm>
+            <a:off x="548640" y="6355080"/>
+            <a:ext cx="11094415" cy="0"/>
+          </a:xfrm>
+          <a:prstGeom prst="line">
+            <a:avLst/>
+          </a:prstGeom>
+          <a:ln w="9525">
+            <a:solidFill>
+              <a:srgbClr val="D5DAE1"/>
+            </a:solidFill>
+          </a:ln>
+        </p:spPr>
+        <p:style>
+          <a:lnRef idx="2">
+            <a:schemeClr val="accent1"/>
+          </a:lnRef>
+          <a:fillRef idx="0">
+            <a:schemeClr val="accent1"/>
+          </a:fillRef>
+          <a:effectRef idx="1">
+            <a:schemeClr val="accent1"/>
+          </a:effectRef>
+          <a:fontRef idx="minor">
+            <a:schemeClr val="tx1"/>
+          </a:fontRef>
+        </p:style>
+      </p:cxnSp>
+      <p:sp>
+        <p:nvSpPr>
+          <p:cNvPr id="35" name="TextBox 34"/>
+          <p:cNvSpPr txBox="1"/>
+          <p:nvPr/>
+        </p:nvSpPr>
+        <p:spPr>
+          <a:xfrm>
+            <a:off x="548640" y="6446520"/>
+            <a:ext cx="10545775" cy="274320"/>
           </a:xfrm>
           <a:prstGeom prst="rect">
             <a:avLst/>
@@ -5566,99 +5690,13 @@
               </a:spcAft>
             </a:pPr>
             <a:r>
-              <a:rPr sz="1500" b="1" i="0">
-                <a:solidFill>
-                  <a:srgbClr val="1F2937"/>
-                </a:solidFill>
-                <a:latin typeface="Calibri"/>
-              </a:rPr>
-              <a:t>Most exposed industries:</a:t>
-            </a:r>
-            <a:r>
-              <a:rPr sz="1500" b="0" i="0">
-                <a:solidFill>
-                  <a:srgbClr val="1F2937"/>
-                </a:solidFill>
-                <a:latin typeface="Calibri"/>
-              </a:rPr>
-              <a:t> autonomous vehicles (safety), finance (money moved on a faked instruction) and healthcare (life-critical model decisions).</a:t>
-            </a:r>
-          </a:p>
-        </p:txBody>
-      </p:sp>
-      <p:cxnSp>
-        <p:nvCxnSpPr>
-          <p:cNvPr id="34" name="Connector 33"/>
-          <p:cNvCxnSpPr/>
-          <p:nvPr/>
-        </p:nvCxnSpPr>
-        <p:spPr>
-          <a:xfrm>
-            <a:off x="548640" y="6355080"/>
-            <a:ext cx="11094415" cy="0"/>
-          </a:xfrm>
-          <a:prstGeom prst="line">
-            <a:avLst/>
-          </a:prstGeom>
-          <a:ln w="9525">
-            <a:solidFill>
-              <a:srgbClr val="D5DAE1"/>
-            </a:solidFill>
-          </a:ln>
-        </p:spPr>
-        <p:style>
-          <a:lnRef idx="2">
-            <a:schemeClr val="accent1"/>
-          </a:lnRef>
-          <a:fillRef idx="0">
-            <a:schemeClr val="accent1"/>
-          </a:fillRef>
-          <a:effectRef idx="1">
-            <a:schemeClr val="accent1"/>
-          </a:effectRef>
-          <a:fontRef idx="minor">
-            <a:schemeClr val="tx1"/>
-          </a:fontRef>
-        </p:style>
-      </p:cxnSp>
-      <p:sp>
-        <p:nvSpPr>
-          <p:cNvPr id="35" name="TextBox 34"/>
-          <p:cNvSpPr txBox="1"/>
-          <p:nvPr/>
-        </p:nvSpPr>
-        <p:spPr>
-          <a:xfrm>
-            <a:off x="548640" y="6446520"/>
-            <a:ext cx="10545775" cy="274320"/>
-          </a:xfrm>
-          <a:prstGeom prst="rect">
-            <a:avLst/>
-          </a:prstGeom>
-          <a:noFill/>
-        </p:spPr>
-        <p:txBody>
-          <a:bodyPr wrap="square" lIns="0" rIns="0" tIns="0" bIns="0" anchor="t">
-            <a:spAutoFit/>
-          </a:bodyPr>
-          <a:lstStyle/>
-          <a:p>
-            <a:pPr algn="l">
-              <a:lnSpc>
-                <a:spcPct val="110000"/>
-              </a:lnSpc>
-              <a:spcAft>
-                <a:spcPts val="600"/>
-              </a:spcAft>
-            </a:pPr>
-            <a:r>
               <a:rPr sz="1000" b="0" i="0">
                 <a:solidFill>
                   <a:srgbClr val="5B6472"/>
                 </a:solidFill>
                 <a:latin typeface="Calibri"/>
               </a:rPr>
-              <a:t>Sources: Lalchand et al. (2024); Povolny &amp; Trivedi (2020); Parisi (2019, Ch. 10).</a:t>
+              <a:t>Sources: Lalchand et al. (2024); Google GenAI Security Team (2025); Parisi (2019, Ch. 10).</a:t>
             </a:r>
           </a:p>
         </p:txBody>
@@ -5858,7 +5896,7 @@
         <p:spPr>
           <a:xfrm>
             <a:off x="548640" y="1645920"/>
-            <a:ext cx="3611880" cy="3429000"/>
+            <a:ext cx="3611880" cy="3246120"/>
           </a:xfrm>
           <a:prstGeom prst="roundRect">
             <a:avLst>
@@ -6028,7 +6066,7 @@
         <p:spPr>
           <a:xfrm>
             <a:off x="777240" y="2880360"/>
-            <a:ext cx="3154680" cy="2057400"/>
+            <a:ext cx="3154680" cy="1874519"/>
           </a:xfrm>
           <a:prstGeom prst="rect">
             <a:avLst/>
@@ -6065,7 +6103,7 @@
                 </a:solidFill>
                 <a:latin typeface="Calibri"/>
               </a:rPr>
-              <a:t> 5 cm of black tape on a 35 mph sign made the MobilEye camera read 85.</a:t>
+              <a:t> About 5 cm of tape made the MobilEye camera read 35 mph as 85.</a:t>
             </a:r>
           </a:p>
           <a:p>
@@ -6093,7 +6131,7 @@
                 </a:solidFill>
                 <a:latin typeface="Calibri"/>
               </a:rPr>
-              <a:t> The car began accelerating toward 85 mph; the camera is in 40+ million vehicles.</a:t>
+              <a:t> The car began accelerating toward 85 mph.</a:t>
             </a:r>
           </a:p>
           <a:p>
@@ -6121,7 +6159,7 @@
                 </a:solidFill>
                 <a:latin typeface="Calibri"/>
               </a:rPr>
-              <a:t> Newer cameras handle it; older cars were not updated.</a:t>
+              <a:t> A 2020 camera seemed immune; vulnerable ones remain in many Teslas.</a:t>
             </a:r>
           </a:p>
         </p:txBody>
@@ -6135,7 +6173,7 @@
         <p:spPr>
           <a:xfrm>
             <a:off x="4325112" y="1645920"/>
-            <a:ext cx="3611880" cy="3429000"/>
+            <a:ext cx="3611880" cy="3246120"/>
           </a:xfrm>
           <a:prstGeom prst="roundRect">
             <a:avLst>
@@ -6305,7 +6343,7 @@
         <p:spPr>
           <a:xfrm>
             <a:off x="4553712" y="2880360"/>
-            <a:ext cx="3154680" cy="2057400"/>
+            <a:ext cx="3154680" cy="1874519"/>
           </a:xfrm>
           <a:prstGeom prst="rect">
             <a:avLst/>
@@ -6342,7 +6380,7 @@
                 </a:solidFill>
                 <a:latin typeface="Calibri"/>
               </a:rPr>
-              <a:t> An employee joined a video call where the CFO and colleagues were all deepfakes.</a:t>
+              <a:t> Every other person on the video call was a deepfake.</a:t>
             </a:r>
           </a:p>
           <a:p>
@@ -6388,7 +6426,7 @@
                 </a:solidFill>
                 <a:latin typeface="Calibri"/>
               </a:rPr>
-              <a:t> sent to the fraudsters.</a:t>
+              <a:t> sent to fraudsters.</a:t>
             </a:r>
           </a:p>
           <a:p>
@@ -6407,7 +6445,7 @@
                 </a:solidFill>
                 <a:latin typeface="Calibri"/>
               </a:rPr>
-              <a:t>Outcome:</a:t>
+              <a:t>Lesson:</a:t>
             </a:r>
             <a:r>
               <a:rPr sz="1300" b="0" i="0">
@@ -6416,7 +6454,7 @@
                 </a:solidFill>
                 <a:latin typeface="Calibri"/>
               </a:rPr>
-              <a:t> Money lost; the firm and its staff were tricked, not its IT systems.</a:t>
+              <a:t> A call-back check would have stopped it.</a:t>
             </a:r>
           </a:p>
         </p:txBody>
@@ -6430,7 +6468,7 @@
         <p:spPr>
           <a:xfrm>
             <a:off x="8101583" y="1645920"/>
-            <a:ext cx="3611880" cy="3429000"/>
+            <a:ext cx="3611880" cy="3246120"/>
           </a:xfrm>
           <a:prstGeom prst="roundRect">
             <a:avLst>
@@ -6586,7 +6624,7 @@
                 </a:solidFill>
                 <a:latin typeface="Calibri"/>
               </a:rPr>
-              <a:t>EchoLeak: Microsoft 365 Copilot</a:t>
+              <a:t>Microsoft 365 Copilot</a:t>
             </a:r>
           </a:p>
         </p:txBody>
@@ -6600,7 +6638,7 @@
         <p:spPr>
           <a:xfrm>
             <a:off x="8330183" y="2880360"/>
-            <a:ext cx="3154680" cy="2057400"/>
+            <a:ext cx="3154680" cy="1874519"/>
           </a:xfrm>
           <a:prstGeom prst="rect">
             <a:avLst/>
@@ -6637,7 +6675,7 @@
                 </a:solidFill>
                 <a:latin typeface="Calibri"/>
               </a:rPr>
-              <a:t> A crafted email could make Copilot leak data with zero clicks.</a:t>
+              <a:t> Injected instructions could make Copilot disclose data, with no user interaction.</a:t>
             </a:r>
           </a:p>
           <a:p>
@@ -6683,7 +6721,7 @@
                 </a:solidFill>
                 <a:latin typeface="Calibri"/>
               </a:rPr>
-              <a:t> (CVSS).</a:t>
+              <a:t>.</a:t>
             </a:r>
           </a:p>
           <a:p>
@@ -6702,7 +6740,7 @@
                 </a:solidFill>
                 <a:latin typeface="Calibri"/>
               </a:rPr>
-              <a:t>Outcome:</a:t>
+              <a:t>Stopped:</a:t>
             </a:r>
             <a:r>
               <a:rPr sz="1300" b="0" i="0">
@@ -6711,7 +6749,7 @@
                 </a:solidFill>
                 <a:latin typeface="Calibri"/>
               </a:rPr>
-              <a:t> Microsoft fixed it server-side; no exploitation was reported.</a:t>
+              <a:t> Microsoft fixed it server-side; no exploitation.</a:t>
             </a:r>
           </a:p>
         </p:txBody>
@@ -6724,7 +6762,7 @@
         </p:nvSpPr>
         <p:spPr>
           <a:xfrm>
-            <a:off x="548640" y="5303520"/>
+            <a:off x="548640" y="5120640"/>
             <a:ext cx="11064240" cy="274320"/>
           </a:xfrm>
           <a:prstGeom prst="rect">
@@ -6766,7 +6804,7 @@
         </p:nvSpPr>
         <p:spPr>
           <a:xfrm>
-            <a:off x="548640" y="5623560"/>
+            <a:off x="548640" y="5440680"/>
             <a:ext cx="11064240" cy="548640"/>
           </a:xfrm>
           <a:prstGeom prst="rect">
@@ -6795,7 +6833,7 @@
                 </a:solidFill>
                 <a:latin typeface="Calibri"/>
               </a:rPr>
-              <a:t>None needed a break-in: each fooled a trusted AI, or a person, with input crafted for it.</a:t>
+              <a:t>None needed a break-in: each fooled a trusted AI, or a person, with crafted input.</a:t>
             </a:r>
           </a:p>
         </p:txBody>
@@ -7072,7 +7110,7 @@
         <p:spPr>
           <a:xfrm>
             <a:off x="548640" y="1645920"/>
-            <a:ext cx="3611880" cy="3246120"/>
+            <a:ext cx="3611880" cy="2651760"/>
           </a:xfrm>
           <a:prstGeom prst="roundRect">
             <a:avLst>
@@ -7242,7 +7280,7 @@
         <p:spPr>
           <a:xfrm>
             <a:off x="777240" y="2880360"/>
-            <a:ext cx="3154680" cy="1874519"/>
+            <a:ext cx="3154680" cy="1280160"/>
           </a:xfrm>
           <a:prstGeom prst="rect">
             <a:avLst/>
@@ -7307,7 +7345,7 @@
                 </a:solidFill>
                 <a:latin typeface="Calibri"/>
               </a:rPr>
-              <a:t>Lessons: attacks need no gradients, humans stay crucial, security is never finished.</a:t>
+              <a:t>Humans stay crucial; the work is never finished.</a:t>
             </a:r>
           </a:p>
         </p:txBody>
@@ -7321,7 +7359,7 @@
         <p:spPr>
           <a:xfrm>
             <a:off x="4325112" y="1645920"/>
-            <a:ext cx="3611880" cy="3246120"/>
+            <a:ext cx="3611880" cy="2651760"/>
           </a:xfrm>
           <a:prstGeom prst="roundRect">
             <a:avLst>
@@ -7491,7 +7529,7 @@
         <p:spPr>
           <a:xfrm>
             <a:off x="4553712" y="2880360"/>
-            <a:ext cx="3154680" cy="1874519"/>
+            <a:ext cx="3154680" cy="1280160"/>
           </a:xfrm>
           <a:prstGeom prst="rect">
             <a:avLst/>
@@ -7519,7 +7557,7 @@
                 </a:solidFill>
                 <a:latin typeface="Calibri"/>
               </a:rPr>
-              <a:t>Training on adversarial data “significantly enhanced” resistance to prompt injection.</a:t>
+              <a:t>Training on adversarial data “significantly enhanced” its prompt-injection defenses.</a:t>
             </a:r>
           </a:p>
           <a:p>
@@ -7538,7 +7576,7 @@
                 </a:solidFill>
                 <a:latin typeface="Calibri"/>
               </a:rPr>
-              <a:t>Plus ML classifiers, link redaction and user confirmation.</a:t>
+              <a:t>Plus classifiers and user confirmation.</a:t>
             </a:r>
           </a:p>
         </p:txBody>
@@ -7552,7 +7590,7 @@
         <p:spPr>
           <a:xfrm>
             <a:off x="8101583" y="1645920"/>
-            <a:ext cx="3611880" cy="3246120"/>
+            <a:ext cx="3611880" cy="2651760"/>
           </a:xfrm>
           <a:prstGeom prst="roundRect">
             <a:avLst>
@@ -7722,7 +7760,7 @@
         <p:spPr>
           <a:xfrm>
             <a:off x="8330183" y="2880360"/>
-            <a:ext cx="3154680" cy="1874519"/>
+            <a:ext cx="3154680" cy="1280160"/>
           </a:xfrm>
           <a:prstGeom prst="rect">
             <a:avLst/>
@@ -7805,7 +7843,7 @@
                 </a:solidFill>
                 <a:latin typeface="Calibri"/>
               </a:rPr>
-              <a:t> blocks insecure generated code.</a:t>
+              <a:t> blocks insecure code.</a:t>
             </a:r>
           </a:p>
         </p:txBody>
@@ -7818,8 +7856,8 @@
         </p:nvSpPr>
         <p:spPr>
           <a:xfrm>
-            <a:off x="548640" y="5074920"/>
-            <a:ext cx="11064240" cy="274320"/>
+            <a:off x="548640" y="4526280"/>
+            <a:ext cx="5486400" cy="274320"/>
           </a:xfrm>
           <a:prstGeom prst="rect">
             <a:avLst/>
@@ -7843,11 +7881,11 @@
             <a:r>
               <a:rPr sz="1200" b="1" i="0">
                 <a:solidFill>
-                  <a:srgbClr val="1E846F"/>
-                </a:solidFill>
-                <a:latin typeface="Calibri"/>
-              </a:rPr>
-              <a:t>WHAT IS PROVING MOST EFFECTIVE</a:t>
+                  <a:srgbClr val="1F5FAD"/>
+                </a:solidFill>
+                <a:latin typeface="Calibri"/>
+              </a:rPr>
+              <a:t>HOW THEY TEST</a:t>
             </a:r>
           </a:p>
         </p:txBody>
@@ -7860,8 +7898,8 @@
         </p:nvSpPr>
         <p:spPr>
           <a:xfrm>
-            <a:off x="548640" y="5394960"/>
-            <a:ext cx="11064240" cy="731520"/>
+            <a:off x="548640" y="4846320"/>
+            <a:ext cx="5394960" cy="1280160"/>
           </a:xfrm>
           <a:prstGeom prst="rect">
             <a:avLst/>
@@ -7883,61 +7921,59 @@
               </a:spcAft>
             </a:pPr>
             <a:r>
-              <a:rPr sz="1500" b="1" i="0">
+              <a:rPr sz="1500" b="0" i="0">
                 <a:solidFill>
                   <a:srgbClr val="1F2937"/>
                 </a:solidFill>
                 <a:latin typeface="Calibri"/>
               </a:rPr>
-              <a:t>Layers, not one fix:</a:t>
-            </a:r>
-            <a:r>
-              <a:rPr sz="1500" b="0" i="0">
-                <a:solidFill>
-                  <a:srgbClr val="1F2937"/>
-                </a:solidFill>
-                <a:latin typeface="Calibri"/>
-              </a:rPr>
-              <a:t> adversarial training + input/output classifiers + continuous red teaming + a human check before money moves.</a:t>
-            </a:r>
-          </a:p>
-        </p:txBody>
-      </p:sp>
-      <p:cxnSp>
-        <p:nvCxnSpPr>
-          <p:cNvPr id="22" name="Connector 21"/>
-          <p:cNvCxnSpPr/>
-          <p:nvPr/>
-        </p:nvCxnSpPr>
-        <p:spPr>
-          <a:xfrm>
-            <a:off x="548640" y="6355080"/>
-            <a:ext cx="11094415" cy="0"/>
-          </a:xfrm>
-          <a:prstGeom prst="line">
-            <a:avLst/>
-          </a:prstGeom>
-          <a:ln w="9525">
-            <a:solidFill>
-              <a:srgbClr val="D5DAE1"/>
-            </a:solidFill>
-          </a:ln>
-        </p:spPr>
-        <p:style>
-          <a:lnRef idx="2">
-            <a:schemeClr val="accent1"/>
-          </a:lnRef>
-          <a:fillRef idx="0">
-            <a:schemeClr val="accent1"/>
-          </a:fillRef>
-          <a:effectRef idx="1">
-            <a:schemeClr val="accent1"/>
-          </a:effectRef>
-          <a:fontRef idx="minor">
-            <a:schemeClr val="tx1"/>
-          </a:fontRef>
-        </p:style>
-      </p:cxnSp>
+              <a:t>Red teams and automated attack tools probe models before release, then again after every change.</a:t>
+            </a:r>
+          </a:p>
+        </p:txBody>
+      </p:sp>
+      <p:sp>
+        <p:nvSpPr>
+          <p:cNvPr id="22" name="TextBox 21"/>
+          <p:cNvSpPr txBox="1"/>
+          <p:nvPr/>
+        </p:nvSpPr>
+        <p:spPr>
+          <a:xfrm>
+            <a:off x="6400800" y="4526280"/>
+            <a:ext cx="5257800" cy="274320"/>
+          </a:xfrm>
+          <a:prstGeom prst="rect">
+            <a:avLst/>
+          </a:prstGeom>
+          <a:noFill/>
+        </p:spPr>
+        <p:txBody>
+          <a:bodyPr wrap="square" lIns="0" rIns="0" tIns="0" bIns="0" anchor="t">
+            <a:spAutoFit/>
+          </a:bodyPr>
+          <a:lstStyle/>
+          <a:p>
+            <a:pPr algn="l">
+              <a:lnSpc>
+                <a:spcPct val="110000"/>
+              </a:lnSpc>
+              <a:spcAft>
+                <a:spcPts val="0"/>
+              </a:spcAft>
+            </a:pPr>
+            <a:r>
+              <a:rPr sz="1200" b="1" i="0">
+                <a:solidFill>
+                  <a:srgbClr val="1E846F"/>
+                </a:solidFill>
+                <a:latin typeface="Calibri"/>
+              </a:rPr>
+              <a:t>WHAT IS PROVING MOST EFFECTIVE</a:t>
+            </a:r>
+          </a:p>
+        </p:txBody>
+      </p:sp>
       <p:sp>
         <p:nvSpPr>
           <p:cNvPr id="23" name="TextBox 22"/>
@@ -7946,8 +7982,8 @@
         </p:nvSpPr>
         <p:spPr>
           <a:xfrm>
-            <a:off x="548640" y="6446520"/>
-            <a:ext cx="10545775" cy="274320"/>
+            <a:off x="6400800" y="4846320"/>
+            <a:ext cx="5257800" cy="1280160"/>
           </a:xfrm>
           <a:prstGeom prst="rect">
             <a:avLst/>
@@ -7969,6 +8005,92 @@
               </a:spcAft>
             </a:pPr>
             <a:r>
+              <a:rPr sz="1500" b="1" i="0">
+                <a:solidFill>
+                  <a:srgbClr val="1F2937"/>
+                </a:solidFill>
+                <a:latin typeface="Calibri"/>
+              </a:rPr>
+              <a:t>Layers, not one fix.</a:t>
+            </a:r>
+            <a:r>
+              <a:rPr sz="1500" b="0" i="0">
+                <a:solidFill>
+                  <a:srgbClr val="1F2937"/>
+                </a:solidFill>
+                <a:latin typeface="Calibri"/>
+              </a:rPr>
+              <a:t> Microsoft stopped the Copilot flaw before exploitation; deepfake payments need a human check.</a:t>
+            </a:r>
+          </a:p>
+        </p:txBody>
+      </p:sp>
+      <p:cxnSp>
+        <p:nvCxnSpPr>
+          <p:cNvPr id="24" name="Connector 23"/>
+          <p:cNvCxnSpPr/>
+          <p:nvPr/>
+        </p:nvCxnSpPr>
+        <p:spPr>
+          <a:xfrm>
+            <a:off x="548640" y="6355080"/>
+            <a:ext cx="11094415" cy="0"/>
+          </a:xfrm>
+          <a:prstGeom prst="line">
+            <a:avLst/>
+          </a:prstGeom>
+          <a:ln w="9525">
+            <a:solidFill>
+              <a:srgbClr val="D5DAE1"/>
+            </a:solidFill>
+          </a:ln>
+        </p:spPr>
+        <p:style>
+          <a:lnRef idx="2">
+            <a:schemeClr val="accent1"/>
+          </a:lnRef>
+          <a:fillRef idx="0">
+            <a:schemeClr val="accent1"/>
+          </a:fillRef>
+          <a:effectRef idx="1">
+            <a:schemeClr val="accent1"/>
+          </a:effectRef>
+          <a:fontRef idx="minor">
+            <a:schemeClr val="tx1"/>
+          </a:fontRef>
+        </p:style>
+      </p:cxnSp>
+      <p:sp>
+        <p:nvSpPr>
+          <p:cNvPr id="25" name="TextBox 24"/>
+          <p:cNvSpPr txBox="1"/>
+          <p:nvPr/>
+        </p:nvSpPr>
+        <p:spPr>
+          <a:xfrm>
+            <a:off x="548640" y="6446520"/>
+            <a:ext cx="10545775" cy="274320"/>
+          </a:xfrm>
+          <a:prstGeom prst="rect">
+            <a:avLst/>
+          </a:prstGeom>
+          <a:noFill/>
+        </p:spPr>
+        <p:txBody>
+          <a:bodyPr wrap="square" lIns="0" rIns="0" tIns="0" bIns="0" anchor="t">
+            <a:spAutoFit/>
+          </a:bodyPr>
+          <a:lstStyle/>
+          <a:p>
+            <a:pPr algn="l">
+              <a:lnSpc>
+                <a:spcPct val="110000"/>
+              </a:lnSpc>
+              <a:spcAft>
+                <a:spcPts val="600"/>
+              </a:spcAft>
+            </a:pPr>
+            <a:r>
               <a:rPr sz="1000" b="0" i="0">
                 <a:solidFill>
                   <a:srgbClr val="5B6472"/>
@@ -7982,7 +8104,7 @@
       </p:sp>
       <p:sp>
         <p:nvSpPr>
-          <p:cNvPr id="24" name="TextBox 23"/>
+          <p:cNvPr id="26" name="TextBox 25"/>
           <p:cNvSpPr txBox="1"/>
           <p:nvPr/>
         </p:nvSpPr>
@@ -8630,212 +8752,224 @@
       </p:sp>
       <p:sp>
         <p:nvSpPr>
-          <p:cNvPr id="16" name="TextBox 15"/>
-          <p:cNvSpPr txBox="1"/>
-          <p:nvPr/>
-        </p:nvSpPr>
-        <p:spPr>
-          <a:xfrm>
-            <a:off x="4754880" y="2377440"/>
-            <a:ext cx="1371600" cy="493776"/>
-          </a:xfrm>
-          <a:prstGeom prst="rect">
+          <p:cNvPr id="16" name="Oval 15"/>
+          <p:cNvSpPr/>
+          <p:nvPr/>
+        </p:nvSpPr>
+        <p:spPr>
+          <a:xfrm>
+            <a:off x="5303520" y="2487168"/>
+            <a:ext cx="274320" cy="274320"/>
+          </a:xfrm>
+          <a:prstGeom prst="ellipse">
             <a:avLst/>
           </a:prstGeom>
           <a:noFill/>
-        </p:spPr>
-        <p:txBody>
-          <a:bodyPr wrap="square" lIns="0" rIns="0" tIns="0" bIns="0" anchor="ctr">
-            <a:spAutoFit/>
-          </a:bodyPr>
-          <a:lstStyle/>
-          <a:p>
-            <a:pPr algn="ctr">
-              <a:lnSpc>
-                <a:spcPct val="110000"/>
-              </a:lnSpc>
-              <a:spcAft>
-                <a:spcPts val="0"/>
-              </a:spcAft>
-            </a:pPr>
-            <a:r>
-              <a:rPr sz="2200" b="1" i="0">
-                <a:solidFill>
-                  <a:srgbClr val="1E846F"/>
-                </a:solidFill>
-                <a:latin typeface="Calibri"/>
-              </a:rPr>
-              <a:t>●</a:t>
-            </a:r>
-          </a:p>
-        </p:txBody>
-      </p:sp>
-      <p:sp>
-        <p:nvSpPr>
-          <p:cNvPr id="17" name="TextBox 16"/>
-          <p:cNvSpPr txBox="1"/>
-          <p:nvPr/>
-        </p:nvSpPr>
-        <p:spPr>
-          <a:xfrm>
-            <a:off x="6126480" y="2377440"/>
-            <a:ext cx="1371600" cy="493776"/>
-          </a:xfrm>
-          <a:prstGeom prst="rect">
+          <a:ln w="31750">
+            <a:solidFill>
+              <a:srgbClr val="B7791F"/>
+            </a:solidFill>
+          </a:ln>
+          <a:effectLst/>
+        </p:spPr>
+        <p:style>
+          <a:lnRef idx="1">
+            <a:schemeClr val="accent1"/>
+          </a:lnRef>
+          <a:fillRef idx="3">
+            <a:schemeClr val="accent1"/>
+          </a:fillRef>
+          <a:effectRef idx="2">
+            <a:schemeClr val="accent1"/>
+          </a:effectRef>
+          <a:fontRef idx="minor">
+            <a:schemeClr val="lt1"/>
+          </a:fontRef>
+        </p:style>
+        <p:txBody>
+          <a:bodyPr rtlCol="0" anchor="ctr"/>
+          <a:lstStyle/>
+          <a:p>
+            <a:pPr algn="ctr"/>
+          </a:p>
+        </p:txBody>
+      </p:sp>
+      <p:sp>
+        <p:nvSpPr>
+          <p:cNvPr id="17" name="Oval 16"/>
+          <p:cNvSpPr/>
+          <p:nvPr/>
+        </p:nvSpPr>
+        <p:spPr>
+          <a:xfrm>
+            <a:off x="6675120" y="2487168"/>
+            <a:ext cx="274320" cy="274320"/>
+          </a:xfrm>
+          <a:prstGeom prst="ellipse">
+            <a:avLst/>
+          </a:prstGeom>
+          <a:solidFill>
+            <a:srgbClr val="1E846F"/>
+          </a:solidFill>
+          <a:ln w="31750">
+            <a:solidFill>
+              <a:srgbClr val="1E846F"/>
+            </a:solidFill>
+          </a:ln>
+          <a:effectLst/>
+        </p:spPr>
+        <p:style>
+          <a:lnRef idx="1">
+            <a:schemeClr val="accent1"/>
+          </a:lnRef>
+          <a:fillRef idx="3">
+            <a:schemeClr val="accent1"/>
+          </a:fillRef>
+          <a:effectRef idx="2">
+            <a:schemeClr val="accent1"/>
+          </a:effectRef>
+          <a:fontRef idx="minor">
+            <a:schemeClr val="lt1"/>
+          </a:fontRef>
+        </p:style>
+        <p:txBody>
+          <a:bodyPr rtlCol="0" anchor="ctr"/>
+          <a:lstStyle/>
+          <a:p>
+            <a:pPr algn="ctr"/>
+          </a:p>
+        </p:txBody>
+      </p:sp>
+      <p:sp>
+        <p:nvSpPr>
+          <p:cNvPr id="18" name="Oval 17"/>
+          <p:cNvSpPr/>
+          <p:nvPr/>
+        </p:nvSpPr>
+        <p:spPr>
+          <a:xfrm>
+            <a:off x="8046719" y="2487168"/>
+            <a:ext cx="274320" cy="274320"/>
+          </a:xfrm>
+          <a:prstGeom prst="ellipse">
             <a:avLst/>
           </a:prstGeom>
           <a:noFill/>
-        </p:spPr>
-        <p:txBody>
-          <a:bodyPr wrap="square" lIns="0" rIns="0" tIns="0" bIns="0" anchor="ctr">
-            <a:spAutoFit/>
-          </a:bodyPr>
-          <a:lstStyle/>
-          <a:p>
-            <a:pPr algn="ctr">
-              <a:lnSpc>
-                <a:spcPct val="110000"/>
-              </a:lnSpc>
-              <a:spcAft>
-                <a:spcPts val="0"/>
-              </a:spcAft>
-            </a:pPr>
-            <a:r>
-              <a:rPr sz="2200" b="1" i="0">
-                <a:solidFill>
-                  <a:srgbClr val="1E846F"/>
-                </a:solidFill>
-                <a:latin typeface="Calibri"/>
-              </a:rPr>
-              <a:t>●</a:t>
-            </a:r>
-          </a:p>
-        </p:txBody>
-      </p:sp>
-      <p:sp>
-        <p:nvSpPr>
-          <p:cNvPr id="18" name="TextBox 17"/>
-          <p:cNvSpPr txBox="1"/>
-          <p:nvPr/>
-        </p:nvSpPr>
-        <p:spPr>
-          <a:xfrm>
-            <a:off x="7498079" y="2377440"/>
-            <a:ext cx="1371600" cy="493776"/>
-          </a:xfrm>
-          <a:prstGeom prst="rect">
-            <a:avLst/>
-          </a:prstGeom>
-          <a:noFill/>
-        </p:spPr>
-        <p:txBody>
-          <a:bodyPr wrap="square" lIns="0" rIns="0" tIns="0" bIns="0" anchor="ctr">
-            <a:spAutoFit/>
-          </a:bodyPr>
-          <a:lstStyle/>
-          <a:p>
-            <a:pPr algn="ctr">
-              <a:lnSpc>
-                <a:spcPct val="110000"/>
-              </a:lnSpc>
-              <a:spcAft>
-                <a:spcPts val="0"/>
-              </a:spcAft>
-            </a:pPr>
-            <a:r>
-              <a:rPr sz="2200" b="1" i="0">
-                <a:solidFill>
-                  <a:srgbClr val="B7791F"/>
-                </a:solidFill>
-                <a:latin typeface="Calibri"/>
-              </a:rPr>
-              <a:t>◐</a:t>
-            </a:r>
-          </a:p>
-        </p:txBody>
-      </p:sp>
-      <p:sp>
-        <p:nvSpPr>
-          <p:cNvPr id="19" name="TextBox 18"/>
-          <p:cNvSpPr txBox="1"/>
-          <p:nvPr/>
-        </p:nvSpPr>
-        <p:spPr>
-          <a:xfrm>
-            <a:off x="8869680" y="2377440"/>
-            <a:ext cx="1371600" cy="493776"/>
-          </a:xfrm>
-          <a:prstGeom prst="rect">
-            <a:avLst/>
-          </a:prstGeom>
-          <a:noFill/>
-        </p:spPr>
-        <p:txBody>
-          <a:bodyPr wrap="square" lIns="0" rIns="0" tIns="0" bIns="0" anchor="ctr">
-            <a:spAutoFit/>
-          </a:bodyPr>
-          <a:lstStyle/>
-          <a:p>
-            <a:pPr algn="ctr">
-              <a:lnSpc>
-                <a:spcPct val="110000"/>
-              </a:lnSpc>
-              <a:spcAft>
-                <a:spcPts val="0"/>
-              </a:spcAft>
-            </a:pPr>
-            <a:r>
-              <a:rPr sz="2200" b="1" i="0">
-                <a:solidFill>
-                  <a:srgbClr val="1E846F"/>
-                </a:solidFill>
-                <a:latin typeface="Calibri"/>
-              </a:rPr>
-              <a:t>●</a:t>
-            </a:r>
-          </a:p>
-        </p:txBody>
-      </p:sp>
-      <p:sp>
-        <p:nvSpPr>
-          <p:cNvPr id="20" name="TextBox 19"/>
-          <p:cNvSpPr txBox="1"/>
-          <p:nvPr/>
-        </p:nvSpPr>
-        <p:spPr>
-          <a:xfrm>
-            <a:off x="10241280" y="2377440"/>
-            <a:ext cx="1371600" cy="493776"/>
-          </a:xfrm>
-          <a:prstGeom prst="rect">
-            <a:avLst/>
-          </a:prstGeom>
-          <a:noFill/>
-        </p:spPr>
-        <p:txBody>
-          <a:bodyPr wrap="square" lIns="0" rIns="0" tIns="0" bIns="0" anchor="ctr">
-            <a:spAutoFit/>
-          </a:bodyPr>
-          <a:lstStyle/>
-          <a:p>
-            <a:pPr algn="ctr">
-              <a:lnSpc>
-                <a:spcPct val="110000"/>
-              </a:lnSpc>
-              <a:spcAft>
-                <a:spcPts val="0"/>
-              </a:spcAft>
-            </a:pPr>
-            <a:r>
-              <a:rPr sz="2200" b="1" i="0">
-                <a:solidFill>
-                  <a:srgbClr val="9AA3AF"/>
-                </a:solidFill>
-                <a:latin typeface="Calibri"/>
-              </a:rPr>
-              <a:t>—</a:t>
-            </a:r>
-          </a:p>
+          <a:ln w="31750">
+            <a:solidFill>
+              <a:srgbClr val="B7791F"/>
+            </a:solidFill>
+          </a:ln>
+          <a:effectLst/>
+        </p:spPr>
+        <p:style>
+          <a:lnRef idx="1">
+            <a:schemeClr val="accent1"/>
+          </a:lnRef>
+          <a:fillRef idx="3">
+            <a:schemeClr val="accent1"/>
+          </a:fillRef>
+          <a:effectRef idx="2">
+            <a:schemeClr val="accent1"/>
+          </a:effectRef>
+          <a:fontRef idx="minor">
+            <a:schemeClr val="lt1"/>
+          </a:fontRef>
+        </p:style>
+        <p:txBody>
+          <a:bodyPr rtlCol="0" anchor="ctr"/>
+          <a:lstStyle/>
+          <a:p>
+            <a:pPr algn="ctr"/>
+          </a:p>
+        </p:txBody>
+      </p:sp>
+      <p:sp>
+        <p:nvSpPr>
+          <p:cNvPr id="19" name="Oval 18"/>
+          <p:cNvSpPr/>
+          <p:nvPr/>
+        </p:nvSpPr>
+        <p:spPr>
+          <a:xfrm>
+            <a:off x="9418319" y="2487168"/>
+            <a:ext cx="274320" cy="274320"/>
+          </a:xfrm>
+          <a:prstGeom prst="ellipse">
+            <a:avLst/>
+          </a:prstGeom>
+          <a:solidFill>
+            <a:srgbClr val="1E846F"/>
+          </a:solidFill>
+          <a:ln w="31750">
+            <a:solidFill>
+              <a:srgbClr val="1E846F"/>
+            </a:solidFill>
+          </a:ln>
+          <a:effectLst/>
+        </p:spPr>
+        <p:style>
+          <a:lnRef idx="1">
+            <a:schemeClr val="accent1"/>
+          </a:lnRef>
+          <a:fillRef idx="3">
+            <a:schemeClr val="accent1"/>
+          </a:fillRef>
+          <a:effectRef idx="2">
+            <a:schemeClr val="accent1"/>
+          </a:effectRef>
+          <a:fontRef idx="minor">
+            <a:schemeClr val="lt1"/>
+          </a:fontRef>
+        </p:style>
+        <p:txBody>
+          <a:bodyPr rtlCol="0" anchor="ctr"/>
+          <a:lstStyle/>
+          <a:p>
+            <a:pPr algn="ctr"/>
+          </a:p>
+        </p:txBody>
+      </p:sp>
+      <p:sp>
+        <p:nvSpPr>
+          <p:cNvPr id="20" name="Rectangle 19"/>
+          <p:cNvSpPr/>
+          <p:nvPr/>
+        </p:nvSpPr>
+        <p:spPr>
+          <a:xfrm>
+            <a:off x="10789919" y="2601468"/>
+            <a:ext cx="274320" cy="45720"/>
+          </a:xfrm>
+          <a:prstGeom prst="rect">
+            <a:avLst/>
+          </a:prstGeom>
+          <a:solidFill>
+            <a:srgbClr val="9AA3AF"/>
+          </a:solidFill>
+          <a:ln>
+            <a:noFill/>
+          </a:ln>
+          <a:effectLst/>
+        </p:spPr>
+        <p:style>
+          <a:lnRef idx="1">
+            <a:schemeClr val="accent1"/>
+          </a:lnRef>
+          <a:fillRef idx="3">
+            <a:schemeClr val="accent1"/>
+          </a:fillRef>
+          <a:effectRef idx="2">
+            <a:schemeClr val="accent1"/>
+          </a:effectRef>
+          <a:fontRef idx="minor">
+            <a:schemeClr val="lt1"/>
+          </a:fontRef>
+        </p:style>
+        <p:txBody>
+          <a:bodyPr rtlCol="0" anchor="ctr"/>
+          <a:lstStyle/>
+          <a:p/>
         </p:txBody>
       </p:sp>
       <p:sp>
@@ -8917,218 +9051,230 @@
                 </a:solidFill>
                 <a:latin typeface="Calibri"/>
               </a:rPr>
-              <a:t>Healthcare, finance</a:t>
-            </a:r>
-          </a:p>
-        </p:txBody>
-      </p:sp>
-      <p:sp>
-        <p:nvSpPr>
-          <p:cNvPr id="23" name="TextBox 22"/>
-          <p:cNvSpPr txBox="1"/>
-          <p:nvPr/>
-        </p:nvSpPr>
-        <p:spPr>
-          <a:xfrm>
-            <a:off x="4754880" y="3054096"/>
-            <a:ext cx="1371600" cy="493776"/>
-          </a:xfrm>
-          <a:prstGeom prst="rect">
+              <a:t>Any model that retrains</a:t>
+            </a:r>
+          </a:p>
+        </p:txBody>
+      </p:sp>
+      <p:sp>
+        <p:nvSpPr>
+          <p:cNvPr id="23" name="Oval 22"/>
+          <p:cNvSpPr/>
+          <p:nvPr/>
+        </p:nvSpPr>
+        <p:spPr>
+          <a:xfrm>
+            <a:off x="5303520" y="3163824"/>
+            <a:ext cx="274320" cy="274320"/>
+          </a:xfrm>
+          <a:prstGeom prst="ellipse">
             <a:avLst/>
           </a:prstGeom>
           <a:noFill/>
-        </p:spPr>
-        <p:txBody>
-          <a:bodyPr wrap="square" lIns="0" rIns="0" tIns="0" bIns="0" anchor="ctr">
-            <a:spAutoFit/>
-          </a:bodyPr>
-          <a:lstStyle/>
-          <a:p>
-            <a:pPr algn="ctr">
-              <a:lnSpc>
-                <a:spcPct val="110000"/>
-              </a:lnSpc>
-              <a:spcAft>
-                <a:spcPts val="0"/>
-              </a:spcAft>
-            </a:pPr>
-            <a:r>
-              <a:rPr sz="2200" b="1" i="0">
-                <a:solidFill>
-                  <a:srgbClr val="B7791F"/>
-                </a:solidFill>
-                <a:latin typeface="Calibri"/>
-              </a:rPr>
-              <a:t>◐</a:t>
-            </a:r>
-          </a:p>
-        </p:txBody>
-      </p:sp>
-      <p:sp>
-        <p:nvSpPr>
-          <p:cNvPr id="24" name="TextBox 23"/>
-          <p:cNvSpPr txBox="1"/>
-          <p:nvPr/>
-        </p:nvSpPr>
-        <p:spPr>
-          <a:xfrm>
-            <a:off x="6126480" y="3054096"/>
-            <a:ext cx="1371600" cy="493776"/>
-          </a:xfrm>
-          <a:prstGeom prst="rect">
+          <a:ln w="31750">
+            <a:solidFill>
+              <a:srgbClr val="B7791F"/>
+            </a:solidFill>
+          </a:ln>
+          <a:effectLst/>
+        </p:spPr>
+        <p:style>
+          <a:lnRef idx="1">
+            <a:schemeClr val="accent1"/>
+          </a:lnRef>
+          <a:fillRef idx="3">
+            <a:schemeClr val="accent1"/>
+          </a:fillRef>
+          <a:effectRef idx="2">
+            <a:schemeClr val="accent1"/>
+          </a:effectRef>
+          <a:fontRef idx="minor">
+            <a:schemeClr val="lt1"/>
+          </a:fontRef>
+        </p:style>
+        <p:txBody>
+          <a:bodyPr rtlCol="0" anchor="ctr"/>
+          <a:lstStyle/>
+          <a:p>
+            <a:pPr algn="ctr"/>
+          </a:p>
+        </p:txBody>
+      </p:sp>
+      <p:sp>
+        <p:nvSpPr>
+          <p:cNvPr id="24" name="Oval 23"/>
+          <p:cNvSpPr/>
+          <p:nvPr/>
+        </p:nvSpPr>
+        <p:spPr>
+          <a:xfrm>
+            <a:off x="6675120" y="3163824"/>
+            <a:ext cx="274320" cy="274320"/>
+          </a:xfrm>
+          <a:prstGeom prst="ellipse">
+            <a:avLst/>
+          </a:prstGeom>
+          <a:solidFill>
+            <a:srgbClr val="1E846F"/>
+          </a:solidFill>
+          <a:ln w="31750">
+            <a:solidFill>
+              <a:srgbClr val="1E846F"/>
+            </a:solidFill>
+          </a:ln>
+          <a:effectLst/>
+        </p:spPr>
+        <p:style>
+          <a:lnRef idx="1">
+            <a:schemeClr val="accent1"/>
+          </a:lnRef>
+          <a:fillRef idx="3">
+            <a:schemeClr val="accent1"/>
+          </a:fillRef>
+          <a:effectRef idx="2">
+            <a:schemeClr val="accent1"/>
+          </a:effectRef>
+          <a:fontRef idx="minor">
+            <a:schemeClr val="lt1"/>
+          </a:fontRef>
+        </p:style>
+        <p:txBody>
+          <a:bodyPr rtlCol="0" anchor="ctr"/>
+          <a:lstStyle/>
+          <a:p>
+            <a:pPr algn="ctr"/>
+          </a:p>
+        </p:txBody>
+      </p:sp>
+      <p:sp>
+        <p:nvSpPr>
+          <p:cNvPr id="25" name="Rectangle 24"/>
+          <p:cNvSpPr/>
+          <p:nvPr/>
+        </p:nvSpPr>
+        <p:spPr>
+          <a:xfrm>
+            <a:off x="8046719" y="3278124"/>
+            <a:ext cx="274320" cy="45720"/>
+          </a:xfrm>
+          <a:prstGeom prst="rect">
+            <a:avLst/>
+          </a:prstGeom>
+          <a:solidFill>
+            <a:srgbClr val="9AA3AF"/>
+          </a:solidFill>
+          <a:ln>
+            <a:noFill/>
+          </a:ln>
+          <a:effectLst/>
+        </p:spPr>
+        <p:style>
+          <a:lnRef idx="1">
+            <a:schemeClr val="accent1"/>
+          </a:lnRef>
+          <a:fillRef idx="3">
+            <a:schemeClr val="accent1"/>
+          </a:fillRef>
+          <a:effectRef idx="2">
+            <a:schemeClr val="accent1"/>
+          </a:effectRef>
+          <a:fontRef idx="minor">
+            <a:schemeClr val="lt1"/>
+          </a:fontRef>
+        </p:style>
+        <p:txBody>
+          <a:bodyPr rtlCol="0" anchor="ctr"/>
+          <a:lstStyle/>
+          <a:p/>
+        </p:txBody>
+      </p:sp>
+      <p:sp>
+        <p:nvSpPr>
+          <p:cNvPr id="26" name="Oval 25"/>
+          <p:cNvSpPr/>
+          <p:nvPr/>
+        </p:nvSpPr>
+        <p:spPr>
+          <a:xfrm>
+            <a:off x="9418319" y="3163824"/>
+            <a:ext cx="274320" cy="274320"/>
+          </a:xfrm>
+          <a:prstGeom prst="ellipse">
+            <a:avLst/>
+          </a:prstGeom>
+          <a:solidFill>
+            <a:srgbClr val="1E846F"/>
+          </a:solidFill>
+          <a:ln w="31750">
+            <a:solidFill>
+              <a:srgbClr val="1E846F"/>
+            </a:solidFill>
+          </a:ln>
+          <a:effectLst/>
+        </p:spPr>
+        <p:style>
+          <a:lnRef idx="1">
+            <a:schemeClr val="accent1"/>
+          </a:lnRef>
+          <a:fillRef idx="3">
+            <a:schemeClr val="accent1"/>
+          </a:fillRef>
+          <a:effectRef idx="2">
+            <a:schemeClr val="accent1"/>
+          </a:effectRef>
+          <a:fontRef idx="minor">
+            <a:schemeClr val="lt1"/>
+          </a:fontRef>
+        </p:style>
+        <p:txBody>
+          <a:bodyPr rtlCol="0" anchor="ctr"/>
+          <a:lstStyle/>
+          <a:p>
+            <a:pPr algn="ctr"/>
+          </a:p>
+        </p:txBody>
+      </p:sp>
+      <p:sp>
+        <p:nvSpPr>
+          <p:cNvPr id="27" name="Oval 26"/>
+          <p:cNvSpPr/>
+          <p:nvPr/>
+        </p:nvSpPr>
+        <p:spPr>
+          <a:xfrm>
+            <a:off x="10789919" y="3163824"/>
+            <a:ext cx="274320" cy="274320"/>
+          </a:xfrm>
+          <a:prstGeom prst="ellipse">
             <a:avLst/>
           </a:prstGeom>
           <a:noFill/>
-        </p:spPr>
-        <p:txBody>
-          <a:bodyPr wrap="square" lIns="0" rIns="0" tIns="0" bIns="0" anchor="ctr">
-            <a:spAutoFit/>
-          </a:bodyPr>
-          <a:lstStyle/>
-          <a:p>
-            <a:pPr algn="ctr">
-              <a:lnSpc>
-                <a:spcPct val="110000"/>
-              </a:lnSpc>
-              <a:spcAft>
-                <a:spcPts val="0"/>
-              </a:spcAft>
-            </a:pPr>
-            <a:r>
-              <a:rPr sz="2200" b="1" i="0">
-                <a:solidFill>
-                  <a:srgbClr val="1E846F"/>
-                </a:solidFill>
-                <a:latin typeface="Calibri"/>
-              </a:rPr>
-              <a:t>●</a:t>
-            </a:r>
-          </a:p>
-        </p:txBody>
-      </p:sp>
-      <p:sp>
-        <p:nvSpPr>
-          <p:cNvPr id="25" name="TextBox 24"/>
-          <p:cNvSpPr txBox="1"/>
-          <p:nvPr/>
-        </p:nvSpPr>
-        <p:spPr>
-          <a:xfrm>
-            <a:off x="7498079" y="3054096"/>
-            <a:ext cx="1371600" cy="493776"/>
-          </a:xfrm>
-          <a:prstGeom prst="rect">
-            <a:avLst/>
-          </a:prstGeom>
-          <a:noFill/>
-        </p:spPr>
-        <p:txBody>
-          <a:bodyPr wrap="square" lIns="0" rIns="0" tIns="0" bIns="0" anchor="ctr">
-            <a:spAutoFit/>
-          </a:bodyPr>
-          <a:lstStyle/>
-          <a:p>
-            <a:pPr algn="ctr">
-              <a:lnSpc>
-                <a:spcPct val="110000"/>
-              </a:lnSpc>
-              <a:spcAft>
-                <a:spcPts val="0"/>
-              </a:spcAft>
-            </a:pPr>
-            <a:r>
-              <a:rPr sz="2200" b="1" i="0">
-                <a:solidFill>
-                  <a:srgbClr val="9AA3AF"/>
-                </a:solidFill>
-                <a:latin typeface="Calibri"/>
-              </a:rPr>
-              <a:t>—</a:t>
-            </a:r>
-          </a:p>
-        </p:txBody>
-      </p:sp>
-      <p:sp>
-        <p:nvSpPr>
-          <p:cNvPr id="26" name="TextBox 25"/>
-          <p:cNvSpPr txBox="1"/>
-          <p:nvPr/>
-        </p:nvSpPr>
-        <p:spPr>
-          <a:xfrm>
-            <a:off x="8869680" y="3054096"/>
-            <a:ext cx="1371600" cy="493776"/>
-          </a:xfrm>
-          <a:prstGeom prst="rect">
-            <a:avLst/>
-          </a:prstGeom>
-          <a:noFill/>
-        </p:spPr>
-        <p:txBody>
-          <a:bodyPr wrap="square" lIns="0" rIns="0" tIns="0" bIns="0" anchor="ctr">
-            <a:spAutoFit/>
-          </a:bodyPr>
-          <a:lstStyle/>
-          <a:p>
-            <a:pPr algn="ctr">
-              <a:lnSpc>
-                <a:spcPct val="110000"/>
-              </a:lnSpc>
-              <a:spcAft>
-                <a:spcPts val="0"/>
-              </a:spcAft>
-            </a:pPr>
-            <a:r>
-              <a:rPr sz="2200" b="1" i="0">
-                <a:solidFill>
-                  <a:srgbClr val="1E846F"/>
-                </a:solidFill>
-                <a:latin typeface="Calibri"/>
-              </a:rPr>
-              <a:t>●</a:t>
-            </a:r>
-          </a:p>
-        </p:txBody>
-      </p:sp>
-      <p:sp>
-        <p:nvSpPr>
-          <p:cNvPr id="27" name="TextBox 26"/>
-          <p:cNvSpPr txBox="1"/>
-          <p:nvPr/>
-        </p:nvSpPr>
-        <p:spPr>
-          <a:xfrm>
-            <a:off x="10241280" y="3054096"/>
-            <a:ext cx="1371600" cy="493776"/>
-          </a:xfrm>
-          <a:prstGeom prst="rect">
-            <a:avLst/>
-          </a:prstGeom>
-          <a:noFill/>
-        </p:spPr>
-        <p:txBody>
-          <a:bodyPr wrap="square" lIns="0" rIns="0" tIns="0" bIns="0" anchor="ctr">
-            <a:spAutoFit/>
-          </a:bodyPr>
-          <a:lstStyle/>
-          <a:p>
-            <a:pPr algn="ctr">
-              <a:lnSpc>
-                <a:spcPct val="110000"/>
-              </a:lnSpc>
-              <a:spcAft>
-                <a:spcPts val="0"/>
-              </a:spcAft>
-            </a:pPr>
-            <a:r>
-              <a:rPr sz="2200" b="1" i="0">
-                <a:solidFill>
-                  <a:srgbClr val="B7791F"/>
-                </a:solidFill>
-                <a:latin typeface="Calibri"/>
-              </a:rPr>
-              <a:t>◐</a:t>
-            </a:r>
+          <a:ln w="31750">
+            <a:solidFill>
+              <a:srgbClr val="B7791F"/>
+            </a:solidFill>
+          </a:ln>
+          <a:effectLst/>
+        </p:spPr>
+        <p:style>
+          <a:lnRef idx="1">
+            <a:schemeClr val="accent1"/>
+          </a:lnRef>
+          <a:fillRef idx="3">
+            <a:schemeClr val="accent1"/>
+          </a:fillRef>
+          <a:effectRef idx="2">
+            <a:schemeClr val="accent1"/>
+          </a:effectRef>
+          <a:fontRef idx="minor">
+            <a:schemeClr val="lt1"/>
+          </a:fontRef>
+        </p:style>
+        <p:txBody>
+          <a:bodyPr rtlCol="0" anchor="ctr"/>
+          <a:lstStyle/>
+          <a:p>
+            <a:pPr algn="ctr"/>
           </a:p>
         </p:txBody>
       </p:sp>
@@ -9260,211 +9406,229 @@
       </p:sp>
       <p:sp>
         <p:nvSpPr>
-          <p:cNvPr id="31" name="TextBox 30"/>
-          <p:cNvSpPr txBox="1"/>
-          <p:nvPr/>
-        </p:nvSpPr>
-        <p:spPr>
-          <a:xfrm>
-            <a:off x="4754880" y="3730752"/>
-            <a:ext cx="1371600" cy="493776"/>
-          </a:xfrm>
-          <a:prstGeom prst="rect">
+          <p:cNvPr id="31" name="Oval 30"/>
+          <p:cNvSpPr/>
+          <p:nvPr/>
+        </p:nvSpPr>
+        <p:spPr>
+          <a:xfrm>
+            <a:off x="5303520" y="3840479"/>
+            <a:ext cx="274320" cy="274320"/>
+          </a:xfrm>
+          <a:prstGeom prst="ellipse">
+            <a:avLst/>
+          </a:prstGeom>
+          <a:solidFill>
+            <a:srgbClr val="1E846F"/>
+          </a:solidFill>
+          <a:ln w="31750">
+            <a:solidFill>
+              <a:srgbClr val="1E846F"/>
+            </a:solidFill>
+          </a:ln>
+          <a:effectLst/>
+        </p:spPr>
+        <p:style>
+          <a:lnRef idx="1">
+            <a:schemeClr val="accent1"/>
+          </a:lnRef>
+          <a:fillRef idx="3">
+            <a:schemeClr val="accent1"/>
+          </a:fillRef>
+          <a:effectRef idx="2">
+            <a:schemeClr val="accent1"/>
+          </a:effectRef>
+          <a:fontRef idx="minor">
+            <a:schemeClr val="lt1"/>
+          </a:fontRef>
+        </p:style>
+        <p:txBody>
+          <a:bodyPr rtlCol="0" anchor="ctr"/>
+          <a:lstStyle/>
+          <a:p>
+            <a:pPr algn="ctr"/>
+          </a:p>
+        </p:txBody>
+      </p:sp>
+      <p:sp>
+        <p:nvSpPr>
+          <p:cNvPr id="32" name="Oval 31"/>
+          <p:cNvSpPr/>
+          <p:nvPr/>
+        </p:nvSpPr>
+        <p:spPr>
+          <a:xfrm>
+            <a:off x="6675120" y="3840479"/>
+            <a:ext cx="274320" cy="274320"/>
+          </a:xfrm>
+          <a:prstGeom prst="ellipse">
+            <a:avLst/>
+          </a:prstGeom>
+          <a:solidFill>
+            <a:srgbClr val="1E846F"/>
+          </a:solidFill>
+          <a:ln w="31750">
+            <a:solidFill>
+              <a:srgbClr val="1E846F"/>
+            </a:solidFill>
+          </a:ln>
+          <a:effectLst/>
+        </p:spPr>
+        <p:style>
+          <a:lnRef idx="1">
+            <a:schemeClr val="accent1"/>
+          </a:lnRef>
+          <a:fillRef idx="3">
+            <a:schemeClr val="accent1"/>
+          </a:fillRef>
+          <a:effectRef idx="2">
+            <a:schemeClr val="accent1"/>
+          </a:effectRef>
+          <a:fontRef idx="minor">
+            <a:schemeClr val="lt1"/>
+          </a:fontRef>
+        </p:style>
+        <p:txBody>
+          <a:bodyPr rtlCol="0" anchor="ctr"/>
+          <a:lstStyle/>
+          <a:p>
+            <a:pPr algn="ctr"/>
+          </a:p>
+        </p:txBody>
+      </p:sp>
+      <p:sp>
+        <p:nvSpPr>
+          <p:cNvPr id="33" name="Oval 32"/>
+          <p:cNvSpPr/>
+          <p:nvPr/>
+        </p:nvSpPr>
+        <p:spPr>
+          <a:xfrm>
+            <a:off x="8046719" y="3840479"/>
+            <a:ext cx="274320" cy="274320"/>
+          </a:xfrm>
+          <a:prstGeom prst="ellipse">
+            <a:avLst/>
+          </a:prstGeom>
+          <a:solidFill>
+            <a:srgbClr val="1E846F"/>
+          </a:solidFill>
+          <a:ln w="31750">
+            <a:solidFill>
+              <a:srgbClr val="1E846F"/>
+            </a:solidFill>
+          </a:ln>
+          <a:effectLst/>
+        </p:spPr>
+        <p:style>
+          <a:lnRef idx="1">
+            <a:schemeClr val="accent1"/>
+          </a:lnRef>
+          <a:fillRef idx="3">
+            <a:schemeClr val="accent1"/>
+          </a:fillRef>
+          <a:effectRef idx="2">
+            <a:schemeClr val="accent1"/>
+          </a:effectRef>
+          <a:fontRef idx="minor">
+            <a:schemeClr val="lt1"/>
+          </a:fontRef>
+        </p:style>
+        <p:txBody>
+          <a:bodyPr rtlCol="0" anchor="ctr"/>
+          <a:lstStyle/>
+          <a:p>
+            <a:pPr algn="ctr"/>
+          </a:p>
+        </p:txBody>
+      </p:sp>
+      <p:sp>
+        <p:nvSpPr>
+          <p:cNvPr id="34" name="Oval 33"/>
+          <p:cNvSpPr/>
+          <p:nvPr/>
+        </p:nvSpPr>
+        <p:spPr>
+          <a:xfrm>
+            <a:off x="9418319" y="3840479"/>
+            <a:ext cx="274320" cy="274320"/>
+          </a:xfrm>
+          <a:prstGeom prst="ellipse">
             <a:avLst/>
           </a:prstGeom>
           <a:noFill/>
-        </p:spPr>
-        <p:txBody>
-          <a:bodyPr wrap="square" lIns="0" rIns="0" tIns="0" bIns="0" anchor="ctr">
-            <a:spAutoFit/>
-          </a:bodyPr>
-          <a:lstStyle/>
-          <a:p>
-            <a:pPr algn="ctr">
-              <a:lnSpc>
-                <a:spcPct val="110000"/>
-              </a:lnSpc>
-              <a:spcAft>
-                <a:spcPts val="0"/>
-              </a:spcAft>
-            </a:pPr>
-            <a:r>
-              <a:rPr sz="2200" b="1" i="0">
-                <a:solidFill>
-                  <a:srgbClr val="1E846F"/>
-                </a:solidFill>
-                <a:latin typeface="Calibri"/>
-              </a:rPr>
-              <a:t>●</a:t>
-            </a:r>
-          </a:p>
-        </p:txBody>
-      </p:sp>
-      <p:sp>
-        <p:nvSpPr>
-          <p:cNvPr id="32" name="TextBox 31"/>
-          <p:cNvSpPr txBox="1"/>
-          <p:nvPr/>
-        </p:nvSpPr>
-        <p:spPr>
-          <a:xfrm>
-            <a:off x="6126480" y="3730752"/>
-            <a:ext cx="1371600" cy="493776"/>
-          </a:xfrm>
-          <a:prstGeom prst="rect">
-            <a:avLst/>
-          </a:prstGeom>
-          <a:noFill/>
-        </p:spPr>
-        <p:txBody>
-          <a:bodyPr wrap="square" lIns="0" rIns="0" tIns="0" bIns="0" anchor="ctr">
-            <a:spAutoFit/>
-          </a:bodyPr>
-          <a:lstStyle/>
-          <a:p>
-            <a:pPr algn="ctr">
-              <a:lnSpc>
-                <a:spcPct val="110000"/>
-              </a:lnSpc>
-              <a:spcAft>
-                <a:spcPts val="0"/>
-              </a:spcAft>
-            </a:pPr>
-            <a:r>
-              <a:rPr sz="2200" b="1" i="0">
-                <a:solidFill>
-                  <a:srgbClr val="1E846F"/>
-                </a:solidFill>
-                <a:latin typeface="Calibri"/>
-              </a:rPr>
-              <a:t>●</a:t>
-            </a:r>
-          </a:p>
-        </p:txBody>
-      </p:sp>
-      <p:sp>
-        <p:nvSpPr>
-          <p:cNvPr id="33" name="TextBox 32"/>
-          <p:cNvSpPr txBox="1"/>
-          <p:nvPr/>
-        </p:nvSpPr>
-        <p:spPr>
-          <a:xfrm>
-            <a:off x="7498079" y="3730752"/>
-            <a:ext cx="1371600" cy="493776"/>
-          </a:xfrm>
-          <a:prstGeom prst="rect">
-            <a:avLst/>
-          </a:prstGeom>
-          <a:noFill/>
-        </p:spPr>
-        <p:txBody>
-          <a:bodyPr wrap="square" lIns="0" rIns="0" tIns="0" bIns="0" anchor="ctr">
-            <a:spAutoFit/>
-          </a:bodyPr>
-          <a:lstStyle/>
-          <a:p>
-            <a:pPr algn="ctr">
-              <a:lnSpc>
-                <a:spcPct val="110000"/>
-              </a:lnSpc>
-              <a:spcAft>
-                <a:spcPts val="0"/>
-              </a:spcAft>
-            </a:pPr>
-            <a:r>
-              <a:rPr sz="2200" b="1" i="0">
-                <a:solidFill>
-                  <a:srgbClr val="1E846F"/>
-                </a:solidFill>
-                <a:latin typeface="Calibri"/>
-              </a:rPr>
-              <a:t>●</a:t>
-            </a:r>
-          </a:p>
-        </p:txBody>
-      </p:sp>
-      <p:sp>
-        <p:nvSpPr>
-          <p:cNvPr id="34" name="TextBox 33"/>
-          <p:cNvSpPr txBox="1"/>
-          <p:nvPr/>
-        </p:nvSpPr>
-        <p:spPr>
-          <a:xfrm>
-            <a:off x="8869680" y="3730752"/>
-            <a:ext cx="1371600" cy="493776"/>
-          </a:xfrm>
-          <a:prstGeom prst="rect">
-            <a:avLst/>
-          </a:prstGeom>
-          <a:noFill/>
-        </p:spPr>
-        <p:txBody>
-          <a:bodyPr wrap="square" lIns="0" rIns="0" tIns="0" bIns="0" anchor="ctr">
-            <a:spAutoFit/>
-          </a:bodyPr>
-          <a:lstStyle/>
-          <a:p>
-            <a:pPr algn="ctr">
-              <a:lnSpc>
-                <a:spcPct val="110000"/>
-              </a:lnSpc>
-              <a:spcAft>
-                <a:spcPts val="0"/>
-              </a:spcAft>
-            </a:pPr>
-            <a:r>
-              <a:rPr sz="2200" b="1" i="0">
-                <a:solidFill>
-                  <a:srgbClr val="B7791F"/>
-                </a:solidFill>
-                <a:latin typeface="Calibri"/>
-              </a:rPr>
-              <a:t>◐</a:t>
-            </a:r>
-          </a:p>
-        </p:txBody>
-      </p:sp>
-      <p:sp>
-        <p:nvSpPr>
-          <p:cNvPr id="35" name="TextBox 34"/>
-          <p:cNvSpPr txBox="1"/>
-          <p:nvPr/>
-        </p:nvSpPr>
-        <p:spPr>
-          <a:xfrm>
-            <a:off x="10241280" y="3730752"/>
-            <a:ext cx="1371600" cy="493776"/>
-          </a:xfrm>
-          <a:prstGeom prst="rect">
-            <a:avLst/>
-          </a:prstGeom>
-          <a:noFill/>
-        </p:spPr>
-        <p:txBody>
-          <a:bodyPr wrap="square" lIns="0" rIns="0" tIns="0" bIns="0" anchor="ctr">
-            <a:spAutoFit/>
-          </a:bodyPr>
-          <a:lstStyle/>
-          <a:p>
-            <a:pPr algn="ctr">
-              <a:lnSpc>
-                <a:spcPct val="110000"/>
-              </a:lnSpc>
-              <a:spcAft>
-                <a:spcPts val="0"/>
-              </a:spcAft>
-            </a:pPr>
-            <a:r>
-              <a:rPr sz="2200" b="1" i="0">
-                <a:solidFill>
-                  <a:srgbClr val="1E846F"/>
-                </a:solidFill>
-                <a:latin typeface="Calibri"/>
-              </a:rPr>
-              <a:t>●</a:t>
-            </a:r>
+          <a:ln w="31750">
+            <a:solidFill>
+              <a:srgbClr val="B7791F"/>
+            </a:solidFill>
+          </a:ln>
+          <a:effectLst/>
+        </p:spPr>
+        <p:style>
+          <a:lnRef idx="1">
+            <a:schemeClr val="accent1"/>
+          </a:lnRef>
+          <a:fillRef idx="3">
+            <a:schemeClr val="accent1"/>
+          </a:fillRef>
+          <a:effectRef idx="2">
+            <a:schemeClr val="accent1"/>
+          </a:effectRef>
+          <a:fontRef idx="minor">
+            <a:schemeClr val="lt1"/>
+          </a:fontRef>
+        </p:style>
+        <p:txBody>
+          <a:bodyPr rtlCol="0" anchor="ctr"/>
+          <a:lstStyle/>
+          <a:p>
+            <a:pPr algn="ctr"/>
+          </a:p>
+        </p:txBody>
+      </p:sp>
+      <p:sp>
+        <p:nvSpPr>
+          <p:cNvPr id="35" name="Oval 34"/>
+          <p:cNvSpPr/>
+          <p:nvPr/>
+        </p:nvSpPr>
+        <p:spPr>
+          <a:xfrm>
+            <a:off x="10789919" y="3840479"/>
+            <a:ext cx="274320" cy="274320"/>
+          </a:xfrm>
+          <a:prstGeom prst="ellipse">
+            <a:avLst/>
+          </a:prstGeom>
+          <a:solidFill>
+            <a:srgbClr val="1E846F"/>
+          </a:solidFill>
+          <a:ln w="31750">
+            <a:solidFill>
+              <a:srgbClr val="1E846F"/>
+            </a:solidFill>
+          </a:ln>
+          <a:effectLst/>
+        </p:spPr>
+        <p:style>
+          <a:lnRef idx="1">
+            <a:schemeClr val="accent1"/>
+          </a:lnRef>
+          <a:fillRef idx="3">
+            <a:schemeClr val="accent1"/>
+          </a:fillRef>
+          <a:effectRef idx="2">
+            <a:schemeClr val="accent1"/>
+          </a:effectRef>
+          <a:fontRef idx="minor">
+            <a:schemeClr val="lt1"/>
+          </a:fontRef>
+        </p:style>
+        <p:txBody>
+          <a:bodyPr rtlCol="0" anchor="ctr"/>
+          <a:lstStyle/>
+          <a:p>
+            <a:pPr algn="ctr"/>
           </a:p>
         </p:txBody>
       </p:sp>
@@ -9554,224 +9718,280 @@
       </p:sp>
       <p:sp>
         <p:nvSpPr>
-          <p:cNvPr id="38" name="TextBox 37"/>
+          <p:cNvPr id="38" name="Rectangle 37"/>
+          <p:cNvSpPr/>
+          <p:nvPr/>
+        </p:nvSpPr>
+        <p:spPr>
+          <a:xfrm>
+            <a:off x="5303520" y="4631436"/>
+            <a:ext cx="274320" cy="45720"/>
+          </a:xfrm>
+          <a:prstGeom prst="rect">
+            <a:avLst/>
+          </a:prstGeom>
+          <a:solidFill>
+            <a:srgbClr val="9AA3AF"/>
+          </a:solidFill>
+          <a:ln>
+            <a:noFill/>
+          </a:ln>
+          <a:effectLst/>
+        </p:spPr>
+        <p:style>
+          <a:lnRef idx="1">
+            <a:schemeClr val="accent1"/>
+          </a:lnRef>
+          <a:fillRef idx="3">
+            <a:schemeClr val="accent1"/>
+          </a:fillRef>
+          <a:effectRef idx="2">
+            <a:schemeClr val="accent1"/>
+          </a:effectRef>
+          <a:fontRef idx="minor">
+            <a:schemeClr val="lt1"/>
+          </a:fontRef>
+        </p:style>
+        <p:txBody>
+          <a:bodyPr rtlCol="0" anchor="ctr"/>
+          <a:lstStyle/>
+          <a:p/>
+        </p:txBody>
+      </p:sp>
+      <p:sp>
+        <p:nvSpPr>
+          <p:cNvPr id="39" name="Oval 38"/>
+          <p:cNvSpPr/>
+          <p:nvPr/>
+        </p:nvSpPr>
+        <p:spPr>
+          <a:xfrm>
+            <a:off x="6675120" y="4517136"/>
+            <a:ext cx="274320" cy="274320"/>
+          </a:xfrm>
+          <a:prstGeom prst="ellipse">
+            <a:avLst/>
+          </a:prstGeom>
+          <a:noFill/>
+          <a:ln w="31750">
+            <a:solidFill>
+              <a:srgbClr val="B7791F"/>
+            </a:solidFill>
+          </a:ln>
+          <a:effectLst/>
+        </p:spPr>
+        <p:style>
+          <a:lnRef idx="1">
+            <a:schemeClr val="accent1"/>
+          </a:lnRef>
+          <a:fillRef idx="3">
+            <a:schemeClr val="accent1"/>
+          </a:fillRef>
+          <a:effectRef idx="2">
+            <a:schemeClr val="accent1"/>
+          </a:effectRef>
+          <a:fontRef idx="minor">
+            <a:schemeClr val="lt1"/>
+          </a:fontRef>
+        </p:style>
+        <p:txBody>
+          <a:bodyPr rtlCol="0" anchor="ctr"/>
+          <a:lstStyle/>
+          <a:p>
+            <a:pPr algn="ctr"/>
+          </a:p>
+        </p:txBody>
+      </p:sp>
+      <p:sp>
+        <p:nvSpPr>
+          <p:cNvPr id="40" name="Oval 39"/>
+          <p:cNvSpPr/>
+          <p:nvPr/>
+        </p:nvSpPr>
+        <p:spPr>
+          <a:xfrm>
+            <a:off x="8046719" y="4517136"/>
+            <a:ext cx="274320" cy="274320"/>
+          </a:xfrm>
+          <a:prstGeom prst="ellipse">
+            <a:avLst/>
+          </a:prstGeom>
+          <a:noFill/>
+          <a:ln w="31750">
+            <a:solidFill>
+              <a:srgbClr val="B7791F"/>
+            </a:solidFill>
+          </a:ln>
+          <a:effectLst/>
+        </p:spPr>
+        <p:style>
+          <a:lnRef idx="1">
+            <a:schemeClr val="accent1"/>
+          </a:lnRef>
+          <a:fillRef idx="3">
+            <a:schemeClr val="accent1"/>
+          </a:fillRef>
+          <a:effectRef idx="2">
+            <a:schemeClr val="accent1"/>
+          </a:effectRef>
+          <a:fontRef idx="minor">
+            <a:schemeClr val="lt1"/>
+          </a:fontRef>
+        </p:style>
+        <p:txBody>
+          <a:bodyPr rtlCol="0" anchor="ctr"/>
+          <a:lstStyle/>
+          <a:p>
+            <a:pPr algn="ctr"/>
+          </a:p>
+        </p:txBody>
+      </p:sp>
+      <p:sp>
+        <p:nvSpPr>
+          <p:cNvPr id="41" name="Oval 40"/>
+          <p:cNvSpPr/>
+          <p:nvPr/>
+        </p:nvSpPr>
+        <p:spPr>
+          <a:xfrm>
+            <a:off x="9418319" y="4517136"/>
+            <a:ext cx="274320" cy="274320"/>
+          </a:xfrm>
+          <a:prstGeom prst="ellipse">
+            <a:avLst/>
+          </a:prstGeom>
+          <a:noFill/>
+          <a:ln w="31750">
+            <a:solidFill>
+              <a:srgbClr val="B7791F"/>
+            </a:solidFill>
+          </a:ln>
+          <a:effectLst/>
+        </p:spPr>
+        <p:style>
+          <a:lnRef idx="1">
+            <a:schemeClr val="accent1"/>
+          </a:lnRef>
+          <a:fillRef idx="3">
+            <a:schemeClr val="accent1"/>
+          </a:fillRef>
+          <a:effectRef idx="2">
+            <a:schemeClr val="accent1"/>
+          </a:effectRef>
+          <a:fontRef idx="minor">
+            <a:schemeClr val="lt1"/>
+          </a:fontRef>
+        </p:style>
+        <p:txBody>
+          <a:bodyPr rtlCol="0" anchor="ctr"/>
+          <a:lstStyle/>
+          <a:p>
+            <a:pPr algn="ctr"/>
+          </a:p>
+        </p:txBody>
+      </p:sp>
+      <p:sp>
+        <p:nvSpPr>
+          <p:cNvPr id="42" name="Oval 41"/>
+          <p:cNvSpPr/>
+          <p:nvPr/>
+        </p:nvSpPr>
+        <p:spPr>
+          <a:xfrm>
+            <a:off x="10789919" y="4517136"/>
+            <a:ext cx="274320" cy="274320"/>
+          </a:xfrm>
+          <a:prstGeom prst="ellipse">
+            <a:avLst/>
+          </a:prstGeom>
+          <a:solidFill>
+            <a:srgbClr val="1E846F"/>
+          </a:solidFill>
+          <a:ln w="31750">
+            <a:solidFill>
+              <a:srgbClr val="1E846F"/>
+            </a:solidFill>
+          </a:ln>
+          <a:effectLst/>
+        </p:spPr>
+        <p:style>
+          <a:lnRef idx="1">
+            <a:schemeClr val="accent1"/>
+          </a:lnRef>
+          <a:fillRef idx="3">
+            <a:schemeClr val="accent1"/>
+          </a:fillRef>
+          <a:effectRef idx="2">
+            <a:schemeClr val="accent1"/>
+          </a:effectRef>
+          <a:fontRef idx="minor">
+            <a:schemeClr val="lt1"/>
+          </a:fontRef>
+        </p:style>
+        <p:txBody>
+          <a:bodyPr rtlCol="0" anchor="ctr"/>
+          <a:lstStyle/>
+          <a:p>
+            <a:pPr algn="ctr"/>
+          </a:p>
+        </p:txBody>
+      </p:sp>
+      <p:sp>
+        <p:nvSpPr>
+          <p:cNvPr id="43" name="Oval 42"/>
+          <p:cNvSpPr/>
+          <p:nvPr/>
+        </p:nvSpPr>
+        <p:spPr>
+          <a:xfrm>
+            <a:off x="594360" y="5221224"/>
+            <a:ext cx="182880" cy="182880"/>
+          </a:xfrm>
+          <a:prstGeom prst="ellipse">
+            <a:avLst/>
+          </a:prstGeom>
+          <a:solidFill>
+            <a:srgbClr val="1E846F"/>
+          </a:solidFill>
+          <a:ln w="31750">
+            <a:solidFill>
+              <a:srgbClr val="1E846F"/>
+            </a:solidFill>
+          </a:ln>
+          <a:effectLst/>
+        </p:spPr>
+        <p:style>
+          <a:lnRef idx="1">
+            <a:schemeClr val="accent1"/>
+          </a:lnRef>
+          <a:fillRef idx="3">
+            <a:schemeClr val="accent1"/>
+          </a:fillRef>
+          <a:effectRef idx="2">
+            <a:schemeClr val="accent1"/>
+          </a:effectRef>
+          <a:fontRef idx="minor">
+            <a:schemeClr val="lt1"/>
+          </a:fontRef>
+        </p:style>
+        <p:txBody>
+          <a:bodyPr rtlCol="0" anchor="ctr"/>
+          <a:lstStyle/>
+          <a:p>
+            <a:pPr algn="ctr"/>
+          </a:p>
+        </p:txBody>
+      </p:sp>
+      <p:sp>
+        <p:nvSpPr>
+          <p:cNvPr id="44" name="TextBox 43"/>
           <p:cNvSpPr txBox="1"/>
           <p:nvPr/>
         </p:nvSpPr>
         <p:spPr>
           <a:xfrm>
-            <a:off x="4754880" y="4407407"/>
-            <a:ext cx="1371600" cy="493776"/>
-          </a:xfrm>
-          <a:prstGeom prst="rect">
-            <a:avLst/>
-          </a:prstGeom>
-          <a:noFill/>
-        </p:spPr>
-        <p:txBody>
-          <a:bodyPr wrap="square" lIns="0" rIns="0" tIns="0" bIns="0" anchor="ctr">
-            <a:spAutoFit/>
-          </a:bodyPr>
-          <a:lstStyle/>
-          <a:p>
-            <a:pPr algn="ctr">
-              <a:lnSpc>
-                <a:spcPct val="110000"/>
-              </a:lnSpc>
-              <a:spcAft>
-                <a:spcPts val="0"/>
-              </a:spcAft>
-            </a:pPr>
-            <a:r>
-              <a:rPr sz="2200" b="1" i="0">
-                <a:solidFill>
-                  <a:srgbClr val="9AA3AF"/>
-                </a:solidFill>
-                <a:latin typeface="Calibri"/>
-              </a:rPr>
-              <a:t>—</a:t>
-            </a:r>
-          </a:p>
-        </p:txBody>
-      </p:sp>
-      <p:sp>
-        <p:nvSpPr>
-          <p:cNvPr id="39" name="TextBox 38"/>
-          <p:cNvSpPr txBox="1"/>
-          <p:nvPr/>
-        </p:nvSpPr>
-        <p:spPr>
-          <a:xfrm>
-            <a:off x="6126480" y="4407407"/>
-            <a:ext cx="1371600" cy="493776"/>
-          </a:xfrm>
-          <a:prstGeom prst="rect">
-            <a:avLst/>
-          </a:prstGeom>
-          <a:noFill/>
-        </p:spPr>
-        <p:txBody>
-          <a:bodyPr wrap="square" lIns="0" rIns="0" tIns="0" bIns="0" anchor="ctr">
-            <a:spAutoFit/>
-          </a:bodyPr>
-          <a:lstStyle/>
-          <a:p>
-            <a:pPr algn="ctr">
-              <a:lnSpc>
-                <a:spcPct val="110000"/>
-              </a:lnSpc>
-              <a:spcAft>
-                <a:spcPts val="0"/>
-              </a:spcAft>
-            </a:pPr>
-            <a:r>
-              <a:rPr sz="2200" b="1" i="0">
-                <a:solidFill>
-                  <a:srgbClr val="B7791F"/>
-                </a:solidFill>
-                <a:latin typeface="Calibri"/>
-              </a:rPr>
-              <a:t>◐</a:t>
-            </a:r>
-          </a:p>
-        </p:txBody>
-      </p:sp>
-      <p:sp>
-        <p:nvSpPr>
-          <p:cNvPr id="40" name="TextBox 39"/>
-          <p:cNvSpPr txBox="1"/>
-          <p:nvPr/>
-        </p:nvSpPr>
-        <p:spPr>
-          <a:xfrm>
-            <a:off x="7498079" y="4407407"/>
-            <a:ext cx="1371600" cy="493776"/>
-          </a:xfrm>
-          <a:prstGeom prst="rect">
-            <a:avLst/>
-          </a:prstGeom>
-          <a:noFill/>
-        </p:spPr>
-        <p:txBody>
-          <a:bodyPr wrap="square" lIns="0" rIns="0" tIns="0" bIns="0" anchor="ctr">
-            <a:spAutoFit/>
-          </a:bodyPr>
-          <a:lstStyle/>
-          <a:p>
-            <a:pPr algn="ctr">
-              <a:lnSpc>
-                <a:spcPct val="110000"/>
-              </a:lnSpc>
-              <a:spcAft>
-                <a:spcPts val="0"/>
-              </a:spcAft>
-            </a:pPr>
-            <a:r>
-              <a:rPr sz="2200" b="1" i="0">
-                <a:solidFill>
-                  <a:srgbClr val="B7791F"/>
-                </a:solidFill>
-                <a:latin typeface="Calibri"/>
-              </a:rPr>
-              <a:t>◐</a:t>
-            </a:r>
-          </a:p>
-        </p:txBody>
-      </p:sp>
-      <p:sp>
-        <p:nvSpPr>
-          <p:cNvPr id="41" name="TextBox 40"/>
-          <p:cNvSpPr txBox="1"/>
-          <p:nvPr/>
-        </p:nvSpPr>
-        <p:spPr>
-          <a:xfrm>
-            <a:off x="8869680" y="4407407"/>
-            <a:ext cx="1371600" cy="493776"/>
-          </a:xfrm>
-          <a:prstGeom prst="rect">
-            <a:avLst/>
-          </a:prstGeom>
-          <a:noFill/>
-        </p:spPr>
-        <p:txBody>
-          <a:bodyPr wrap="square" lIns="0" rIns="0" tIns="0" bIns="0" anchor="ctr">
-            <a:spAutoFit/>
-          </a:bodyPr>
-          <a:lstStyle/>
-          <a:p>
-            <a:pPr algn="ctr">
-              <a:lnSpc>
-                <a:spcPct val="110000"/>
-              </a:lnSpc>
-              <a:spcAft>
-                <a:spcPts val="0"/>
-              </a:spcAft>
-            </a:pPr>
-            <a:r>
-              <a:rPr sz="2200" b="1" i="0">
-                <a:solidFill>
-                  <a:srgbClr val="1E846F"/>
-                </a:solidFill>
-                <a:latin typeface="Calibri"/>
-              </a:rPr>
-              <a:t>●</a:t>
-            </a:r>
-          </a:p>
-        </p:txBody>
-      </p:sp>
-      <p:sp>
-        <p:nvSpPr>
-          <p:cNvPr id="42" name="TextBox 41"/>
-          <p:cNvSpPr txBox="1"/>
-          <p:nvPr/>
-        </p:nvSpPr>
-        <p:spPr>
-          <a:xfrm>
-            <a:off x="10241280" y="4407407"/>
-            <a:ext cx="1371600" cy="493776"/>
-          </a:xfrm>
-          <a:prstGeom prst="rect">
-            <a:avLst/>
-          </a:prstGeom>
-          <a:noFill/>
-        </p:spPr>
-        <p:txBody>
-          <a:bodyPr wrap="square" lIns="0" rIns="0" tIns="0" bIns="0" anchor="ctr">
-            <a:spAutoFit/>
-          </a:bodyPr>
-          <a:lstStyle/>
-          <a:p>
-            <a:pPr algn="ctr">
-              <a:lnSpc>
-                <a:spcPct val="110000"/>
-              </a:lnSpc>
-              <a:spcAft>
-                <a:spcPts val="0"/>
-              </a:spcAft>
-            </a:pPr>
-            <a:r>
-              <a:rPr sz="2200" b="1" i="0">
-                <a:solidFill>
-                  <a:srgbClr val="1E846F"/>
-                </a:solidFill>
-                <a:latin typeface="Calibri"/>
-              </a:rPr>
-              <a:t>●</a:t>
-            </a:r>
-          </a:p>
-        </p:txBody>
-      </p:sp>
-      <p:sp>
-        <p:nvSpPr>
-          <p:cNvPr id="43" name="TextBox 42"/>
-          <p:cNvSpPr txBox="1"/>
-          <p:nvPr/>
-        </p:nvSpPr>
-        <p:spPr>
-          <a:xfrm>
-            <a:off x="548640" y="5129784"/>
-            <a:ext cx="11064240" cy="365760"/>
+            <a:off x="868680" y="5175504"/>
+            <a:ext cx="1280160" cy="274320"/>
           </a:xfrm>
           <a:prstGeom prst="rect">
             <a:avLst/>
@@ -9793,72 +10013,71 @@
               </a:spcAft>
             </a:pPr>
             <a:r>
-              <a:rPr sz="1200" b="1" i="0">
+              <a:rPr sz="1200" b="0" i="0">
                 <a:solidFill>
                   <a:srgbClr val="5B6472"/>
                 </a:solidFill>
                 <a:latin typeface="Calibri"/>
               </a:rPr>
-              <a:t>●</a:t>
-            </a:r>
-            <a:r>
-              <a:rPr sz="1200" b="0" i="0">
-                <a:solidFill>
-                  <a:srgbClr val="5B6472"/>
-                </a:solidFill>
-                <a:latin typeface="Calibri"/>
-              </a:rPr>
-              <a:t> strong fit   </a:t>
-            </a:r>
-            <a:r>
-              <a:rPr sz="1200" b="1" i="0">
-                <a:solidFill>
-                  <a:srgbClr val="5B6472"/>
-                </a:solidFill>
-                <a:latin typeface="Calibri"/>
-              </a:rPr>
-              <a:t>◐</a:t>
-            </a:r>
-            <a:r>
-              <a:rPr sz="1200" b="0" i="0">
-                <a:solidFill>
-                  <a:srgbClr val="5B6472"/>
-                </a:solidFill>
-                <a:latin typeface="Calibri"/>
-              </a:rPr>
-              <a:t> partial fit   </a:t>
-            </a:r>
-            <a:r>
-              <a:rPr sz="1200" b="1" i="0">
-                <a:solidFill>
-                  <a:srgbClr val="5B6472"/>
-                </a:solidFill>
-                <a:latin typeface="Calibri"/>
-              </a:rPr>
-              <a:t>—</a:t>
-            </a:r>
-            <a:r>
-              <a:rPr sz="1200" b="0" i="0">
-                <a:solidFill>
-                  <a:srgbClr val="5B6472"/>
-                </a:solidFill>
-                <a:latin typeface="Calibri"/>
-              </a:rPr>
-              <a:t> little effect     Author's assessment from the cases and company defenses on slides 3–4.</a:t>
-            </a:r>
-          </a:p>
-        </p:txBody>
-      </p:sp>
-      <p:sp>
-        <p:nvSpPr>
-          <p:cNvPr id="44" name="TextBox 43"/>
+              <a:t>strong fit</a:t>
+            </a:r>
+          </a:p>
+        </p:txBody>
+      </p:sp>
+      <p:sp>
+        <p:nvSpPr>
+          <p:cNvPr id="45" name="Oval 44"/>
+          <p:cNvSpPr/>
+          <p:nvPr/>
+        </p:nvSpPr>
+        <p:spPr>
+          <a:xfrm>
+            <a:off x="2194560" y="5221224"/>
+            <a:ext cx="182880" cy="182880"/>
+          </a:xfrm>
+          <a:prstGeom prst="ellipse">
+            <a:avLst/>
+          </a:prstGeom>
+          <a:noFill/>
+          <a:ln w="31750">
+            <a:solidFill>
+              <a:srgbClr val="B7791F"/>
+            </a:solidFill>
+          </a:ln>
+          <a:effectLst/>
+        </p:spPr>
+        <p:style>
+          <a:lnRef idx="1">
+            <a:schemeClr val="accent1"/>
+          </a:lnRef>
+          <a:fillRef idx="3">
+            <a:schemeClr val="accent1"/>
+          </a:fillRef>
+          <a:effectRef idx="2">
+            <a:schemeClr val="accent1"/>
+          </a:effectRef>
+          <a:fontRef idx="minor">
+            <a:schemeClr val="lt1"/>
+          </a:fontRef>
+        </p:style>
+        <p:txBody>
+          <a:bodyPr rtlCol="0" anchor="ctr"/>
+          <a:lstStyle/>
+          <a:p>
+            <a:pPr algn="ctr"/>
+          </a:p>
+        </p:txBody>
+      </p:sp>
+      <p:sp>
+        <p:nvSpPr>
+          <p:cNvPr id="46" name="TextBox 45"/>
           <p:cNvSpPr txBox="1"/>
           <p:nvPr/>
         </p:nvSpPr>
         <p:spPr>
           <a:xfrm>
-            <a:off x="548640" y="5541264"/>
-            <a:ext cx="11064240" cy="548640"/>
+            <a:off x="2468880" y="5175504"/>
+            <a:ext cx="1280160" cy="274320"/>
           </a:xfrm>
           <a:prstGeom prst="rect">
             <a:avLst/>
@@ -9880,71 +10099,69 @@
               </a:spcAft>
             </a:pPr>
             <a:r>
-              <a:rPr sz="1400" b="1" i="0">
-                <a:solidFill>
-                  <a:srgbClr val="1F2937"/>
-                </a:solidFill>
-                <a:latin typeface="Calibri"/>
-              </a:rPr>
-              <a:t>Takeaway:</a:t>
-            </a:r>
-            <a:r>
-              <a:rPr sz="1400" b="0" i="0">
-                <a:solidFill>
-                  <a:srgbClr val="1F2937"/>
-                </a:solidFill>
-                <a:latin typeface="Calibri"/>
-              </a:rPr>
-              <a:t> only red teaming and anomaly detection help against every attack type; deepfakes are stopped by process (call-back checks), not by retraining.</a:t>
-            </a:r>
-          </a:p>
-        </p:txBody>
-      </p:sp>
-      <p:cxnSp>
-        <p:nvCxnSpPr>
-          <p:cNvPr id="45" name="Connector 44"/>
-          <p:cNvCxnSpPr/>
-          <p:nvPr/>
-        </p:nvCxnSpPr>
-        <p:spPr>
-          <a:xfrm>
-            <a:off x="548640" y="6355080"/>
-            <a:ext cx="11094415" cy="0"/>
-          </a:xfrm>
-          <a:prstGeom prst="line">
-            <a:avLst/>
-          </a:prstGeom>
-          <a:ln w="9525">
-            <a:solidFill>
-              <a:srgbClr val="D5DAE1"/>
-            </a:solidFill>
+              <a:rPr sz="1200" b="0" i="0">
+                <a:solidFill>
+                  <a:srgbClr val="5B6472"/>
+                </a:solidFill>
+                <a:latin typeface="Calibri"/>
+              </a:rPr>
+              <a:t>partial fit</a:t>
+            </a:r>
+          </a:p>
+        </p:txBody>
+      </p:sp>
+      <p:sp>
+        <p:nvSpPr>
+          <p:cNvPr id="47" name="Rectangle 46"/>
+          <p:cNvSpPr/>
+          <p:nvPr/>
+        </p:nvSpPr>
+        <p:spPr>
+          <a:xfrm>
+            <a:off x="3749039" y="5289804"/>
+            <a:ext cx="274320" cy="45720"/>
+          </a:xfrm>
+          <a:prstGeom prst="rect">
+            <a:avLst/>
+          </a:prstGeom>
+          <a:solidFill>
+            <a:srgbClr val="9AA3AF"/>
+          </a:solidFill>
+          <a:ln>
+            <a:noFill/>
           </a:ln>
+          <a:effectLst/>
         </p:spPr>
         <p:style>
-          <a:lnRef idx="2">
+          <a:lnRef idx="1">
             <a:schemeClr val="accent1"/>
           </a:lnRef>
-          <a:fillRef idx="0">
+          <a:fillRef idx="3">
             <a:schemeClr val="accent1"/>
           </a:fillRef>
-          <a:effectRef idx="1">
+          <a:effectRef idx="2">
             <a:schemeClr val="accent1"/>
           </a:effectRef>
           <a:fontRef idx="minor">
-            <a:schemeClr val="tx1"/>
+            <a:schemeClr val="lt1"/>
           </a:fontRef>
         </p:style>
-      </p:cxnSp>
-      <p:sp>
-        <p:nvSpPr>
-          <p:cNvPr id="46" name="TextBox 45"/>
+        <p:txBody>
+          <a:bodyPr rtlCol="0" anchor="ctr"/>
+          <a:lstStyle/>
+          <a:p/>
+        </p:txBody>
+      </p:sp>
+      <p:sp>
+        <p:nvSpPr>
+          <p:cNvPr id="48" name="TextBox 47"/>
           <p:cNvSpPr txBox="1"/>
           <p:nvPr/>
         </p:nvSpPr>
         <p:spPr>
           <a:xfrm>
-            <a:off x="548640" y="6446520"/>
-            <a:ext cx="10545775" cy="274320"/>
+            <a:off x="4069080" y="5175504"/>
+            <a:ext cx="1280160" cy="274320"/>
           </a:xfrm>
           <a:prstGeom prst="rect">
             <a:avLst/>
@@ -9966,6 +10183,176 @@
               </a:spcAft>
             </a:pPr>
             <a:r>
+              <a:rPr sz="1200" b="0" i="0">
+                <a:solidFill>
+                  <a:srgbClr val="5B6472"/>
+                </a:solidFill>
+                <a:latin typeface="Calibri"/>
+              </a:rPr>
+              <a:t>little effect</a:t>
+            </a:r>
+          </a:p>
+        </p:txBody>
+      </p:sp>
+      <p:sp>
+        <p:nvSpPr>
+          <p:cNvPr id="49" name="TextBox 48"/>
+          <p:cNvSpPr txBox="1"/>
+          <p:nvPr/>
+        </p:nvSpPr>
+        <p:spPr>
+          <a:xfrm>
+            <a:off x="5486400" y="5175504"/>
+            <a:ext cx="6126480" cy="274320"/>
+          </a:xfrm>
+          <a:prstGeom prst="rect">
+            <a:avLst/>
+          </a:prstGeom>
+          <a:noFill/>
+        </p:spPr>
+        <p:txBody>
+          <a:bodyPr wrap="square" lIns="0" rIns="0" tIns="0" bIns="0" anchor="t">
+            <a:spAutoFit/>
+          </a:bodyPr>
+          <a:lstStyle/>
+          <a:p>
+            <a:pPr algn="l">
+              <a:lnSpc>
+                <a:spcPct val="110000"/>
+              </a:lnSpc>
+              <a:spcAft>
+                <a:spcPts val="600"/>
+              </a:spcAft>
+            </a:pPr>
+            <a:r>
+              <a:rPr sz="1200" b="0" i="1">
+                <a:solidFill>
+                  <a:srgbClr val="5B6472"/>
+                </a:solidFill>
+                <a:latin typeface="Calibri"/>
+              </a:rPr>
+              <a:t>Author's assessment from the cases and defenses on slides 3–4.</a:t>
+            </a:r>
+          </a:p>
+        </p:txBody>
+      </p:sp>
+      <p:sp>
+        <p:nvSpPr>
+          <p:cNvPr id="50" name="TextBox 49"/>
+          <p:cNvSpPr txBox="1"/>
+          <p:nvPr/>
+        </p:nvSpPr>
+        <p:spPr>
+          <a:xfrm>
+            <a:off x="548640" y="5632704"/>
+            <a:ext cx="11064240" cy="548640"/>
+          </a:xfrm>
+          <a:prstGeom prst="rect">
+            <a:avLst/>
+          </a:prstGeom>
+          <a:noFill/>
+        </p:spPr>
+        <p:txBody>
+          <a:bodyPr wrap="square" lIns="0" rIns="0" tIns="0" bIns="0" anchor="t">
+            <a:spAutoFit/>
+          </a:bodyPr>
+          <a:lstStyle/>
+          <a:p>
+            <a:pPr algn="l">
+              <a:lnSpc>
+                <a:spcPct val="110000"/>
+              </a:lnSpc>
+              <a:spcAft>
+                <a:spcPts val="600"/>
+              </a:spcAft>
+            </a:pPr>
+            <a:r>
+              <a:rPr sz="1400" b="1" i="0">
+                <a:solidFill>
+                  <a:srgbClr val="1F2937"/>
+                </a:solidFill>
+                <a:latin typeface="Calibri"/>
+              </a:rPr>
+              <a:t>Takeaway:</a:t>
+            </a:r>
+            <a:r>
+              <a:rPr sz="1400" b="0" i="0">
+                <a:solidFill>
+                  <a:srgbClr val="1F2937"/>
+                </a:solidFill>
+                <a:latin typeface="Calibri"/>
+              </a:rPr>
+              <a:t> in this assessment, red teaming and anomaly detection help against every attack type; deepfakes need process checks.</a:t>
+            </a:r>
+          </a:p>
+        </p:txBody>
+      </p:sp>
+      <p:cxnSp>
+        <p:nvCxnSpPr>
+          <p:cNvPr id="51" name="Connector 50"/>
+          <p:cNvCxnSpPr/>
+          <p:nvPr/>
+        </p:nvCxnSpPr>
+        <p:spPr>
+          <a:xfrm>
+            <a:off x="548640" y="6355080"/>
+            <a:ext cx="11094415" cy="0"/>
+          </a:xfrm>
+          <a:prstGeom prst="line">
+            <a:avLst/>
+          </a:prstGeom>
+          <a:ln w="9525">
+            <a:solidFill>
+              <a:srgbClr val="D5DAE1"/>
+            </a:solidFill>
+          </a:ln>
+        </p:spPr>
+        <p:style>
+          <a:lnRef idx="2">
+            <a:schemeClr val="accent1"/>
+          </a:lnRef>
+          <a:fillRef idx="0">
+            <a:schemeClr val="accent1"/>
+          </a:fillRef>
+          <a:effectRef idx="1">
+            <a:schemeClr val="accent1"/>
+          </a:effectRef>
+          <a:fontRef idx="minor">
+            <a:schemeClr val="tx1"/>
+          </a:fontRef>
+        </p:style>
+      </p:cxnSp>
+      <p:sp>
+        <p:nvSpPr>
+          <p:cNvPr id="52" name="TextBox 51"/>
+          <p:cNvSpPr txBox="1"/>
+          <p:nvPr/>
+        </p:nvSpPr>
+        <p:spPr>
+          <a:xfrm>
+            <a:off x="548640" y="6446520"/>
+            <a:ext cx="10545775" cy="274320"/>
+          </a:xfrm>
+          <a:prstGeom prst="rect">
+            <a:avLst/>
+          </a:prstGeom>
+          <a:noFill/>
+        </p:spPr>
+        <p:txBody>
+          <a:bodyPr wrap="square" lIns="0" rIns="0" tIns="0" bIns="0" anchor="t">
+            <a:spAutoFit/>
+          </a:bodyPr>
+          <a:lstStyle/>
+          <a:p>
+            <a:pPr algn="l">
+              <a:lnSpc>
+                <a:spcPct val="110000"/>
+              </a:lnSpc>
+              <a:spcAft>
+                <a:spcPts val="600"/>
+              </a:spcAft>
+            </a:pPr>
+            <a:r>
               <a:rPr sz="1000" b="0" i="0">
                 <a:solidFill>
                   <a:srgbClr val="5B6472"/>
@@ -9979,7 +10366,7 @@
       </p:sp>
       <p:sp>
         <p:nvSpPr>
-          <p:cNvPr id="47" name="TextBox 46"/>
+          <p:cNvPr id="53" name="TextBox 52"/>
           <p:cNvSpPr txBox="1"/>
           <p:nvPr/>
         </p:nvSpPr>
@@ -10242,7 +10629,7 @@
                 </a:solidFill>
                 <a:latin typeface="Calibri"/>
               </a:rPr>
-              <a:t>Model what </a:t>
+              <a:t>Learn what </a:t>
             </a:r>
             <a:r>
               <a:rPr sz="1500" b="0" i="1">
@@ -10260,7 +10647,7 @@
                 </a:solidFill>
                 <a:latin typeface="Calibri"/>
               </a:rPr>
-              <a:t> looks like, then flag what does not fit.</a:t>
+              <a:t> looks like; flag what does not fit.</a:t>
             </a:r>
           </a:p>
         </p:txBody>
@@ -10292,7 +10679,7 @@
                 <a:spcPct val="110000"/>
               </a:lnSpc>
               <a:spcAft>
-                <a:spcPts val="900"/>
+                <a:spcPts val="1000"/>
               </a:spcAft>
               <a:buClr>
                 <a:srgbClr val="1E846F"/>
@@ -10301,7 +10688,7 @@
               <a:buChar char="■"/>
             </a:pPr>
             <a:r>
-              <a:rPr sz="1450" b="1" i="0">
+              <a:rPr sz="1500" b="1" i="0">
                 <a:solidFill>
                   <a:srgbClr val="1F2937"/>
                 </a:solidFill>
@@ -10310,13 +10697,13 @@
               <a:t>Inputs:</a:t>
             </a:r>
             <a:r>
-              <a:rPr sz="1450" b="0" i="0">
+              <a:rPr sz="1500" b="0" i="0">
                 <a:solidFill>
                   <a:srgbClr val="1F2937"/>
                 </a:solidFill>
                 <a:latin typeface="Calibri"/>
               </a:rPr>
-              <a:t> a camera reading of 85 mph on a 35 mph road is out of distribution → slow down, ask the driver.</a:t>
+              <a:t> 85 mph on a 35 mph road is out of range → slow down.</a:t>
             </a:r>
           </a:p>
           <a:p>
@@ -10325,7 +10712,7 @@
                 <a:spcPct val="110000"/>
               </a:lnSpc>
               <a:spcAft>
-                <a:spcPts val="900"/>
+                <a:spcPts val="1000"/>
               </a:spcAft>
               <a:buClr>
                 <a:srgbClr val="1E846F"/>
@@ -10334,7 +10721,7 @@
               <a:buChar char="■"/>
             </a:pPr>
             <a:r>
-              <a:rPr sz="1450" b="1" i="0">
+              <a:rPr sz="1500" b="1" i="0">
                 <a:solidFill>
                   <a:srgbClr val="1F2937"/>
                 </a:solidFill>
@@ -10343,13 +10730,13 @@
               <a:t>Payments:</a:t>
             </a:r>
             <a:r>
-              <a:rPr sz="1450" b="0" i="0">
+              <a:rPr sz="1500" b="0" i="0">
                 <a:solidFill>
                   <a:srgbClr val="1F2937"/>
                 </a:solidFill>
                 <a:latin typeface="Calibri"/>
               </a:rPr>
-              <a:t> a large, urgent transfer right after one video call is unusual → hold and call back.</a:t>
+              <a:t> a large, urgent transfer after one video call → hold and call back.</a:t>
             </a:r>
           </a:p>
           <a:p>
@@ -10358,7 +10745,7 @@
                 <a:spcPct val="110000"/>
               </a:lnSpc>
               <a:spcAft>
-                <a:spcPts val="900"/>
+                <a:spcPts val="1000"/>
               </a:spcAft>
               <a:buClr>
                 <a:srgbClr val="1E846F"/>
@@ -10367,7 +10754,7 @@
               <a:buChar char="■"/>
             </a:pPr>
             <a:r>
-              <a:rPr sz="1450" b="1" i="0">
+              <a:rPr sz="1500" b="1" i="0">
                 <a:solidFill>
                   <a:srgbClr val="1F2937"/>
                 </a:solidFill>
@@ -10376,13 +10763,13 @@
               <a:t>Training data:</a:t>
             </a:r>
             <a:r>
-              <a:rPr sz="1450" b="0" i="0">
+              <a:rPr sz="1500" b="0" i="0">
                 <a:solidFill>
                   <a:srgbClr val="1F2937"/>
                 </a:solidFill>
                 <a:latin typeface="Calibri"/>
               </a:rPr>
-              <a:t> outliers in new data are screened before retraining → stops poisoning.</a:t>
+              <a:t> screen outliers before retraining → blocks poisoning.</a:t>
             </a:r>
           </a:p>
           <a:p>
@@ -10391,7 +10778,7 @@
                 <a:spcPct val="110000"/>
               </a:lnSpc>
               <a:spcAft>
-                <a:spcPts val="900"/>
+                <a:spcPts val="1000"/>
               </a:spcAft>
               <a:buClr>
                 <a:srgbClr val="1E846F"/>
@@ -10400,22 +10787,22 @@
               <a:buChar char="■"/>
             </a:pPr>
             <a:r>
-              <a:rPr sz="1450" b="1" i="0">
+              <a:rPr sz="1500" b="1" i="0">
                 <a:solidFill>
                   <a:srgbClr val="1F2937"/>
                 </a:solidFill>
                 <a:latin typeface="Calibri"/>
               </a:rPr>
-              <a:t>AI usage:</a:t>
-            </a:r>
-            <a:r>
-              <a:rPr sz="1450" b="0" i="0">
+              <a:t>AI agents:</a:t>
+            </a:r>
+            <a:r>
+              <a:rPr sz="1500" b="0" i="0">
                 <a:solidFill>
                   <a:srgbClr val="1F2937"/>
                 </a:solidFill>
                 <a:latin typeface="Calibri"/>
               </a:rPr>
-              <a:t> an assistant suddenly sending data to an outside link → block it.</a:t>
+              <a:t> an assistant suddenly sending data outside → block it.</a:t>
             </a:r>
           </a:p>
         </p:txBody>
@@ -10429,7 +10816,7 @@
         <p:spPr>
           <a:xfrm>
             <a:off x="6400800" y="1645920"/>
-            <a:ext cx="5257800" cy="4434840"/>
+            <a:ext cx="5257800" cy="3291840"/>
           </a:xfrm>
           <a:prstGeom prst="roundRect">
             <a:avLst>
@@ -10515,7 +10902,7 @@
         <p:spPr>
           <a:xfrm>
             <a:off x="6675120" y="2194560"/>
-            <a:ext cx="4754880" cy="3840480"/>
+            <a:ext cx="4754880" cy="3657600"/>
           </a:xfrm>
           <a:prstGeom prst="rect">
             <a:avLst/>
@@ -10533,35 +10920,26 @@
                 <a:spcPct val="110000"/>
               </a:lnSpc>
               <a:spcAft>
-                <a:spcPts val="1000"/>
+                <a:spcPts val="1200"/>
               </a:spcAft>
             </a:pPr>
             <a:r>
-              <a:rPr sz="1450" b="0" i="0">
+              <a:rPr sz="1500" b="1" i="0">
                 <a:solidFill>
                   <a:srgbClr val="1F2937"/>
                 </a:solidFill>
                 <a:latin typeface="Calibri"/>
               </a:rPr>
-              <a:t>The </a:t>
-            </a:r>
-            <a:r>
-              <a:rPr sz="1450" b="1" i="0">
+              <a:t>EU AI Act, Article 15:</a:t>
+            </a:r>
+            <a:r>
+              <a:rPr sz="1500" b="0" i="0">
                 <a:solidFill>
                   <a:srgbClr val="1F2937"/>
                 </a:solidFill>
                 <a:latin typeface="Calibri"/>
               </a:rPr>
-              <a:t>EU AI Act, Article 15</a:t>
-            </a:r>
-            <a:r>
-              <a:rPr sz="1450" b="0" i="0">
-                <a:solidFill>
-                  <a:srgbClr val="1F2937"/>
-                </a:solidFill>
-                <a:latin typeface="Calibri"/>
-              </a:rPr>
-              <a:t>, requires high-risk AI to be “resilient against attempts by unauthorised third parties to alter their use, outputs or performance.”</a:t>
+              <a:t> high-risk AI must be “resilient against attempts by unauthorised third parties to alter their use, outputs or performance.”</a:t>
             </a:r>
           </a:p>
           <a:p>
@@ -10570,17 +10948,17 @@
                 <a:spcPct val="110000"/>
               </a:lnSpc>
               <a:spcAft>
-                <a:spcPts val="1000"/>
+                <a:spcPts val="1200"/>
               </a:spcAft>
             </a:pPr>
             <a:r>
-              <a:rPr sz="1450" b="0" i="0">
+              <a:rPr sz="1500" b="0" i="0">
                 <a:solidFill>
                   <a:srgbClr val="1F2937"/>
                 </a:solidFill>
                 <a:latin typeface="Calibri"/>
               </a:rPr>
-              <a:t>It names data poisoning, model poisoning and adversarial examples, and asks for measures to “prevent, detect, respond to” them.</a:t>
+              <a:t>It names data poisoning, model poisoning and adversarial examples, and requires measures to “prevent, detect, respond to” them.</a:t>
             </a:r>
           </a:p>
           <a:p>
@@ -10589,26 +10967,26 @@
                 <a:spcPct val="110000"/>
               </a:lnSpc>
               <a:spcAft>
-                <a:spcPts val="1000"/>
+                <a:spcPts val="1200"/>
               </a:spcAft>
             </a:pPr>
             <a:r>
-              <a:rPr sz="1450" b="1" i="0">
+              <a:rPr sz="1500" b="1" i="0">
                 <a:solidFill>
                   <a:srgbClr val="1F2937"/>
                 </a:solidFill>
                 <a:latin typeface="Calibri"/>
               </a:rPr>
-              <a:t>Why it matters:</a:t>
-            </a:r>
-            <a:r>
-              <a:rPr sz="1450" b="0" i="0">
+              <a:t>Effect:</a:t>
+            </a:r>
+            <a:r>
+              <a:rPr sz="1500" b="0" i="0">
                 <a:solidFill>
                   <a:srgbClr val="1F2937"/>
                 </a:solidFill>
                 <a:latin typeface="Calibri"/>
               </a:rPr>
-              <a:t> robustness testing and anomaly detection move from best practice to legal duty.</a:t>
+              <a:t> robustness testing and anomaly detection become legal duties.</a:t>
             </a:r>
           </a:p>
         </p:txBody>
@@ -10966,7 +11344,7 @@
                 </a:solidFill>
                 <a:latin typeface="Calibri"/>
               </a:rPr>
-              <a:t> In Modules 3–5 I built detectors and trusted their accuracy; this module showed that the detector itself is a target. I want to build AI defenses that are red-teamed before release and backed by anomaly checks.</a:t>
+              <a:t> In Modules 3–5 I built an anomaly detector, a fraud model and a phishing filter and judged them by accuracy; this module showed the detector itself is a target. I want to build AI defenses that are red-teamed before release, watched by anomaly checks, and that let a human confirm high-stakes actions.</a:t>
             </a:r>
           </a:p>
         </p:txBody>
@@ -11267,7 +11645,7 @@
                 </a:solidFill>
                 <a:latin typeface="Calibri"/>
               </a:rPr>
-              <a:t>Regulation (EU) 2024/1689 of the European Parliament and of the Council of 13 June 2024 laying down harmonised rules on artificial intelligence. (2024). </a:t>
+              <a:t>Regulation (EU) 2024/1689 of the European Parliament and of the Council of 13 June 2024 laying down harmonised rules on artificial intelligence (Artificial Intelligence Act). (2024). </a:t>
             </a:r>
             <a:r>
               <a:rPr sz="1100" b="0" i="1">

</xml_diff>

<commit_message>
Module 6 deck: title date October 18 (as submitted)
Co-Authored-By: Claude Opus 5.5 <noreply@anthropic.com>
</commit_message>
<xml_diff>
--- a/module-06-adversarial-attacks/Bandari_Ruthvik_Nath_Module6_Adversarial_Attack_Analysis.pptx
+++ b/module-06-adversarial-attacks/Bandari_Ruthvik_Nath_Module6_Adversarial_Attack_Analysis.pptx
@@ -4,16 +4,19 @@
   <p:sldMasterIdLst>
     <p:sldMasterId id="2147483648" r:id="rId1"/>
   </p:sldMasterIdLst>
+  <p:notesMasterIdLst>
+    <p:notesMasterId r:id="rId9"/>
+  </p:notesMasterIdLst>
   <p:sldIdLst>
-    <p:sldId id="256" r:id="rId7"/>
-    <p:sldId id="257" r:id="rId9"/>
-    <p:sldId id="258" r:id="rId10"/>
-    <p:sldId id="259" r:id="rId11"/>
-    <p:sldId id="260" r:id="rId12"/>
-    <p:sldId id="261" r:id="rId13"/>
-    <p:sldId id="262" r:id="rId14"/>
+    <p:sldId id="256" r:id="rId2"/>
+    <p:sldId id="257" r:id="rId3"/>
+    <p:sldId id="258" r:id="rId4"/>
+    <p:sldId id="259" r:id="rId5"/>
+    <p:sldId id="260" r:id="rId6"/>
+    <p:sldId id="261" r:id="rId7"/>
+    <p:sldId id="262" r:id="rId8"/>
   </p:sldIdLst>
-  <p:sldSz cx="12191695" cy="6858000" type="screen4x3"/>
+  <p:sldSz cx="12192000" cy="6858000"/>
   <p:notesSz cx="6858000" cy="9144000"/>
   <p:defaultTextStyle>
     <a:defPPr>
@@ -110,11 +113,27 @@
       </a:defRPr>
     </a:lvl9pPr>
   </p:defaultTextStyle>
+  <p:extLst>
+    <p:ext uri="{EFAFB233-063F-42B5-8137-9DF3F51BA10A}">
+      <p15:sldGuideLst xmlns:p15="http://schemas.microsoft.com/office/powerpoint/2012/main">
+        <p15:guide id="1" orient="horz" pos="2160">
+          <p15:clr>
+            <a:srgbClr val="A4A3A4"/>
+          </p15:clr>
+        </p15:guide>
+        <p15:guide id="2" pos="2880">
+          <p15:clr>
+            <a:srgbClr val="A4A3A4"/>
+          </p15:clr>
+        </p15:guide>
+      </p15:sldGuideLst>
+    </p:ext>
+  </p:extLst>
 </p:presentation>
 </file>
 
 <file path=ppt/notesMasters/notesMaster1.xml><?xml version="1.0" encoding="utf-8"?>
-<p:notesMaster xmlns:a="http://schemas.openxmlformats.org/drawingml/2006/main" xmlns:p="http://schemas.openxmlformats.org/presentationml/2006/main" xmlns:r="http://schemas.openxmlformats.org/officeDocument/2006/relationships">
+<p:notesMaster xmlns:a="http://schemas.openxmlformats.org/drawingml/2006/main" xmlns:r="http://schemas.openxmlformats.org/officeDocument/2006/relationships" xmlns:p="http://schemas.openxmlformats.org/presentationml/2006/main">
   <p:cSld>
     <p:bg>
       <p:bgRef idx="1001">
@@ -135,241 +154,16 @@
           <a:chExt cx="0" cy="0"/>
         </a:xfrm>
       </p:grpSpPr>
-      <p:sp>
-        <p:nvSpPr>
-          <p:cNvPr id="2" name="Header Placeholder 1"/>
-          <p:cNvSpPr>
-            <a:spLocks noGrp="1"/>
-          </p:cNvSpPr>
-          <p:nvPr>
-            <p:ph type="hdr" sz="quarter"/>
-          </p:nvPr>
-        </p:nvSpPr>
-        <p:spPr>
-          <a:xfrm>
-            <a:off x="0" y="0"/>
-            <a:ext cx="2971800" cy="457200"/>
-          </a:xfrm>
-          <a:prstGeom prst="rect">
-            <a:avLst/>
-          </a:prstGeom>
-        </p:spPr>
-        <p:txBody>
-          <a:bodyPr vert="horz" lIns="91440" tIns="45720" rIns="91440" bIns="45720" rtlCol="0"/>
-          <a:lstStyle>
-            <a:lvl1pPr algn="l">
-              <a:defRPr sz="1200"/>
-            </a:lvl1pPr>
-          </a:lstStyle>
-          <a:p>
-            <a:endParaRPr lang="en-US"/>
-          </a:p>
-        </p:txBody>
-      </p:sp>
-      <p:sp>
-        <p:nvSpPr>
-          <p:cNvPr id="3" name="Date Placeholder 2"/>
-          <p:cNvSpPr>
-            <a:spLocks noGrp="1"/>
-          </p:cNvSpPr>
-          <p:nvPr>
-            <p:ph type="dt" idx="1"/>
-          </p:nvPr>
-        </p:nvSpPr>
-        <p:spPr>
-          <a:xfrm>
-            <a:off x="3884613" y="0"/>
-            <a:ext cx="2971800" cy="457200"/>
-          </a:xfrm>
-          <a:prstGeom prst="rect">
-            <a:avLst/>
-          </a:prstGeom>
-        </p:spPr>
-        <p:txBody>
-          <a:bodyPr vert="horz" lIns="91440" tIns="45720" rIns="91440" bIns="45720" rtlCol="0"/>
-          <a:lstStyle>
-            <a:lvl1pPr algn="r">
-              <a:defRPr sz="1200"/>
-            </a:lvl1pPr>
-          </a:lstStyle>
-          <a:p>
-            <a:fld id="{0F89C1C7-3DCD-1040-A9CF-14679D8B5DDD}" type="datetimeFigureOut">
-              <a:rPr lang="en-US" smtClean="0"/>
-              <a:t>10/17/16</a:t>
-            </a:fld>
-            <a:endParaRPr lang="en-US"/>
-          </a:p>
-        </p:txBody>
-      </p:sp>
-      <p:sp>
-        <p:nvSpPr>
-          <p:cNvPr id="4" name="Slide Image Placeholder 3"/>
-          <p:cNvSpPr>
-            <a:spLocks noGrp="1" noRot="1" noChangeAspect="1"/>
-          </p:cNvSpPr>
-          <p:nvPr>
-            <p:ph type="sldImg" idx="2"/>
-          </p:nvPr>
-        </p:nvSpPr>
-        <p:spPr>
-          <a:xfrm>
-            <a:off x="1143000" y="685800"/>
-            <a:ext cx="4572000" cy="3429000"/>
-          </a:xfrm>
-          <a:prstGeom prst="rect">
-            <a:avLst/>
-          </a:prstGeom>
-          <a:noFill/>
-          <a:ln w="12700">
-            <a:solidFill>
-              <a:prstClr val="black"/>
-            </a:solidFill>
-          </a:ln>
-        </p:spPr>
-        <p:txBody>
-          <a:bodyPr vert="horz" lIns="91440" tIns="45720" rIns="91440" bIns="45720" rtlCol="0" anchor="ctr"/>
-          <a:lstStyle/>
-          <a:p>
-            <a:endParaRPr lang="en-US"/>
-          </a:p>
-        </p:txBody>
-      </p:sp>
-      <p:sp>
-        <p:nvSpPr>
-          <p:cNvPr id="5" name="Notes Placeholder 4"/>
-          <p:cNvSpPr>
-            <a:spLocks noGrp="1"/>
-          </p:cNvSpPr>
-          <p:nvPr>
-            <p:ph type="body" sz="quarter" idx="3"/>
-          </p:nvPr>
-        </p:nvSpPr>
-        <p:spPr>
-          <a:xfrm>
-            <a:off x="685800" y="4343400"/>
-            <a:ext cx="5486400" cy="4114800"/>
-          </a:xfrm>
-          <a:prstGeom prst="rect">
-            <a:avLst/>
-          </a:prstGeom>
-        </p:spPr>
-        <p:txBody>
-          <a:bodyPr vert="horz" lIns="91440" tIns="45720" rIns="91440" bIns="45720" rtlCol="0"/>
-          <a:lstStyle/>
-          <a:p>
-            <a:pPr lvl="0"/>
-            <a:r>
-              <a:rPr lang="en-US" smtClean="0"/>
-              <a:t>Click to edit Master text styles</a:t>
-            </a:r>
-          </a:p>
-          <a:p>
-            <a:pPr lvl="1"/>
-            <a:r>
-              <a:rPr lang="en-US" smtClean="0"/>
-              <a:t>Second level</a:t>
-            </a:r>
-          </a:p>
-          <a:p>
-            <a:pPr lvl="2"/>
-            <a:r>
-              <a:rPr lang="en-US" smtClean="0"/>
-              <a:t>Third level</a:t>
-            </a:r>
-          </a:p>
-          <a:p>
-            <a:pPr lvl="3"/>
-            <a:r>
-              <a:rPr lang="en-US" smtClean="0"/>
-              <a:t>Fourth level</a:t>
-            </a:r>
-          </a:p>
-          <a:p>
-            <a:pPr lvl="4"/>
-            <a:r>
-              <a:rPr lang="en-US" smtClean="0"/>
-              <a:t>Fifth level</a:t>
-            </a:r>
-            <a:endParaRPr lang="en-US"/>
-          </a:p>
-        </p:txBody>
-      </p:sp>
-      <p:sp>
-        <p:nvSpPr>
-          <p:cNvPr id="6" name="Footer Placeholder 5"/>
-          <p:cNvSpPr>
-            <a:spLocks noGrp="1"/>
-          </p:cNvSpPr>
-          <p:nvPr>
-            <p:ph type="ftr" sz="quarter" idx="4"/>
-          </p:nvPr>
-        </p:nvSpPr>
-        <p:spPr>
-          <a:xfrm>
-            <a:off x="0" y="8685213"/>
-            <a:ext cx="2971800" cy="457200"/>
-          </a:xfrm>
-          <a:prstGeom prst="rect">
-            <a:avLst/>
-          </a:prstGeom>
-        </p:spPr>
-        <p:txBody>
-          <a:bodyPr vert="horz" lIns="91440" tIns="45720" rIns="91440" bIns="45720" rtlCol="0" anchor="b"/>
-          <a:lstStyle>
-            <a:lvl1pPr algn="l">
-              <a:defRPr sz="1200"/>
-            </a:lvl1pPr>
-          </a:lstStyle>
-          <a:p>
-            <a:endParaRPr lang="en-US"/>
-          </a:p>
-        </p:txBody>
-      </p:sp>
-      <p:sp>
-        <p:nvSpPr>
-          <p:cNvPr id="7" name="Slide Number Placeholder 6"/>
-          <p:cNvSpPr>
-            <a:spLocks noGrp="1"/>
-          </p:cNvSpPr>
-          <p:nvPr>
-            <p:ph type="sldNum" sz="quarter" idx="5"/>
-          </p:nvPr>
-        </p:nvSpPr>
-        <p:spPr>
-          <a:xfrm>
-            <a:off x="3884613" y="8685213"/>
-            <a:ext cx="2971800" cy="457200"/>
-          </a:xfrm>
-          <a:prstGeom prst="rect">
-            <a:avLst/>
-          </a:prstGeom>
-        </p:spPr>
-        <p:txBody>
-          <a:bodyPr vert="horz" lIns="91440" tIns="45720" rIns="91440" bIns="45720" rtlCol="0" anchor="b"/>
-          <a:lstStyle>
-            <a:lvl1pPr algn="r">
-              <a:defRPr sz="1200"/>
-            </a:lvl1pPr>
-          </a:lstStyle>
-          <a:p>
-            <a:fld id="{BB5E49A5-4136-284D-997B-48E1D791AD67}" type="slidenum">
-              <a:rPr lang="en-US" smtClean="0"/>
-              <a:t>‹#›</a:t>
-            </a:fld>
-            <a:endParaRPr lang="en-US"/>
-          </a:p>
-        </p:txBody>
-      </p:sp>
     </p:spTree>
     <p:extLst>
       <p:ext uri="{BB962C8B-B14F-4D97-AF65-F5344CB8AC3E}">
-        <p14:creationId xmlns:p14="http://schemas.microsoft.com/office/powerpoint/2010/main" val="2623252185"/>
+        <p14:creationId xmlns:p14="http://schemas.microsoft.com/office/powerpoint/2010/main" val="3735102312"/>
       </p:ext>
     </p:extLst>
   </p:cSld>
   <p:clrMap bg1="lt1" tx1="dk1" bg2="lt2" tx2="dk2" accent1="accent1" accent2="accent2" accent3="accent3" accent4="accent4" accent5="accent5" accent6="accent6" hlink="hlink" folHlink="folHlink"/>
   <p:notesStyle>
-    <a:lvl1pPr marL="0" algn="l" defTabSz="457200" rtl="0" eaLnBrk="1" latinLnBrk="0" hangingPunct="1">
+    <a:lvl1pPr marL="0" algn="l" defTabSz="914400" rtl="0" eaLnBrk="1" latinLnBrk="0" hangingPunct="1">
       <a:defRPr sz="1200" kern="1200">
         <a:solidFill>
           <a:schemeClr val="tx1"/>
@@ -379,7 +173,7 @@
         <a:cs typeface="+mn-cs"/>
       </a:defRPr>
     </a:lvl1pPr>
-    <a:lvl2pPr marL="457200" algn="l" defTabSz="457200" rtl="0" eaLnBrk="1" latinLnBrk="0" hangingPunct="1">
+    <a:lvl2pPr marL="457200" algn="l" defTabSz="914400" rtl="0" eaLnBrk="1" latinLnBrk="0" hangingPunct="1">
       <a:defRPr sz="1200" kern="1200">
         <a:solidFill>
           <a:schemeClr val="tx1"/>
@@ -389,7 +183,7 @@
         <a:cs typeface="+mn-cs"/>
       </a:defRPr>
     </a:lvl2pPr>
-    <a:lvl3pPr marL="914400" algn="l" defTabSz="457200" rtl="0" eaLnBrk="1" latinLnBrk="0" hangingPunct="1">
+    <a:lvl3pPr marL="914400" algn="l" defTabSz="914400" rtl="0" eaLnBrk="1" latinLnBrk="0" hangingPunct="1">
       <a:defRPr sz="1200" kern="1200">
         <a:solidFill>
           <a:schemeClr val="tx1"/>
@@ -399,7 +193,7 @@
         <a:cs typeface="+mn-cs"/>
       </a:defRPr>
     </a:lvl3pPr>
-    <a:lvl4pPr marL="1371600" algn="l" defTabSz="457200" rtl="0" eaLnBrk="1" latinLnBrk="0" hangingPunct="1">
+    <a:lvl4pPr marL="1371600" algn="l" defTabSz="914400" rtl="0" eaLnBrk="1" latinLnBrk="0" hangingPunct="1">
       <a:defRPr sz="1200" kern="1200">
         <a:solidFill>
           <a:schemeClr val="tx1"/>
@@ -409,7 +203,7 @@
         <a:cs typeface="+mn-cs"/>
       </a:defRPr>
     </a:lvl4pPr>
-    <a:lvl5pPr marL="1828800" algn="l" defTabSz="457200" rtl="0" eaLnBrk="1" latinLnBrk="0" hangingPunct="1">
+    <a:lvl5pPr marL="1828800" algn="l" defTabSz="914400" rtl="0" eaLnBrk="1" latinLnBrk="0" hangingPunct="1">
       <a:defRPr sz="1200" kern="1200">
         <a:solidFill>
           <a:schemeClr val="tx1"/>
@@ -419,7 +213,7 @@
         <a:cs typeface="+mn-cs"/>
       </a:defRPr>
     </a:lvl5pPr>
-    <a:lvl6pPr marL="2286000" algn="l" defTabSz="457200" rtl="0" eaLnBrk="1" latinLnBrk="0" hangingPunct="1">
+    <a:lvl6pPr marL="2286000" algn="l" defTabSz="914400" rtl="0" eaLnBrk="1" latinLnBrk="0" hangingPunct="1">
       <a:defRPr sz="1200" kern="1200">
         <a:solidFill>
           <a:schemeClr val="tx1"/>
@@ -429,7 +223,7 @@
         <a:cs typeface="+mn-cs"/>
       </a:defRPr>
     </a:lvl6pPr>
-    <a:lvl7pPr marL="2743200" algn="l" defTabSz="457200" rtl="0" eaLnBrk="1" latinLnBrk="0" hangingPunct="1">
+    <a:lvl7pPr marL="2743200" algn="l" defTabSz="914400" rtl="0" eaLnBrk="1" latinLnBrk="0" hangingPunct="1">
       <a:defRPr sz="1200" kern="1200">
         <a:solidFill>
           <a:schemeClr val="tx1"/>
@@ -439,7 +233,7 @@
         <a:cs typeface="+mn-cs"/>
       </a:defRPr>
     </a:lvl7pPr>
-    <a:lvl8pPr marL="3200400" algn="l" defTabSz="457200" rtl="0" eaLnBrk="1" latinLnBrk="0" hangingPunct="1">
+    <a:lvl8pPr marL="3200400" algn="l" defTabSz="914400" rtl="0" eaLnBrk="1" latinLnBrk="0" hangingPunct="1">
       <a:defRPr sz="1200" kern="1200">
         <a:solidFill>
           <a:schemeClr val="tx1"/>
@@ -449,7 +243,7 @@
         <a:cs typeface="+mn-cs"/>
       </a:defRPr>
     </a:lvl8pPr>
-    <a:lvl9pPr marL="3657600" algn="l" defTabSz="457200" rtl="0" eaLnBrk="1" latinLnBrk="0" hangingPunct="1">
+    <a:lvl9pPr marL="3657600" algn="l" defTabSz="914400" rtl="0" eaLnBrk="1" latinLnBrk="0" hangingPunct="1">
       <a:defRPr sz="1200" kern="1200">
         <a:solidFill>
           <a:schemeClr val="tx1"/>
@@ -464,7 +258,7 @@
 </file>
 
 <file path=ppt/notesSlides/notesSlide1.xml><?xml version="1.0" encoding="utf-8"?>
-<p:notes xmlns:a="http://schemas.openxmlformats.org/drawingml/2006/main" xmlns:p="http://schemas.openxmlformats.org/presentationml/2006/main" xmlns:r="http://schemas.openxmlformats.org/officeDocument/2006/relationships">
+<p:notes xmlns:a="http://schemas.openxmlformats.org/drawingml/2006/main" xmlns:r="http://schemas.openxmlformats.org/officeDocument/2006/relationships" xmlns:p="http://schemas.openxmlformats.org/presentationml/2006/main">
   <p:cSld>
     <p:spTree>
       <p:nvGrpSpPr>
@@ -484,7 +278,7 @@
         <p:nvSpPr>
           <p:cNvPr id="2" name="Slide Image Placeholder 1"/>
           <p:cNvSpPr>
-            <a:spLocks noGrp="1"/>
+            <a:spLocks noGrp="1" noRot="1" noChangeAspect="1"/>
           </p:cNvSpPr>
           <p:nvPr>
             <p:ph type="sldImg" idx="2"/>
@@ -499,7 +293,7 @@
             <a:spLocks noGrp="1"/>
           </p:cNvSpPr>
           <p:nvPr>
-            <p:ph type="body" idx="3" sz="quarter"/>
+            <p:ph type="body" sz="quarter" idx="3"/>
           </p:nvPr>
         </p:nvSpPr>
         <p:spPr/>
@@ -520,7 +314,7 @@
             <a:spLocks noGrp="1"/>
           </p:cNvSpPr>
           <p:nvPr>
-            <p:ph type="sldNum" idx="5" sz="quarter"/>
+            <p:ph type="sldNum" sz="quarter" idx="5"/>
           </p:nvPr>
         </p:nvSpPr>
         <p:spPr/>
@@ -534,7 +328,7 @@
 </file>
 
 <file path=ppt/notesSlides/notesSlide2.xml><?xml version="1.0" encoding="utf-8"?>
-<p:notes xmlns:a="http://schemas.openxmlformats.org/drawingml/2006/main" xmlns:p="http://schemas.openxmlformats.org/presentationml/2006/main" xmlns:r="http://schemas.openxmlformats.org/officeDocument/2006/relationships">
+<p:notes xmlns:a="http://schemas.openxmlformats.org/drawingml/2006/main" xmlns:r="http://schemas.openxmlformats.org/officeDocument/2006/relationships" xmlns:p="http://schemas.openxmlformats.org/presentationml/2006/main">
   <p:cSld>
     <p:spTree>
       <p:nvGrpSpPr>
@@ -554,7 +348,7 @@
         <p:nvSpPr>
           <p:cNvPr id="2" name="Slide Image Placeholder 1"/>
           <p:cNvSpPr>
-            <a:spLocks noGrp="1"/>
+            <a:spLocks noGrp="1" noRot="1" noChangeAspect="1"/>
           </p:cNvSpPr>
           <p:nvPr>
             <p:ph type="sldImg" idx="2"/>
@@ -569,7 +363,7 @@
             <a:spLocks noGrp="1"/>
           </p:cNvSpPr>
           <p:nvPr>
-            <p:ph type="body" idx="3" sz="quarter"/>
+            <p:ph type="body" sz="quarter" idx="3"/>
           </p:nvPr>
         </p:nvSpPr>
         <p:spPr/>
@@ -590,7 +384,7 @@
             <a:spLocks noGrp="1"/>
           </p:cNvSpPr>
           <p:nvPr>
-            <p:ph type="sldNum" idx="5" sz="quarter"/>
+            <p:ph type="sldNum" sz="quarter" idx="5"/>
           </p:nvPr>
         </p:nvSpPr>
         <p:spPr/>
@@ -604,7 +398,7 @@
 </file>
 
 <file path=ppt/notesSlides/notesSlide3.xml><?xml version="1.0" encoding="utf-8"?>
-<p:notes xmlns:a="http://schemas.openxmlformats.org/drawingml/2006/main" xmlns:p="http://schemas.openxmlformats.org/presentationml/2006/main" xmlns:r="http://schemas.openxmlformats.org/officeDocument/2006/relationships">
+<p:notes xmlns:a="http://schemas.openxmlformats.org/drawingml/2006/main" xmlns:r="http://schemas.openxmlformats.org/officeDocument/2006/relationships" xmlns:p="http://schemas.openxmlformats.org/presentationml/2006/main">
   <p:cSld>
     <p:spTree>
       <p:nvGrpSpPr>
@@ -624,7 +418,7 @@
         <p:nvSpPr>
           <p:cNvPr id="2" name="Slide Image Placeholder 1"/>
           <p:cNvSpPr>
-            <a:spLocks noGrp="1"/>
+            <a:spLocks noGrp="1" noRot="1" noChangeAspect="1"/>
           </p:cNvSpPr>
           <p:nvPr>
             <p:ph type="sldImg" idx="2"/>
@@ -639,7 +433,7 @@
             <a:spLocks noGrp="1"/>
           </p:cNvSpPr>
           <p:nvPr>
-            <p:ph type="body" idx="3" sz="quarter"/>
+            <p:ph type="body" sz="quarter" idx="3"/>
           </p:nvPr>
         </p:nvSpPr>
         <p:spPr/>
@@ -660,7 +454,7 @@
             <a:spLocks noGrp="1"/>
           </p:cNvSpPr>
           <p:nvPr>
-            <p:ph type="sldNum" idx="5" sz="quarter"/>
+            <p:ph type="sldNum" sz="quarter" idx="5"/>
           </p:nvPr>
         </p:nvSpPr>
         <p:spPr/>
@@ -674,7 +468,7 @@
 </file>
 
 <file path=ppt/notesSlides/notesSlide4.xml><?xml version="1.0" encoding="utf-8"?>
-<p:notes xmlns:a="http://schemas.openxmlformats.org/drawingml/2006/main" xmlns:p="http://schemas.openxmlformats.org/presentationml/2006/main" xmlns:r="http://schemas.openxmlformats.org/officeDocument/2006/relationships">
+<p:notes xmlns:a="http://schemas.openxmlformats.org/drawingml/2006/main" xmlns:r="http://schemas.openxmlformats.org/officeDocument/2006/relationships" xmlns:p="http://schemas.openxmlformats.org/presentationml/2006/main">
   <p:cSld>
     <p:spTree>
       <p:nvGrpSpPr>
@@ -694,7 +488,7 @@
         <p:nvSpPr>
           <p:cNvPr id="2" name="Slide Image Placeholder 1"/>
           <p:cNvSpPr>
-            <a:spLocks noGrp="1"/>
+            <a:spLocks noGrp="1" noRot="1" noChangeAspect="1"/>
           </p:cNvSpPr>
           <p:nvPr>
             <p:ph type="sldImg" idx="2"/>
@@ -709,7 +503,7 @@
             <a:spLocks noGrp="1"/>
           </p:cNvSpPr>
           <p:nvPr>
-            <p:ph type="body" idx="3" sz="quarter"/>
+            <p:ph type="body" sz="quarter" idx="3"/>
           </p:nvPr>
         </p:nvSpPr>
         <p:spPr/>
@@ -730,7 +524,7 @@
             <a:spLocks noGrp="1"/>
           </p:cNvSpPr>
           <p:nvPr>
-            <p:ph type="sldNum" idx="5" sz="quarter"/>
+            <p:ph type="sldNum" sz="quarter" idx="5"/>
           </p:nvPr>
         </p:nvSpPr>
         <p:spPr/>
@@ -744,7 +538,7 @@
 </file>
 
 <file path=ppt/notesSlides/notesSlide5.xml><?xml version="1.0" encoding="utf-8"?>
-<p:notes xmlns:a="http://schemas.openxmlformats.org/drawingml/2006/main" xmlns:p="http://schemas.openxmlformats.org/presentationml/2006/main" xmlns:r="http://schemas.openxmlformats.org/officeDocument/2006/relationships">
+<p:notes xmlns:a="http://schemas.openxmlformats.org/drawingml/2006/main" xmlns:r="http://schemas.openxmlformats.org/officeDocument/2006/relationships" xmlns:p="http://schemas.openxmlformats.org/presentationml/2006/main">
   <p:cSld>
     <p:spTree>
       <p:nvGrpSpPr>
@@ -764,7 +558,7 @@
         <p:nvSpPr>
           <p:cNvPr id="2" name="Slide Image Placeholder 1"/>
           <p:cNvSpPr>
-            <a:spLocks noGrp="1"/>
+            <a:spLocks noGrp="1" noRot="1" noChangeAspect="1"/>
           </p:cNvSpPr>
           <p:nvPr>
             <p:ph type="sldImg" idx="2"/>
@@ -779,7 +573,7 @@
             <a:spLocks noGrp="1"/>
           </p:cNvSpPr>
           <p:nvPr>
-            <p:ph type="body" idx="3" sz="quarter"/>
+            <p:ph type="body" sz="quarter" idx="3"/>
           </p:nvPr>
         </p:nvSpPr>
         <p:spPr/>
@@ -800,7 +594,7 @@
             <a:spLocks noGrp="1"/>
           </p:cNvSpPr>
           <p:nvPr>
-            <p:ph type="sldNum" idx="5" sz="quarter"/>
+            <p:ph type="sldNum" sz="quarter" idx="5"/>
           </p:nvPr>
         </p:nvSpPr>
         <p:spPr/>
@@ -814,7 +608,7 @@
 </file>
 
 <file path=ppt/notesSlides/notesSlide6.xml><?xml version="1.0" encoding="utf-8"?>
-<p:notes xmlns:a="http://schemas.openxmlformats.org/drawingml/2006/main" xmlns:p="http://schemas.openxmlformats.org/presentationml/2006/main" xmlns:r="http://schemas.openxmlformats.org/officeDocument/2006/relationships">
+<p:notes xmlns:a="http://schemas.openxmlformats.org/drawingml/2006/main" xmlns:r="http://schemas.openxmlformats.org/officeDocument/2006/relationships" xmlns:p="http://schemas.openxmlformats.org/presentationml/2006/main">
   <p:cSld>
     <p:spTree>
       <p:nvGrpSpPr>
@@ -834,7 +628,7 @@
         <p:nvSpPr>
           <p:cNvPr id="2" name="Slide Image Placeholder 1"/>
           <p:cNvSpPr>
-            <a:spLocks noGrp="1"/>
+            <a:spLocks noGrp="1" noRot="1" noChangeAspect="1"/>
           </p:cNvSpPr>
           <p:nvPr>
             <p:ph type="sldImg" idx="2"/>
@@ -849,7 +643,7 @@
             <a:spLocks noGrp="1"/>
           </p:cNvSpPr>
           <p:nvPr>
-            <p:ph type="body" idx="3" sz="quarter"/>
+            <p:ph type="body" sz="quarter" idx="3"/>
           </p:nvPr>
         </p:nvSpPr>
         <p:spPr/>
@@ -870,7 +664,7 @@
             <a:spLocks noGrp="1"/>
           </p:cNvSpPr>
           <p:nvPr>
-            <p:ph type="sldNum" idx="5" sz="quarter"/>
+            <p:ph type="sldNum" sz="quarter" idx="5"/>
           </p:nvPr>
         </p:nvSpPr>
         <p:spPr/>
@@ -884,7 +678,7 @@
 </file>
 
 <file path=ppt/notesSlides/notesSlide7.xml><?xml version="1.0" encoding="utf-8"?>
-<p:notes xmlns:a="http://schemas.openxmlformats.org/drawingml/2006/main" xmlns:p="http://schemas.openxmlformats.org/presentationml/2006/main" xmlns:r="http://schemas.openxmlformats.org/officeDocument/2006/relationships">
+<p:notes xmlns:a="http://schemas.openxmlformats.org/drawingml/2006/main" xmlns:r="http://schemas.openxmlformats.org/officeDocument/2006/relationships" xmlns:p="http://schemas.openxmlformats.org/presentationml/2006/main">
   <p:cSld>
     <p:spTree>
       <p:nvGrpSpPr>
@@ -904,7 +698,7 @@
         <p:nvSpPr>
           <p:cNvPr id="2" name="Slide Image Placeholder 1"/>
           <p:cNvSpPr>
-            <a:spLocks noGrp="1"/>
+            <a:spLocks noGrp="1" noRot="1" noChangeAspect="1"/>
           </p:cNvSpPr>
           <p:nvPr>
             <p:ph type="sldImg" idx="2"/>
@@ -919,7 +713,7 @@
             <a:spLocks noGrp="1"/>
           </p:cNvSpPr>
           <p:nvPr>
-            <p:ph type="body" idx="3" sz="quarter"/>
+            <p:ph type="body" sz="quarter" idx="3"/>
           </p:nvPr>
         </p:nvSpPr>
         <p:spPr/>
@@ -940,7 +734,7 @@
             <a:spLocks noGrp="1"/>
           </p:cNvSpPr>
           <p:nvPr>
-            <p:ph type="sldNum" idx="5" sz="quarter"/>
+            <p:ph type="sldNum" sz="quarter" idx="5"/>
           </p:nvPr>
         </p:nvSpPr>
         <p:spPr/>
@@ -991,10 +785,9 @@
           <a:lstStyle/>
           <a:p>
             <a:r>
-              <a:rPr lang="en-US" smtClean="0"/>
+              <a:rPr lang="en-US"/>
               <a:t>Click to edit Master title style</a:t>
             </a:r>
-            <a:endParaRPr lang="en-US"/>
           </a:p>
         </p:txBody>
       </p:sp>
@@ -1110,10 +903,9 @@
           </a:lstStyle>
           <a:p>
             <a:r>
-              <a:rPr lang="en-US" smtClean="0"/>
+              <a:rPr lang="en-US"/>
               <a:t>Click to edit Master subtitle style</a:t>
             </a:r>
-            <a:endParaRPr lang="en-US"/>
           </a:p>
         </p:txBody>
       </p:sp>
@@ -1134,7 +926,7 @@
           <a:p>
             <a:fld id="{5BCAD085-E8A6-8845-BD4E-CB4CCA059FC4}" type="datetimeFigureOut">
               <a:rPr lang="en-US" smtClean="0"/>
-              <a:t>1/27/13</a:t>
+              <a:t>10/18/26</a:t>
             </a:fld>
             <a:endParaRPr lang="en-US"/>
           </a:p>
@@ -1228,10 +1020,9 @@
           <a:lstStyle/>
           <a:p>
             <a:r>
-              <a:rPr lang="en-US" smtClean="0"/>
+              <a:rPr lang="en-US"/>
               <a:t>Click to edit Master title style</a:t>
             </a:r>
-            <a:endParaRPr lang="en-US"/>
           </a:p>
         </p:txBody>
       </p:sp>
@@ -1252,38 +1043,37 @@
           <a:p>
             <a:pPr lvl="0"/>
             <a:r>
-              <a:rPr lang="en-US" smtClean="0"/>
+              <a:rPr lang="en-US"/>
               <a:t>Click to edit Master text styles</a:t>
             </a:r>
           </a:p>
           <a:p>
             <a:pPr lvl="1"/>
             <a:r>
-              <a:rPr lang="en-US" smtClean="0"/>
+              <a:rPr lang="en-US"/>
               <a:t>Second level</a:t>
             </a:r>
           </a:p>
           <a:p>
             <a:pPr lvl="2"/>
             <a:r>
-              <a:rPr lang="en-US" smtClean="0"/>
+              <a:rPr lang="en-US"/>
               <a:t>Third level</a:t>
             </a:r>
           </a:p>
           <a:p>
             <a:pPr lvl="3"/>
             <a:r>
-              <a:rPr lang="en-US" smtClean="0"/>
+              <a:rPr lang="en-US"/>
               <a:t>Fourth level</a:t>
             </a:r>
           </a:p>
           <a:p>
             <a:pPr lvl="4"/>
             <a:r>
-              <a:rPr lang="en-US" smtClean="0"/>
+              <a:rPr lang="en-US"/>
               <a:t>Fifth level</a:t>
             </a:r>
-            <a:endParaRPr lang="en-US"/>
           </a:p>
         </p:txBody>
       </p:sp>
@@ -1304,7 +1094,7 @@
           <a:p>
             <a:fld id="{5BCAD085-E8A6-8845-BD4E-CB4CCA059FC4}" type="datetimeFigureOut">
               <a:rPr lang="en-US" smtClean="0"/>
-              <a:t>1/27/13</a:t>
+              <a:t>10/18/26</a:t>
             </a:fld>
             <a:endParaRPr lang="en-US"/>
           </a:p>
@@ -1403,10 +1193,9 @@
           <a:lstStyle/>
           <a:p>
             <a:r>
-              <a:rPr lang="en-US" smtClean="0"/>
+              <a:rPr lang="en-US"/>
               <a:t>Click to edit Master title style</a:t>
             </a:r>
-            <a:endParaRPr lang="en-US"/>
           </a:p>
         </p:txBody>
       </p:sp>
@@ -1432,38 +1221,37 @@
           <a:p>
             <a:pPr lvl="0"/>
             <a:r>
-              <a:rPr lang="en-US" smtClean="0"/>
+              <a:rPr lang="en-US"/>
               <a:t>Click to edit Master text styles</a:t>
             </a:r>
           </a:p>
           <a:p>
             <a:pPr lvl="1"/>
             <a:r>
-              <a:rPr lang="en-US" smtClean="0"/>
+              <a:rPr lang="en-US"/>
               <a:t>Second level</a:t>
             </a:r>
           </a:p>
           <a:p>
             <a:pPr lvl="2"/>
             <a:r>
-              <a:rPr lang="en-US" smtClean="0"/>
+              <a:rPr lang="en-US"/>
               <a:t>Third level</a:t>
             </a:r>
           </a:p>
           <a:p>
             <a:pPr lvl="3"/>
             <a:r>
-              <a:rPr lang="en-US" smtClean="0"/>
+              <a:rPr lang="en-US"/>
               <a:t>Fourth level</a:t>
             </a:r>
           </a:p>
           <a:p>
             <a:pPr lvl="4"/>
             <a:r>
-              <a:rPr lang="en-US" smtClean="0"/>
+              <a:rPr lang="en-US"/>
               <a:t>Fifth level</a:t>
             </a:r>
-            <a:endParaRPr lang="en-US"/>
           </a:p>
         </p:txBody>
       </p:sp>
@@ -1484,7 +1272,7 @@
           <a:p>
             <a:fld id="{5BCAD085-E8A6-8845-BD4E-CB4CCA059FC4}" type="datetimeFigureOut">
               <a:rPr lang="en-US" smtClean="0"/>
-              <a:t>1/27/13</a:t>
+              <a:t>10/18/26</a:t>
             </a:fld>
             <a:endParaRPr lang="en-US"/>
           </a:p>
@@ -1578,10 +1366,9 @@
           <a:lstStyle/>
           <a:p>
             <a:r>
-              <a:rPr lang="en-US" smtClean="0"/>
+              <a:rPr lang="en-US"/>
               <a:t>Click to edit Master title style</a:t>
             </a:r>
-            <a:endParaRPr lang="en-US"/>
           </a:p>
         </p:txBody>
       </p:sp>
@@ -1602,38 +1389,37 @@
           <a:p>
             <a:pPr lvl="0"/>
             <a:r>
-              <a:rPr lang="en-US" smtClean="0"/>
+              <a:rPr lang="en-US"/>
               <a:t>Click to edit Master text styles</a:t>
             </a:r>
           </a:p>
           <a:p>
             <a:pPr lvl="1"/>
             <a:r>
-              <a:rPr lang="en-US" smtClean="0"/>
+              <a:rPr lang="en-US"/>
               <a:t>Second level</a:t>
             </a:r>
           </a:p>
           <a:p>
             <a:pPr lvl="2"/>
             <a:r>
-              <a:rPr lang="en-US" smtClean="0"/>
+              <a:rPr lang="en-US"/>
               <a:t>Third level</a:t>
             </a:r>
           </a:p>
           <a:p>
             <a:pPr lvl="3"/>
             <a:r>
-              <a:rPr lang="en-US" smtClean="0"/>
+              <a:rPr lang="en-US"/>
               <a:t>Fourth level</a:t>
             </a:r>
           </a:p>
           <a:p>
             <a:pPr lvl="4"/>
             <a:r>
-              <a:rPr lang="en-US" smtClean="0"/>
+              <a:rPr lang="en-US"/>
               <a:t>Fifth level</a:t>
             </a:r>
-            <a:endParaRPr lang="en-US"/>
           </a:p>
         </p:txBody>
       </p:sp>
@@ -1654,7 +1440,7 @@
           <a:p>
             <a:fld id="{5BCAD085-E8A6-8845-BD4E-CB4CCA059FC4}" type="datetimeFigureOut">
               <a:rPr lang="en-US" smtClean="0"/>
-              <a:t>1/27/13</a:t>
+              <a:t>10/18/26</a:t>
             </a:fld>
             <a:endParaRPr lang="en-US"/>
           </a:p>
@@ -1757,10 +1543,9 @@
           </a:lstStyle>
           <a:p>
             <a:r>
-              <a:rPr lang="en-US" smtClean="0"/>
+              <a:rPr lang="en-US"/>
               <a:t>Click to edit Master title style</a:t>
             </a:r>
-            <a:endParaRPr lang="en-US"/>
           </a:p>
         </p:txBody>
       </p:sp>
@@ -1877,7 +1662,7 @@
           <a:p>
             <a:pPr lvl="0"/>
             <a:r>
-              <a:rPr lang="en-US" smtClean="0"/>
+              <a:rPr lang="en-US"/>
               <a:t>Click to edit Master text styles</a:t>
             </a:r>
           </a:p>
@@ -1900,7 +1685,7 @@
           <a:p>
             <a:fld id="{5BCAD085-E8A6-8845-BD4E-CB4CCA059FC4}" type="datetimeFigureOut">
               <a:rPr lang="en-US" smtClean="0"/>
-              <a:t>1/27/13</a:t>
+              <a:t>10/18/26</a:t>
             </a:fld>
             <a:endParaRPr lang="en-US"/>
           </a:p>
@@ -1994,10 +1779,9 @@
           <a:lstStyle/>
           <a:p>
             <a:r>
-              <a:rPr lang="en-US" smtClean="0"/>
+              <a:rPr lang="en-US"/>
               <a:t>Click to edit Master title style</a:t>
             </a:r>
-            <a:endParaRPr lang="en-US"/>
           </a:p>
         </p:txBody>
       </p:sp>
@@ -2051,38 +1835,37 @@
           <a:p>
             <a:pPr lvl="0"/>
             <a:r>
-              <a:rPr lang="en-US" smtClean="0"/>
+              <a:rPr lang="en-US"/>
               <a:t>Click to edit Master text styles</a:t>
             </a:r>
           </a:p>
           <a:p>
             <a:pPr lvl="1"/>
             <a:r>
-              <a:rPr lang="en-US" smtClean="0"/>
+              <a:rPr lang="en-US"/>
               <a:t>Second level</a:t>
             </a:r>
           </a:p>
           <a:p>
             <a:pPr lvl="2"/>
             <a:r>
-              <a:rPr lang="en-US" smtClean="0"/>
+              <a:rPr lang="en-US"/>
               <a:t>Third level</a:t>
             </a:r>
           </a:p>
           <a:p>
             <a:pPr lvl="3"/>
             <a:r>
-              <a:rPr lang="en-US" smtClean="0"/>
+              <a:rPr lang="en-US"/>
               <a:t>Fourth level</a:t>
             </a:r>
           </a:p>
           <a:p>
             <a:pPr lvl="4"/>
             <a:r>
-              <a:rPr lang="en-US" smtClean="0"/>
+              <a:rPr lang="en-US"/>
               <a:t>Fifth level</a:t>
             </a:r>
-            <a:endParaRPr lang="en-US"/>
           </a:p>
         </p:txBody>
       </p:sp>
@@ -2136,38 +1919,37 @@
           <a:p>
             <a:pPr lvl="0"/>
             <a:r>
-              <a:rPr lang="en-US" smtClean="0"/>
+              <a:rPr lang="en-US"/>
               <a:t>Click to edit Master text styles</a:t>
             </a:r>
           </a:p>
           <a:p>
             <a:pPr lvl="1"/>
             <a:r>
-              <a:rPr lang="en-US" smtClean="0"/>
+              <a:rPr lang="en-US"/>
               <a:t>Second level</a:t>
             </a:r>
           </a:p>
           <a:p>
             <a:pPr lvl="2"/>
             <a:r>
-              <a:rPr lang="en-US" smtClean="0"/>
+              <a:rPr lang="en-US"/>
               <a:t>Third level</a:t>
             </a:r>
           </a:p>
           <a:p>
             <a:pPr lvl="3"/>
             <a:r>
-              <a:rPr lang="en-US" smtClean="0"/>
+              <a:rPr lang="en-US"/>
               <a:t>Fourth level</a:t>
             </a:r>
           </a:p>
           <a:p>
             <a:pPr lvl="4"/>
             <a:r>
-              <a:rPr lang="en-US" smtClean="0"/>
+              <a:rPr lang="en-US"/>
               <a:t>Fifth level</a:t>
             </a:r>
-            <a:endParaRPr lang="en-US"/>
           </a:p>
         </p:txBody>
       </p:sp>
@@ -2188,7 +1970,7 @@
           <a:p>
             <a:fld id="{5BCAD085-E8A6-8845-BD4E-CB4CCA059FC4}" type="datetimeFigureOut">
               <a:rPr lang="en-US" smtClean="0"/>
-              <a:t>1/27/13</a:t>
+              <a:t>10/18/26</a:t>
             </a:fld>
             <a:endParaRPr lang="en-US"/>
           </a:p>
@@ -2286,10 +2068,9 @@
           </a:lstStyle>
           <a:p>
             <a:r>
-              <a:rPr lang="en-US" smtClean="0"/>
+              <a:rPr lang="en-US"/>
               <a:t>Click to edit Master title style</a:t>
             </a:r>
-            <a:endParaRPr lang="en-US"/>
           </a:p>
         </p:txBody>
       </p:sp>
@@ -2352,7 +2133,7 @@
           <a:p>
             <a:pPr lvl="0"/>
             <a:r>
-              <a:rPr lang="en-US" smtClean="0"/>
+              <a:rPr lang="en-US"/>
               <a:t>Click to edit Master text styles</a:t>
             </a:r>
           </a:p>
@@ -2408,38 +2189,37 @@
           <a:p>
             <a:pPr lvl="0"/>
             <a:r>
-              <a:rPr lang="en-US" smtClean="0"/>
+              <a:rPr lang="en-US"/>
               <a:t>Click to edit Master text styles</a:t>
             </a:r>
           </a:p>
           <a:p>
             <a:pPr lvl="1"/>
             <a:r>
-              <a:rPr lang="en-US" smtClean="0"/>
+              <a:rPr lang="en-US"/>
               <a:t>Second level</a:t>
             </a:r>
           </a:p>
           <a:p>
             <a:pPr lvl="2"/>
             <a:r>
-              <a:rPr lang="en-US" smtClean="0"/>
+              <a:rPr lang="en-US"/>
               <a:t>Third level</a:t>
             </a:r>
           </a:p>
           <a:p>
             <a:pPr lvl="3"/>
             <a:r>
-              <a:rPr lang="en-US" smtClean="0"/>
+              <a:rPr lang="en-US"/>
               <a:t>Fourth level</a:t>
             </a:r>
           </a:p>
           <a:p>
             <a:pPr lvl="4"/>
             <a:r>
-              <a:rPr lang="en-US" smtClean="0"/>
+              <a:rPr lang="en-US"/>
               <a:t>Fifth level</a:t>
             </a:r>
-            <a:endParaRPr lang="en-US"/>
           </a:p>
         </p:txBody>
       </p:sp>
@@ -2502,7 +2282,7 @@
           <a:p>
             <a:pPr lvl="0"/>
             <a:r>
-              <a:rPr lang="en-US" smtClean="0"/>
+              <a:rPr lang="en-US"/>
               <a:t>Click to edit Master text styles</a:t>
             </a:r>
           </a:p>
@@ -2558,38 +2338,37 @@
           <a:p>
             <a:pPr lvl="0"/>
             <a:r>
-              <a:rPr lang="en-US" smtClean="0"/>
+              <a:rPr lang="en-US"/>
               <a:t>Click to edit Master text styles</a:t>
             </a:r>
           </a:p>
           <a:p>
             <a:pPr lvl="1"/>
             <a:r>
-              <a:rPr lang="en-US" smtClean="0"/>
+              <a:rPr lang="en-US"/>
               <a:t>Second level</a:t>
             </a:r>
           </a:p>
           <a:p>
             <a:pPr lvl="2"/>
             <a:r>
-              <a:rPr lang="en-US" smtClean="0"/>
+              <a:rPr lang="en-US"/>
               <a:t>Third level</a:t>
             </a:r>
           </a:p>
           <a:p>
             <a:pPr lvl="3"/>
             <a:r>
-              <a:rPr lang="en-US" smtClean="0"/>
+              <a:rPr lang="en-US"/>
               <a:t>Fourth level</a:t>
             </a:r>
           </a:p>
           <a:p>
             <a:pPr lvl="4"/>
             <a:r>
-              <a:rPr lang="en-US" smtClean="0"/>
+              <a:rPr lang="en-US"/>
               <a:t>Fifth level</a:t>
             </a:r>
-            <a:endParaRPr lang="en-US"/>
           </a:p>
         </p:txBody>
       </p:sp>
@@ -2610,7 +2389,7 @@
           <a:p>
             <a:fld id="{5BCAD085-E8A6-8845-BD4E-CB4CCA059FC4}" type="datetimeFigureOut">
               <a:rPr lang="en-US" smtClean="0"/>
-              <a:t>1/27/13</a:t>
+              <a:t>10/18/26</a:t>
             </a:fld>
             <a:endParaRPr lang="en-US"/>
           </a:p>
@@ -2704,10 +2483,9 @@
           <a:lstStyle/>
           <a:p>
             <a:r>
-              <a:rPr lang="en-US" smtClean="0"/>
+              <a:rPr lang="en-US"/>
               <a:t>Click to edit Master title style</a:t>
             </a:r>
-            <a:endParaRPr lang="en-US"/>
           </a:p>
         </p:txBody>
       </p:sp>
@@ -2728,7 +2506,7 @@
           <a:p>
             <a:fld id="{5BCAD085-E8A6-8845-BD4E-CB4CCA059FC4}" type="datetimeFigureOut">
               <a:rPr lang="en-US" smtClean="0"/>
-              <a:t>1/27/13</a:t>
+              <a:t>10/18/26</a:t>
             </a:fld>
             <a:endParaRPr lang="en-US"/>
           </a:p>
@@ -2823,7 +2601,7 @@
           <a:p>
             <a:fld id="{5BCAD085-E8A6-8845-BD4E-CB4CCA059FC4}" type="datetimeFigureOut">
               <a:rPr lang="en-US" smtClean="0"/>
-              <a:t>1/27/13</a:t>
+              <a:t>10/18/26</a:t>
             </a:fld>
             <a:endParaRPr lang="en-US"/>
           </a:p>
@@ -2926,10 +2704,9 @@
           </a:lstStyle>
           <a:p>
             <a:r>
-              <a:rPr lang="en-US" smtClean="0"/>
+              <a:rPr lang="en-US"/>
               <a:t>Click to edit Master title style</a:t>
             </a:r>
-            <a:endParaRPr lang="en-US"/>
           </a:p>
         </p:txBody>
       </p:sp>
@@ -2983,38 +2760,37 @@
           <a:p>
             <a:pPr lvl="0"/>
             <a:r>
-              <a:rPr lang="en-US" smtClean="0"/>
+              <a:rPr lang="en-US"/>
               <a:t>Click to edit Master text styles</a:t>
             </a:r>
           </a:p>
           <a:p>
             <a:pPr lvl="1"/>
             <a:r>
-              <a:rPr lang="en-US" smtClean="0"/>
+              <a:rPr lang="en-US"/>
               <a:t>Second level</a:t>
             </a:r>
           </a:p>
           <a:p>
             <a:pPr lvl="2"/>
             <a:r>
-              <a:rPr lang="en-US" smtClean="0"/>
+              <a:rPr lang="en-US"/>
               <a:t>Third level</a:t>
             </a:r>
           </a:p>
           <a:p>
             <a:pPr lvl="3"/>
             <a:r>
-              <a:rPr lang="en-US" smtClean="0"/>
+              <a:rPr lang="en-US"/>
               <a:t>Fourth level</a:t>
             </a:r>
           </a:p>
           <a:p>
             <a:pPr lvl="4"/>
             <a:r>
-              <a:rPr lang="en-US" smtClean="0"/>
+              <a:rPr lang="en-US"/>
               <a:t>Fifth level</a:t>
             </a:r>
-            <a:endParaRPr lang="en-US"/>
           </a:p>
         </p:txBody>
       </p:sp>
@@ -3077,7 +2853,7 @@
           <a:p>
             <a:pPr lvl="0"/>
             <a:r>
-              <a:rPr lang="en-US" smtClean="0"/>
+              <a:rPr lang="en-US"/>
               <a:t>Click to edit Master text styles</a:t>
             </a:r>
           </a:p>
@@ -3100,7 +2876,7 @@
           <a:p>
             <a:fld id="{5BCAD085-E8A6-8845-BD4E-CB4CCA059FC4}" type="datetimeFigureOut">
               <a:rPr lang="en-US" smtClean="0"/>
-              <a:t>1/27/13</a:t>
+              <a:t>10/18/26</a:t>
             </a:fld>
             <a:endParaRPr lang="en-US"/>
           </a:p>
@@ -3203,10 +2979,9 @@
           </a:lstStyle>
           <a:p>
             <a:r>
-              <a:rPr lang="en-US" smtClean="0"/>
+              <a:rPr lang="en-US"/>
               <a:t>Click to edit Master title style</a:t>
             </a:r>
-            <a:endParaRPr lang="en-US"/>
           </a:p>
         </p:txBody>
       </p:sp>
@@ -3330,7 +3105,7 @@
           <a:p>
             <a:pPr lvl="0"/>
             <a:r>
-              <a:rPr lang="en-US" smtClean="0"/>
+              <a:rPr lang="en-US"/>
               <a:t>Click to edit Master text styles</a:t>
             </a:r>
           </a:p>
@@ -3353,7 +3128,7 @@
           <a:p>
             <a:fld id="{5BCAD085-E8A6-8845-BD4E-CB4CCA059FC4}" type="datetimeFigureOut">
               <a:rPr lang="en-US" smtClean="0"/>
-              <a:t>1/27/13</a:t>
+              <a:t>10/18/26</a:t>
             </a:fld>
             <a:endParaRPr lang="en-US"/>
           </a:p>
@@ -3462,10 +3237,9 @@
           <a:lstStyle/>
           <a:p>
             <a:r>
-              <a:rPr lang="en-US" smtClean="0"/>
+              <a:rPr lang="en-US"/>
               <a:t>Click to edit Master title style</a:t>
             </a:r>
-            <a:endParaRPr lang="en-US"/>
           </a:p>
         </p:txBody>
       </p:sp>
@@ -3496,38 +3270,37 @@
           <a:p>
             <a:pPr lvl="0"/>
             <a:r>
-              <a:rPr lang="en-US" smtClean="0"/>
+              <a:rPr lang="en-US"/>
               <a:t>Click to edit Master text styles</a:t>
             </a:r>
           </a:p>
           <a:p>
             <a:pPr lvl="1"/>
             <a:r>
-              <a:rPr lang="en-US" smtClean="0"/>
+              <a:rPr lang="en-US"/>
               <a:t>Second level</a:t>
             </a:r>
           </a:p>
           <a:p>
             <a:pPr lvl="2"/>
             <a:r>
-              <a:rPr lang="en-US" smtClean="0"/>
+              <a:rPr lang="en-US"/>
               <a:t>Third level</a:t>
             </a:r>
           </a:p>
           <a:p>
             <a:pPr lvl="3"/>
             <a:r>
-              <a:rPr lang="en-US" smtClean="0"/>
+              <a:rPr lang="en-US"/>
               <a:t>Fourth level</a:t>
             </a:r>
           </a:p>
           <a:p>
             <a:pPr lvl="4"/>
             <a:r>
-              <a:rPr lang="en-US" smtClean="0"/>
+              <a:rPr lang="en-US"/>
               <a:t>Fifth level</a:t>
             </a:r>
-            <a:endParaRPr lang="en-US"/>
           </a:p>
         </p:txBody>
       </p:sp>
@@ -3566,7 +3339,7 @@
           <a:p>
             <a:fld id="{5BCAD085-E8A6-8845-BD4E-CB4CCA059FC4}" type="datetimeFigureOut">
               <a:rPr lang="en-US" smtClean="0"/>
-              <a:t>1/27/13</a:t>
+              <a:t>10/18/26</a:t>
             </a:fld>
             <a:endParaRPr lang="en-US"/>
           </a:p>
@@ -3925,7 +3698,7 @@
 </file>
 
 <file path=ppt/slides/slide1.xml><?xml version="1.0" encoding="utf-8"?>
-<p:sld xmlns:a="http://schemas.openxmlformats.org/drawingml/2006/main" xmlns:p="http://schemas.openxmlformats.org/presentationml/2006/main" xmlns:r="http://schemas.openxmlformats.org/officeDocument/2006/relationships">
+<p:sld xmlns:a="http://schemas.openxmlformats.org/drawingml/2006/main" xmlns:r="http://schemas.openxmlformats.org/officeDocument/2006/relationships" xmlns:p="http://schemas.openxmlformats.org/presentationml/2006/main">
   <p:cSld>
     <p:spTree>
       <p:nvGrpSpPr>
@@ -3933,7 +3706,14 @@
         <p:cNvGrpSpPr/>
         <p:nvPr/>
       </p:nvGrpSpPr>
-      <p:grpSpPr/>
+      <p:grpSpPr>
+        <a:xfrm>
+          <a:off x="0" y="0"/>
+          <a:ext cx="0" cy="0"/>
+          <a:chOff x="0" y="0"/>
+          <a:chExt cx="0" cy="0"/>
+        </a:xfrm>
+      </p:grpSpPr>
       <p:sp>
         <p:nvSpPr>
           <p:cNvPr id="2" name="Rectangle 1"/>
@@ -3973,7 +3753,9 @@
         <p:txBody>
           <a:bodyPr rtlCol="0" anchor="ctr"/>
           <a:lstStyle/>
-          <a:p/>
+          <a:p>
+            <a:endParaRPr/>
+          </a:p>
         </p:txBody>
       </p:sp>
       <p:sp>
@@ -4015,7 +3797,9 @@
         <p:txBody>
           <a:bodyPr rtlCol="0" anchor="ctr"/>
           <a:lstStyle/>
-          <a:p/>
+          <a:p>
+            <a:endParaRPr/>
+          </a:p>
         </p:txBody>
       </p:sp>
       <p:sp>
@@ -4035,7 +3819,7 @@
           <a:noFill/>
         </p:spPr>
         <p:txBody>
-          <a:bodyPr wrap="square" lIns="0" rIns="0" tIns="0" bIns="0" anchor="t">
+          <a:bodyPr wrap="square" lIns="0" tIns="0" rIns="0" bIns="0" anchor="t">
             <a:spAutoFit/>
           </a:bodyPr>
           <a:lstStyle/>
@@ -4096,7 +3880,7 @@
           <a:noFill/>
         </p:spPr>
         <p:txBody>
-          <a:bodyPr wrap="square" lIns="0" rIns="0" tIns="0" bIns="0" anchor="t">
+          <a:bodyPr wrap="square" lIns="0" tIns="0" rIns="0" bIns="0" anchor="t">
             <a:spAutoFit/>
           </a:bodyPr>
           <a:lstStyle/>
@@ -4130,7 +3914,7 @@
         <p:spPr>
           <a:xfrm>
             <a:off x="548640" y="4434840"/>
-            <a:ext cx="10972800" cy="1280160"/>
+            <a:ext cx="10972800" cy="901529"/>
           </a:xfrm>
           <a:prstGeom prst="rect">
             <a:avLst/>
@@ -4138,7 +3922,7 @@
           <a:noFill/>
         </p:spPr>
         <p:txBody>
-          <a:bodyPr wrap="square" lIns="0" rIns="0" tIns="0" bIns="0" anchor="t">
+          <a:bodyPr wrap="square" lIns="0" tIns="0" rIns="0" bIns="0" anchor="t">
             <a:spAutoFit/>
           </a:bodyPr>
           <a:lstStyle/>
@@ -4152,7 +3936,7 @@
               </a:spcAft>
             </a:pPr>
             <a:r>
-              <a:rPr sz="1600" b="0" i="0">
+              <a:rPr sz="1600" b="0" i="0" dirty="0">
                 <a:solidFill>
                   <a:srgbClr val="C9D3E0"/>
                 </a:solidFill>
@@ -4171,13 +3955,31 @@
               </a:spcAft>
             </a:pPr>
             <a:r>
-              <a:rPr sz="1600" b="0" i="0">
+              <a:rPr sz="1600" b="0" i="0" dirty="0">
                 <a:solidFill>
                   <a:srgbClr val="C9D3E0"/>
                 </a:solidFill>
                 <a:latin typeface="Calibri"/>
               </a:rPr>
-              <a:t>AAI6680: AI for Cybersecurity · Northeastern University · Mimoza Dimodugno, PhD</a:t>
+              <a:t>AAI6680: AI for Cybersecurity · Northeastern University · Mimoza </a:t>
+            </a:r>
+            <a:r>
+              <a:rPr sz="1600" b="0" i="0" dirty="0" err="1">
+                <a:solidFill>
+                  <a:srgbClr val="C9D3E0"/>
+                </a:solidFill>
+                <a:latin typeface="Calibri"/>
+              </a:rPr>
+              <a:t>Dimodugno</a:t>
+            </a:r>
+            <a:r>
+              <a:rPr sz="1600" b="0" i="0" dirty="0">
+                <a:solidFill>
+                  <a:srgbClr val="C9D3E0"/>
+                </a:solidFill>
+                <a:latin typeface="Calibri"/>
+              </a:rPr>
+              <a:t>, PhD</a:t>
             </a:r>
           </a:p>
           <a:p>
@@ -4196,7 +3998,25 @@
                 </a:solidFill>
                 <a:latin typeface="Calibri"/>
               </a:rPr>
-              <a:t>October 19, 2026</a:t>
+              <a:t>October 1</a:t>
+            </a:r>
+            <a:r>
+              <a:rPr lang="en-US" sz="1600" b="0" i="0">
+                <a:solidFill>
+                  <a:srgbClr val="C9D3E0"/>
+                </a:solidFill>
+                <a:latin typeface="Calibri"/>
+              </a:rPr>
+              <a:t>8</a:t>
+            </a:r>
+            <a:r>
+              <a:rPr sz="1600" b="0" i="0">
+                <a:solidFill>
+                  <a:srgbClr val="C9D3E0"/>
+                </a:solidFill>
+                <a:latin typeface="Calibri"/>
+              </a:rPr>
+              <a:t>, 2026</a:t>
             </a:r>
           </a:p>
         </p:txBody>
@@ -4210,7 +4030,7 @@
 </file>
 
 <file path=ppt/slides/slide2.xml><?xml version="1.0" encoding="utf-8"?>
-<p:sld xmlns:a="http://schemas.openxmlformats.org/drawingml/2006/main" xmlns:p="http://schemas.openxmlformats.org/presentationml/2006/main" xmlns:r="http://schemas.openxmlformats.org/officeDocument/2006/relationships">
+<p:sld xmlns:a="http://schemas.openxmlformats.org/drawingml/2006/main" xmlns:r="http://schemas.openxmlformats.org/officeDocument/2006/relationships" xmlns:p="http://schemas.openxmlformats.org/presentationml/2006/main">
   <p:cSld>
     <p:spTree>
       <p:nvGrpSpPr>
@@ -4218,7 +4038,14 @@
         <p:cNvGrpSpPr/>
         <p:nvPr/>
       </p:nvGrpSpPr>
-      <p:grpSpPr/>
+      <p:grpSpPr>
+        <a:xfrm>
+          <a:off x="0" y="0"/>
+          <a:ext cx="0" cy="0"/>
+          <a:chOff x="0" y="0"/>
+          <a:chExt cx="0" cy="0"/>
+        </a:xfrm>
+      </p:grpSpPr>
       <p:sp>
         <p:nvSpPr>
           <p:cNvPr id="2" name="Rectangle 1"/>
@@ -4258,7 +4085,9 @@
         <p:txBody>
           <a:bodyPr rtlCol="0" anchor="ctr"/>
           <a:lstStyle/>
-          <a:p/>
+          <a:p>
+            <a:endParaRPr/>
+          </a:p>
         </p:txBody>
       </p:sp>
       <p:sp>
@@ -4278,7 +4107,7 @@
           <a:noFill/>
         </p:spPr>
         <p:txBody>
-          <a:bodyPr wrap="square" lIns="0" rIns="0" tIns="0" bIns="0" anchor="t">
+          <a:bodyPr wrap="square" lIns="0" tIns="0" rIns="0" bIns="0" anchor="t">
             <a:spAutoFit/>
           </a:bodyPr>
           <a:lstStyle/>
@@ -4320,7 +4149,7 @@
           <a:noFill/>
         </p:spPr>
         <p:txBody>
-          <a:bodyPr wrap="square" lIns="0" rIns="0" tIns="0" bIns="0" anchor="t">
+          <a:bodyPr wrap="square" lIns="0" tIns="0" rIns="0" bIns="0" anchor="t">
             <a:spAutoFit/>
           </a:bodyPr>
           <a:lstStyle/>
@@ -4386,7 +4215,9 @@
         <p:txBody>
           <a:bodyPr rtlCol="0" anchor="ctr"/>
           <a:lstStyle/>
-          <a:p/>
+          <a:p>
+            <a:endParaRPr/>
+          </a:p>
         </p:txBody>
       </p:sp>
       <p:sp>
@@ -4428,7 +4259,9 @@
         <p:txBody>
           <a:bodyPr rtlCol="0" anchor="ctr"/>
           <a:lstStyle/>
-          <a:p/>
+          <a:p>
+            <a:endParaRPr/>
+          </a:p>
         </p:txBody>
       </p:sp>
       <p:sp>
@@ -4448,7 +4281,7 @@
           <a:noFill/>
         </p:spPr>
         <p:txBody>
-          <a:bodyPr wrap="square" lIns="0" rIns="0" tIns="0" bIns="0" anchor="t">
+          <a:bodyPr wrap="square" lIns="0" tIns="0" rIns="0" bIns="0" anchor="t">
             <a:spAutoFit/>
           </a:bodyPr>
           <a:lstStyle/>
@@ -4490,7 +4323,7 @@
           <a:noFill/>
         </p:spPr>
         <p:txBody>
-          <a:bodyPr wrap="square" lIns="0" rIns="0" tIns="0" bIns="0" anchor="t">
+          <a:bodyPr wrap="square" lIns="0" tIns="0" rIns="0" bIns="0" anchor="t">
             <a:spAutoFit/>
           </a:bodyPr>
           <a:lstStyle/>
@@ -4556,7 +4389,9 @@
         <p:txBody>
           <a:bodyPr rtlCol="0" anchor="ctr"/>
           <a:lstStyle/>
-          <a:p/>
+          <a:p>
+            <a:endParaRPr/>
+          </a:p>
         </p:txBody>
       </p:sp>
       <p:sp>
@@ -4598,7 +4433,9 @@
         <p:txBody>
           <a:bodyPr rtlCol="0" anchor="ctr"/>
           <a:lstStyle/>
-          <a:p/>
+          <a:p>
+            <a:endParaRPr/>
+          </a:p>
         </p:txBody>
       </p:sp>
       <p:sp>
@@ -4618,7 +4455,7 @@
           <a:noFill/>
         </p:spPr>
         <p:txBody>
-          <a:bodyPr wrap="square" lIns="0" rIns="0" tIns="0" bIns="0" anchor="t">
+          <a:bodyPr wrap="square" lIns="0" tIns="0" rIns="0" bIns="0" anchor="t">
             <a:spAutoFit/>
           </a:bodyPr>
           <a:lstStyle/>
@@ -4660,7 +4497,7 @@
           <a:noFill/>
         </p:spPr>
         <p:txBody>
-          <a:bodyPr wrap="square" lIns="0" rIns="0" tIns="0" bIns="0" anchor="t">
+          <a:bodyPr wrap="square" lIns="0" tIns="0" rIns="0" bIns="0" anchor="t">
             <a:spAutoFit/>
           </a:bodyPr>
           <a:lstStyle/>
@@ -4726,7 +4563,9 @@
         <p:txBody>
           <a:bodyPr rtlCol="0" anchor="ctr"/>
           <a:lstStyle/>
-          <a:p/>
+          <a:p>
+            <a:endParaRPr/>
+          </a:p>
         </p:txBody>
       </p:sp>
       <p:sp>
@@ -4768,7 +4607,9 @@
         <p:txBody>
           <a:bodyPr rtlCol="0" anchor="ctr"/>
           <a:lstStyle/>
-          <a:p/>
+          <a:p>
+            <a:endParaRPr/>
+          </a:p>
         </p:txBody>
       </p:sp>
       <p:sp>
@@ -4788,7 +4629,7 @@
           <a:noFill/>
         </p:spPr>
         <p:txBody>
-          <a:bodyPr wrap="square" lIns="0" rIns="0" tIns="0" bIns="0" anchor="t">
+          <a:bodyPr wrap="square" lIns="0" tIns="0" rIns="0" bIns="0" anchor="t">
             <a:spAutoFit/>
           </a:bodyPr>
           <a:lstStyle/>
@@ -4830,7 +4671,7 @@
           <a:noFill/>
         </p:spPr>
         <p:txBody>
-          <a:bodyPr wrap="square" lIns="0" rIns="0" tIns="0" bIns="0" anchor="t">
+          <a:bodyPr wrap="square" lIns="0" tIns="0" rIns="0" bIns="0" anchor="t">
             <a:spAutoFit/>
           </a:bodyPr>
           <a:lstStyle/>
@@ -4896,7 +4737,9 @@
         <p:txBody>
           <a:bodyPr rtlCol="0" anchor="ctr"/>
           <a:lstStyle/>
-          <a:p/>
+          <a:p>
+            <a:endParaRPr/>
+          </a:p>
         </p:txBody>
       </p:sp>
       <p:sp>
@@ -4938,7 +4781,9 @@
         <p:txBody>
           <a:bodyPr rtlCol="0" anchor="ctr"/>
           <a:lstStyle/>
-          <a:p/>
+          <a:p>
+            <a:endParaRPr/>
+          </a:p>
         </p:txBody>
       </p:sp>
       <p:sp>
@@ -4958,7 +4803,7 @@
           <a:noFill/>
         </p:spPr>
         <p:txBody>
-          <a:bodyPr wrap="square" lIns="0" rIns="0" tIns="0" bIns="0" anchor="t">
+          <a:bodyPr wrap="square" lIns="0" tIns="0" rIns="0" bIns="0" anchor="t">
             <a:spAutoFit/>
           </a:bodyPr>
           <a:lstStyle/>
@@ -5000,7 +4845,7 @@
           <a:noFill/>
         </p:spPr>
         <p:txBody>
-          <a:bodyPr wrap="square" lIns="0" rIns="0" tIns="0" bIns="0" anchor="t">
+          <a:bodyPr wrap="square" lIns="0" tIns="0" rIns="0" bIns="0" anchor="t">
             <a:spAutoFit/>
           </a:bodyPr>
           <a:lstStyle/>
@@ -5066,7 +4911,9 @@
         <p:txBody>
           <a:bodyPr rtlCol="0" anchor="ctr"/>
           <a:lstStyle/>
-          <a:p/>
+          <a:p>
+            <a:endParaRPr/>
+          </a:p>
         </p:txBody>
       </p:sp>
       <p:sp>
@@ -5108,7 +4955,9 @@
         <p:txBody>
           <a:bodyPr rtlCol="0" anchor="ctr"/>
           <a:lstStyle/>
-          <a:p/>
+          <a:p>
+            <a:endParaRPr/>
+          </a:p>
         </p:txBody>
       </p:sp>
       <p:sp>
@@ -5128,7 +4977,7 @@
           <a:noFill/>
         </p:spPr>
         <p:txBody>
-          <a:bodyPr wrap="square" lIns="0" rIns="0" tIns="0" bIns="0" anchor="t">
+          <a:bodyPr wrap="square" lIns="0" tIns="0" rIns="0" bIns="0" anchor="t">
             <a:spAutoFit/>
           </a:bodyPr>
           <a:lstStyle/>
@@ -5170,7 +5019,7 @@
           <a:noFill/>
         </p:spPr>
         <p:txBody>
-          <a:bodyPr wrap="square" lIns="0" rIns="0" tIns="0" bIns="0" anchor="t">
+          <a:bodyPr wrap="square" lIns="0" tIns="0" rIns="0" bIns="0" anchor="t">
             <a:spAutoFit/>
           </a:bodyPr>
           <a:lstStyle/>
@@ -5236,7 +5085,9 @@
         <p:txBody>
           <a:bodyPr rtlCol="0" anchor="ctr"/>
           <a:lstStyle/>
-          <a:p/>
+          <a:p>
+            <a:endParaRPr/>
+          </a:p>
         </p:txBody>
       </p:sp>
       <p:sp>
@@ -5278,7 +5129,9 @@
         <p:txBody>
           <a:bodyPr rtlCol="0" anchor="ctr"/>
           <a:lstStyle/>
-          <a:p/>
+          <a:p>
+            <a:endParaRPr/>
+          </a:p>
         </p:txBody>
       </p:sp>
       <p:sp>
@@ -5298,7 +5151,7 @@
           <a:noFill/>
         </p:spPr>
         <p:txBody>
-          <a:bodyPr wrap="square" lIns="0" rIns="0" tIns="0" bIns="0" anchor="t">
+          <a:bodyPr wrap="square" lIns="0" tIns="0" rIns="0" bIns="0" anchor="t">
             <a:spAutoFit/>
           </a:bodyPr>
           <a:lstStyle/>
@@ -5340,7 +5193,7 @@
           <a:noFill/>
         </p:spPr>
         <p:txBody>
-          <a:bodyPr wrap="square" lIns="0" rIns="0" tIns="0" bIns="0" anchor="t">
+          <a:bodyPr wrap="square" lIns="0" tIns="0" rIns="0" bIns="0" anchor="t">
             <a:spAutoFit/>
           </a:bodyPr>
           <a:lstStyle/>
@@ -5406,7 +5259,9 @@
         <p:txBody>
           <a:bodyPr rtlCol="0" anchor="ctr"/>
           <a:lstStyle/>
-          <a:p/>
+          <a:p>
+            <a:endParaRPr/>
+          </a:p>
         </p:txBody>
       </p:sp>
       <p:sp>
@@ -5448,7 +5303,9 @@
         <p:txBody>
           <a:bodyPr rtlCol="0" anchor="ctr"/>
           <a:lstStyle/>
-          <a:p/>
+          <a:p>
+            <a:endParaRPr/>
+          </a:p>
         </p:txBody>
       </p:sp>
       <p:sp>
@@ -5468,7 +5325,7 @@
           <a:noFill/>
         </p:spPr>
         <p:txBody>
-          <a:bodyPr wrap="square" lIns="0" rIns="0" tIns="0" bIns="0" anchor="t">
+          <a:bodyPr wrap="square" lIns="0" tIns="0" rIns="0" bIns="0" anchor="t">
             <a:spAutoFit/>
           </a:bodyPr>
           <a:lstStyle/>
@@ -5510,7 +5367,7 @@
           <a:noFill/>
         </p:spPr>
         <p:txBody>
-          <a:bodyPr wrap="square" lIns="0" rIns="0" tIns="0" bIns="0" anchor="t">
+          <a:bodyPr wrap="square" lIns="0" tIns="0" rIns="0" bIns="0" anchor="t">
             <a:spAutoFit/>
           </a:bodyPr>
           <a:lstStyle/>
@@ -5552,7 +5409,7 @@
           <a:noFill/>
         </p:spPr>
         <p:txBody>
-          <a:bodyPr wrap="square" lIns="0" rIns="0" tIns="0" bIns="0">
+          <a:bodyPr wrap="square" lIns="0" tIns="0" rIns="0" bIns="0">
             <a:spAutoFit/>
           </a:bodyPr>
           <a:lstStyle/>
@@ -5676,7 +5533,7 @@
           <a:noFill/>
         </p:spPr>
         <p:txBody>
-          <a:bodyPr wrap="square" lIns="0" rIns="0" tIns="0" bIns="0" anchor="t">
+          <a:bodyPr wrap="square" lIns="0" tIns="0" rIns="0" bIns="0" anchor="t">
             <a:spAutoFit/>
           </a:bodyPr>
           <a:lstStyle/>
@@ -5718,7 +5575,7 @@
           <a:noFill/>
         </p:spPr>
         <p:txBody>
-          <a:bodyPr wrap="square" lIns="0" rIns="0" tIns="0" bIns="0" anchor="t">
+          <a:bodyPr wrap="square" lIns="0" tIns="0" rIns="0" bIns="0" anchor="t">
             <a:spAutoFit/>
           </a:bodyPr>
           <a:lstStyle/>
@@ -5752,7 +5609,7 @@
 </file>
 
 <file path=ppt/slides/slide3.xml><?xml version="1.0" encoding="utf-8"?>
-<p:sld xmlns:a="http://schemas.openxmlformats.org/drawingml/2006/main" xmlns:p="http://schemas.openxmlformats.org/presentationml/2006/main" xmlns:r="http://schemas.openxmlformats.org/officeDocument/2006/relationships">
+<p:sld xmlns:a="http://schemas.openxmlformats.org/drawingml/2006/main" xmlns:r="http://schemas.openxmlformats.org/officeDocument/2006/relationships" xmlns:p="http://schemas.openxmlformats.org/presentationml/2006/main">
   <p:cSld>
     <p:spTree>
       <p:nvGrpSpPr>
@@ -5760,7 +5617,14 @@
         <p:cNvGrpSpPr/>
         <p:nvPr/>
       </p:nvGrpSpPr>
-      <p:grpSpPr/>
+      <p:grpSpPr>
+        <a:xfrm>
+          <a:off x="0" y="0"/>
+          <a:ext cx="0" cy="0"/>
+          <a:chOff x="0" y="0"/>
+          <a:chExt cx="0" cy="0"/>
+        </a:xfrm>
+      </p:grpSpPr>
       <p:sp>
         <p:nvSpPr>
           <p:cNvPr id="2" name="Rectangle 1"/>
@@ -5800,7 +5664,9 @@
         <p:txBody>
           <a:bodyPr rtlCol="0" anchor="ctr"/>
           <a:lstStyle/>
-          <a:p/>
+          <a:p>
+            <a:endParaRPr/>
+          </a:p>
         </p:txBody>
       </p:sp>
       <p:sp>
@@ -5820,7 +5686,7 @@
           <a:noFill/>
         </p:spPr>
         <p:txBody>
-          <a:bodyPr wrap="square" lIns="0" rIns="0" tIns="0" bIns="0" anchor="t">
+          <a:bodyPr wrap="square" lIns="0" tIns="0" rIns="0" bIns="0" anchor="t">
             <a:spAutoFit/>
           </a:bodyPr>
           <a:lstStyle/>
@@ -5862,7 +5728,7 @@
           <a:noFill/>
         </p:spPr>
         <p:txBody>
-          <a:bodyPr wrap="square" lIns="0" rIns="0" tIns="0" bIns="0" anchor="t">
+          <a:bodyPr wrap="square" lIns="0" tIns="0" rIns="0" bIns="0" anchor="t">
             <a:spAutoFit/>
           </a:bodyPr>
           <a:lstStyle/>
@@ -5928,7 +5794,9 @@
         <p:txBody>
           <a:bodyPr rtlCol="0" anchor="ctr"/>
           <a:lstStyle/>
-          <a:p/>
+          <a:p>
+            <a:endParaRPr/>
+          </a:p>
         </p:txBody>
       </p:sp>
       <p:sp>
@@ -5970,7 +5838,9 @@
         <p:txBody>
           <a:bodyPr rtlCol="0" anchor="ctr"/>
           <a:lstStyle/>
-          <a:p/>
+          <a:p>
+            <a:endParaRPr/>
+          </a:p>
         </p:txBody>
       </p:sp>
       <p:sp>
@@ -5990,7 +5860,7 @@
           <a:noFill/>
         </p:spPr>
         <p:txBody>
-          <a:bodyPr wrap="square" lIns="0" rIns="0" tIns="0" bIns="0" anchor="t">
+          <a:bodyPr wrap="square" lIns="0" tIns="0" rIns="0" bIns="0" anchor="t">
             <a:spAutoFit/>
           </a:bodyPr>
           <a:lstStyle/>
@@ -6032,7 +5902,7 @@
           <a:noFill/>
         </p:spPr>
         <p:txBody>
-          <a:bodyPr wrap="square" lIns="0" rIns="0" tIns="0" bIns="0" anchor="t">
+          <a:bodyPr wrap="square" lIns="0" tIns="0" rIns="0" bIns="0" anchor="t">
             <a:spAutoFit/>
           </a:bodyPr>
           <a:lstStyle/>
@@ -6074,7 +5944,7 @@
           <a:noFill/>
         </p:spPr>
         <p:txBody>
-          <a:bodyPr wrap="square" lIns="0" rIns="0" tIns="0" bIns="0" anchor="t">
+          <a:bodyPr wrap="square" lIns="0" tIns="0" rIns="0" bIns="0" anchor="t">
             <a:spAutoFit/>
           </a:bodyPr>
           <a:lstStyle/>
@@ -6205,7 +6075,9 @@
         <p:txBody>
           <a:bodyPr rtlCol="0" anchor="ctr"/>
           <a:lstStyle/>
-          <a:p/>
+          <a:p>
+            <a:endParaRPr/>
+          </a:p>
         </p:txBody>
       </p:sp>
       <p:sp>
@@ -6247,7 +6119,9 @@
         <p:txBody>
           <a:bodyPr rtlCol="0" anchor="ctr"/>
           <a:lstStyle/>
-          <a:p/>
+          <a:p>
+            <a:endParaRPr/>
+          </a:p>
         </p:txBody>
       </p:sp>
       <p:sp>
@@ -6267,7 +6141,7 @@
           <a:noFill/>
         </p:spPr>
         <p:txBody>
-          <a:bodyPr wrap="square" lIns="0" rIns="0" tIns="0" bIns="0" anchor="t">
+          <a:bodyPr wrap="square" lIns="0" tIns="0" rIns="0" bIns="0" anchor="t">
             <a:spAutoFit/>
           </a:bodyPr>
           <a:lstStyle/>
@@ -6309,7 +6183,7 @@
           <a:noFill/>
         </p:spPr>
         <p:txBody>
-          <a:bodyPr wrap="square" lIns="0" rIns="0" tIns="0" bIns="0" anchor="t">
+          <a:bodyPr wrap="square" lIns="0" tIns="0" rIns="0" bIns="0" anchor="t">
             <a:spAutoFit/>
           </a:bodyPr>
           <a:lstStyle/>
@@ -6351,7 +6225,7 @@
           <a:noFill/>
         </p:spPr>
         <p:txBody>
-          <a:bodyPr wrap="square" lIns="0" rIns="0" tIns="0" bIns="0" anchor="t">
+          <a:bodyPr wrap="square" lIns="0" tIns="0" rIns="0" bIns="0" anchor="t">
             <a:spAutoFit/>
           </a:bodyPr>
           <a:lstStyle/>
@@ -6500,7 +6374,9 @@
         <p:txBody>
           <a:bodyPr rtlCol="0" anchor="ctr"/>
           <a:lstStyle/>
-          <a:p/>
+          <a:p>
+            <a:endParaRPr/>
+          </a:p>
         </p:txBody>
       </p:sp>
       <p:sp>
@@ -6542,7 +6418,9 @@
         <p:txBody>
           <a:bodyPr rtlCol="0" anchor="ctr"/>
           <a:lstStyle/>
-          <a:p/>
+          <a:p>
+            <a:endParaRPr/>
+          </a:p>
         </p:txBody>
       </p:sp>
       <p:sp>
@@ -6562,7 +6440,7 @@
           <a:noFill/>
         </p:spPr>
         <p:txBody>
-          <a:bodyPr wrap="square" lIns="0" rIns="0" tIns="0" bIns="0" anchor="t">
+          <a:bodyPr wrap="square" lIns="0" tIns="0" rIns="0" bIns="0" anchor="t">
             <a:spAutoFit/>
           </a:bodyPr>
           <a:lstStyle/>
@@ -6604,7 +6482,7 @@
           <a:noFill/>
         </p:spPr>
         <p:txBody>
-          <a:bodyPr wrap="square" lIns="0" rIns="0" tIns="0" bIns="0" anchor="t">
+          <a:bodyPr wrap="square" lIns="0" tIns="0" rIns="0" bIns="0" anchor="t">
             <a:spAutoFit/>
           </a:bodyPr>
           <a:lstStyle/>
@@ -6646,7 +6524,7 @@
           <a:noFill/>
         </p:spPr>
         <p:txBody>
-          <a:bodyPr wrap="square" lIns="0" rIns="0" tIns="0" bIns="0" anchor="t">
+          <a:bodyPr wrap="square" lIns="0" tIns="0" rIns="0" bIns="0" anchor="t">
             <a:spAutoFit/>
           </a:bodyPr>
           <a:lstStyle/>
@@ -6771,7 +6649,7 @@
           <a:noFill/>
         </p:spPr>
         <p:txBody>
-          <a:bodyPr wrap="square" lIns="0" rIns="0" tIns="0" bIns="0" anchor="t">
+          <a:bodyPr wrap="square" lIns="0" tIns="0" rIns="0" bIns="0" anchor="t">
             <a:spAutoFit/>
           </a:bodyPr>
           <a:lstStyle/>
@@ -6813,7 +6691,7 @@
           <a:noFill/>
         </p:spPr>
         <p:txBody>
-          <a:bodyPr wrap="square" lIns="0" rIns="0" tIns="0" bIns="0" anchor="t">
+          <a:bodyPr wrap="square" lIns="0" tIns="0" rIns="0" bIns="0" anchor="t">
             <a:spAutoFit/>
           </a:bodyPr>
           <a:lstStyle/>
@@ -6890,7 +6768,7 @@
           <a:noFill/>
         </p:spPr>
         <p:txBody>
-          <a:bodyPr wrap="square" lIns="0" rIns="0" tIns="0" bIns="0" anchor="t">
+          <a:bodyPr wrap="square" lIns="0" tIns="0" rIns="0" bIns="0" anchor="t">
             <a:spAutoFit/>
           </a:bodyPr>
           <a:lstStyle/>
@@ -6932,7 +6810,7 @@
           <a:noFill/>
         </p:spPr>
         <p:txBody>
-          <a:bodyPr wrap="square" lIns="0" rIns="0" tIns="0" bIns="0" anchor="t">
+          <a:bodyPr wrap="square" lIns="0" tIns="0" rIns="0" bIns="0" anchor="t">
             <a:spAutoFit/>
           </a:bodyPr>
           <a:lstStyle/>
@@ -6966,7 +6844,7 @@
 </file>
 
 <file path=ppt/slides/slide4.xml><?xml version="1.0" encoding="utf-8"?>
-<p:sld xmlns:a="http://schemas.openxmlformats.org/drawingml/2006/main" xmlns:p="http://schemas.openxmlformats.org/presentationml/2006/main" xmlns:r="http://schemas.openxmlformats.org/officeDocument/2006/relationships">
+<p:sld xmlns:a="http://schemas.openxmlformats.org/drawingml/2006/main" xmlns:r="http://schemas.openxmlformats.org/officeDocument/2006/relationships" xmlns:p="http://schemas.openxmlformats.org/presentationml/2006/main">
   <p:cSld>
     <p:spTree>
       <p:nvGrpSpPr>
@@ -6974,7 +6852,14 @@
         <p:cNvGrpSpPr/>
         <p:nvPr/>
       </p:nvGrpSpPr>
-      <p:grpSpPr/>
+      <p:grpSpPr>
+        <a:xfrm>
+          <a:off x="0" y="0"/>
+          <a:ext cx="0" cy="0"/>
+          <a:chOff x="0" y="0"/>
+          <a:chExt cx="0" cy="0"/>
+        </a:xfrm>
+      </p:grpSpPr>
       <p:sp>
         <p:nvSpPr>
           <p:cNvPr id="2" name="Rectangle 1"/>
@@ -7014,7 +6899,9 @@
         <p:txBody>
           <a:bodyPr rtlCol="0" anchor="ctr"/>
           <a:lstStyle/>
-          <a:p/>
+          <a:p>
+            <a:endParaRPr/>
+          </a:p>
         </p:txBody>
       </p:sp>
       <p:sp>
@@ -7034,7 +6921,7 @@
           <a:noFill/>
         </p:spPr>
         <p:txBody>
-          <a:bodyPr wrap="square" lIns="0" rIns="0" tIns="0" bIns="0" anchor="t">
+          <a:bodyPr wrap="square" lIns="0" tIns="0" rIns="0" bIns="0" anchor="t">
             <a:spAutoFit/>
           </a:bodyPr>
           <a:lstStyle/>
@@ -7076,7 +6963,7 @@
           <a:noFill/>
         </p:spPr>
         <p:txBody>
-          <a:bodyPr wrap="square" lIns="0" rIns="0" tIns="0" bIns="0" anchor="t">
+          <a:bodyPr wrap="square" lIns="0" tIns="0" rIns="0" bIns="0" anchor="t">
             <a:spAutoFit/>
           </a:bodyPr>
           <a:lstStyle/>
@@ -7142,7 +7029,9 @@
         <p:txBody>
           <a:bodyPr rtlCol="0" anchor="ctr"/>
           <a:lstStyle/>
-          <a:p/>
+          <a:p>
+            <a:endParaRPr/>
+          </a:p>
         </p:txBody>
       </p:sp>
       <p:sp>
@@ -7184,7 +7073,9 @@
         <p:txBody>
           <a:bodyPr rtlCol="0" anchor="ctr"/>
           <a:lstStyle/>
-          <a:p/>
+          <a:p>
+            <a:endParaRPr/>
+          </a:p>
         </p:txBody>
       </p:sp>
       <p:sp>
@@ -7204,7 +7095,7 @@
           <a:noFill/>
         </p:spPr>
         <p:txBody>
-          <a:bodyPr wrap="square" lIns="0" rIns="0" tIns="0" bIns="0" anchor="t">
+          <a:bodyPr wrap="square" lIns="0" tIns="0" rIns="0" bIns="0" anchor="t">
             <a:spAutoFit/>
           </a:bodyPr>
           <a:lstStyle/>
@@ -7246,7 +7137,7 @@
           <a:noFill/>
         </p:spPr>
         <p:txBody>
-          <a:bodyPr wrap="square" lIns="0" rIns="0" tIns="0" bIns="0" anchor="t">
+          <a:bodyPr wrap="square" lIns="0" tIns="0" rIns="0" bIns="0" anchor="t">
             <a:spAutoFit/>
           </a:bodyPr>
           <a:lstStyle/>
@@ -7288,7 +7179,7 @@
           <a:noFill/>
         </p:spPr>
         <p:txBody>
-          <a:bodyPr wrap="square" lIns="0" rIns="0" tIns="0" bIns="0" anchor="t">
+          <a:bodyPr wrap="square" lIns="0" tIns="0" rIns="0" bIns="0" anchor="t">
             <a:spAutoFit/>
           </a:bodyPr>
           <a:lstStyle/>
@@ -7391,7 +7282,9 @@
         <p:txBody>
           <a:bodyPr rtlCol="0" anchor="ctr"/>
           <a:lstStyle/>
-          <a:p/>
+          <a:p>
+            <a:endParaRPr/>
+          </a:p>
         </p:txBody>
       </p:sp>
       <p:sp>
@@ -7433,7 +7326,9 @@
         <p:txBody>
           <a:bodyPr rtlCol="0" anchor="ctr"/>
           <a:lstStyle/>
-          <a:p/>
+          <a:p>
+            <a:endParaRPr/>
+          </a:p>
         </p:txBody>
       </p:sp>
       <p:sp>
@@ -7453,7 +7348,7 @@
           <a:noFill/>
         </p:spPr>
         <p:txBody>
-          <a:bodyPr wrap="square" lIns="0" rIns="0" tIns="0" bIns="0" anchor="t">
+          <a:bodyPr wrap="square" lIns="0" tIns="0" rIns="0" bIns="0" anchor="t">
             <a:spAutoFit/>
           </a:bodyPr>
           <a:lstStyle/>
@@ -7495,7 +7390,7 @@
           <a:noFill/>
         </p:spPr>
         <p:txBody>
-          <a:bodyPr wrap="square" lIns="0" rIns="0" tIns="0" bIns="0" anchor="t">
+          <a:bodyPr wrap="square" lIns="0" tIns="0" rIns="0" bIns="0" anchor="t">
             <a:spAutoFit/>
           </a:bodyPr>
           <a:lstStyle/>
@@ -7537,7 +7432,7 @@
           <a:noFill/>
         </p:spPr>
         <p:txBody>
-          <a:bodyPr wrap="square" lIns="0" rIns="0" tIns="0" bIns="0" anchor="t">
+          <a:bodyPr wrap="square" lIns="0" tIns="0" rIns="0" bIns="0" anchor="t">
             <a:spAutoFit/>
           </a:bodyPr>
           <a:lstStyle/>
@@ -7622,7 +7517,9 @@
         <p:txBody>
           <a:bodyPr rtlCol="0" anchor="ctr"/>
           <a:lstStyle/>
-          <a:p/>
+          <a:p>
+            <a:endParaRPr/>
+          </a:p>
         </p:txBody>
       </p:sp>
       <p:sp>
@@ -7664,7 +7561,9 @@
         <p:txBody>
           <a:bodyPr rtlCol="0" anchor="ctr"/>
           <a:lstStyle/>
-          <a:p/>
+          <a:p>
+            <a:endParaRPr/>
+          </a:p>
         </p:txBody>
       </p:sp>
       <p:sp>
@@ -7684,7 +7583,7 @@
           <a:noFill/>
         </p:spPr>
         <p:txBody>
-          <a:bodyPr wrap="square" lIns="0" rIns="0" tIns="0" bIns="0" anchor="t">
+          <a:bodyPr wrap="square" lIns="0" tIns="0" rIns="0" bIns="0" anchor="t">
             <a:spAutoFit/>
           </a:bodyPr>
           <a:lstStyle/>
@@ -7726,7 +7625,7 @@
           <a:noFill/>
         </p:spPr>
         <p:txBody>
-          <a:bodyPr wrap="square" lIns="0" rIns="0" tIns="0" bIns="0" anchor="t">
+          <a:bodyPr wrap="square" lIns="0" tIns="0" rIns="0" bIns="0" anchor="t">
             <a:spAutoFit/>
           </a:bodyPr>
           <a:lstStyle/>
@@ -7768,7 +7667,7 @@
           <a:noFill/>
         </p:spPr>
         <p:txBody>
-          <a:bodyPr wrap="square" lIns="0" rIns="0" tIns="0" bIns="0" anchor="t">
+          <a:bodyPr wrap="square" lIns="0" tIns="0" rIns="0" bIns="0" anchor="t">
             <a:spAutoFit/>
           </a:bodyPr>
           <a:lstStyle/>
@@ -7865,7 +7764,7 @@
           <a:noFill/>
         </p:spPr>
         <p:txBody>
-          <a:bodyPr wrap="square" lIns="0" rIns="0" tIns="0" bIns="0" anchor="t">
+          <a:bodyPr wrap="square" lIns="0" tIns="0" rIns="0" bIns="0" anchor="t">
             <a:spAutoFit/>
           </a:bodyPr>
           <a:lstStyle/>
@@ -7907,7 +7806,7 @@
           <a:noFill/>
         </p:spPr>
         <p:txBody>
-          <a:bodyPr wrap="square" lIns="0" rIns="0" tIns="0" bIns="0" anchor="t">
+          <a:bodyPr wrap="square" lIns="0" tIns="0" rIns="0" bIns="0" anchor="t">
             <a:spAutoFit/>
           </a:bodyPr>
           <a:lstStyle/>
@@ -7949,7 +7848,7 @@
           <a:noFill/>
         </p:spPr>
         <p:txBody>
-          <a:bodyPr wrap="square" lIns="0" rIns="0" tIns="0" bIns="0" anchor="t">
+          <a:bodyPr wrap="square" lIns="0" tIns="0" rIns="0" bIns="0" anchor="t">
             <a:spAutoFit/>
           </a:bodyPr>
           <a:lstStyle/>
@@ -7991,7 +7890,7 @@
           <a:noFill/>
         </p:spPr>
         <p:txBody>
-          <a:bodyPr wrap="square" lIns="0" rIns="0" tIns="0" bIns="0" anchor="t">
+          <a:bodyPr wrap="square" lIns="0" tIns="0" rIns="0" bIns="0" anchor="t">
             <a:spAutoFit/>
           </a:bodyPr>
           <a:lstStyle/>
@@ -8077,7 +7976,7 @@
           <a:noFill/>
         </p:spPr>
         <p:txBody>
-          <a:bodyPr wrap="square" lIns="0" rIns="0" tIns="0" bIns="0" anchor="t">
+          <a:bodyPr wrap="square" lIns="0" tIns="0" rIns="0" bIns="0" anchor="t">
             <a:spAutoFit/>
           </a:bodyPr>
           <a:lstStyle/>
@@ -8119,7 +8018,7 @@
           <a:noFill/>
         </p:spPr>
         <p:txBody>
-          <a:bodyPr wrap="square" lIns="0" rIns="0" tIns="0" bIns="0" anchor="t">
+          <a:bodyPr wrap="square" lIns="0" tIns="0" rIns="0" bIns="0" anchor="t">
             <a:spAutoFit/>
           </a:bodyPr>
           <a:lstStyle/>
@@ -8153,7 +8052,7 @@
 </file>
 
 <file path=ppt/slides/slide5.xml><?xml version="1.0" encoding="utf-8"?>
-<p:sld xmlns:a="http://schemas.openxmlformats.org/drawingml/2006/main" xmlns:p="http://schemas.openxmlformats.org/presentationml/2006/main" xmlns:r="http://schemas.openxmlformats.org/officeDocument/2006/relationships">
+<p:sld xmlns:a="http://schemas.openxmlformats.org/drawingml/2006/main" xmlns:r="http://schemas.openxmlformats.org/officeDocument/2006/relationships" xmlns:p="http://schemas.openxmlformats.org/presentationml/2006/main">
   <p:cSld>
     <p:spTree>
       <p:nvGrpSpPr>
@@ -8161,7 +8060,14 @@
         <p:cNvGrpSpPr/>
         <p:nvPr/>
       </p:nvGrpSpPr>
-      <p:grpSpPr/>
+      <p:grpSpPr>
+        <a:xfrm>
+          <a:off x="0" y="0"/>
+          <a:ext cx="0" cy="0"/>
+          <a:chOff x="0" y="0"/>
+          <a:chExt cx="0" cy="0"/>
+        </a:xfrm>
+      </p:grpSpPr>
       <p:sp>
         <p:nvSpPr>
           <p:cNvPr id="2" name="Rectangle 1"/>
@@ -8201,7 +8107,9 @@
         <p:txBody>
           <a:bodyPr rtlCol="0" anchor="ctr"/>
           <a:lstStyle/>
-          <a:p/>
+          <a:p>
+            <a:endParaRPr/>
+          </a:p>
         </p:txBody>
       </p:sp>
       <p:sp>
@@ -8221,7 +8129,7 @@
           <a:noFill/>
         </p:spPr>
         <p:txBody>
-          <a:bodyPr wrap="square" lIns="0" rIns="0" tIns="0" bIns="0" anchor="t">
+          <a:bodyPr wrap="square" lIns="0" tIns="0" rIns="0" bIns="0" anchor="t">
             <a:spAutoFit/>
           </a:bodyPr>
           <a:lstStyle/>
@@ -8263,7 +8171,7 @@
           <a:noFill/>
         </p:spPr>
         <p:txBody>
-          <a:bodyPr wrap="square" lIns="0" rIns="0" tIns="0" bIns="0" anchor="t">
+          <a:bodyPr wrap="square" lIns="0" tIns="0" rIns="0" bIns="0" anchor="t">
             <a:spAutoFit/>
           </a:bodyPr>
           <a:lstStyle/>
@@ -8327,7 +8235,9 @@
         <p:txBody>
           <a:bodyPr rtlCol="0" anchor="ctr"/>
           <a:lstStyle/>
-          <a:p/>
+          <a:p>
+            <a:endParaRPr/>
+          </a:p>
         </p:txBody>
       </p:sp>
       <p:sp>
@@ -8347,7 +8257,7 @@
           <a:noFill/>
         </p:spPr>
         <p:txBody>
-          <a:bodyPr wrap="square" lIns="0" rIns="0" tIns="0" bIns="0" anchor="ctr">
+          <a:bodyPr wrap="square" lIns="0" tIns="0" rIns="0" bIns="0" anchor="ctr">
             <a:spAutoFit/>
           </a:bodyPr>
           <a:lstStyle/>
@@ -8389,7 +8299,7 @@
           <a:noFill/>
         </p:spPr>
         <p:txBody>
-          <a:bodyPr wrap="square" lIns="0" rIns="0" tIns="0" bIns="0" anchor="ctr">
+          <a:bodyPr wrap="square" lIns="0" tIns="0" rIns="0" bIns="0" anchor="ctr">
             <a:spAutoFit/>
           </a:bodyPr>
           <a:lstStyle/>
@@ -8431,7 +8341,7 @@
           <a:noFill/>
         </p:spPr>
         <p:txBody>
-          <a:bodyPr wrap="square" lIns="0" rIns="0" tIns="0" bIns="0" anchor="ctr">
+          <a:bodyPr wrap="square" lIns="0" tIns="0" rIns="0" bIns="0" anchor="ctr">
             <a:spAutoFit/>
           </a:bodyPr>
           <a:lstStyle/>
@@ -8473,7 +8383,7 @@
           <a:noFill/>
         </p:spPr>
         <p:txBody>
-          <a:bodyPr wrap="square" lIns="0" rIns="0" tIns="0" bIns="0" anchor="ctr">
+          <a:bodyPr wrap="square" lIns="0" tIns="0" rIns="0" bIns="0" anchor="ctr">
             <a:spAutoFit/>
           </a:bodyPr>
           <a:lstStyle/>
@@ -8515,7 +8425,7 @@
           <a:noFill/>
         </p:spPr>
         <p:txBody>
-          <a:bodyPr wrap="square" lIns="0" rIns="0" tIns="0" bIns="0" anchor="ctr">
+          <a:bodyPr wrap="square" lIns="0" tIns="0" rIns="0" bIns="0" anchor="ctr">
             <a:spAutoFit/>
           </a:bodyPr>
           <a:lstStyle/>
@@ -8557,7 +8467,7 @@
           <a:noFill/>
         </p:spPr>
         <p:txBody>
-          <a:bodyPr wrap="square" lIns="0" rIns="0" tIns="0" bIns="0" anchor="ctr">
+          <a:bodyPr wrap="square" lIns="0" tIns="0" rIns="0" bIns="0" anchor="ctr">
             <a:spAutoFit/>
           </a:bodyPr>
           <a:lstStyle/>
@@ -8599,7 +8509,7 @@
           <a:noFill/>
         </p:spPr>
         <p:txBody>
-          <a:bodyPr wrap="square" lIns="0" rIns="0" tIns="0" bIns="0" anchor="ctr">
+          <a:bodyPr wrap="square" lIns="0" tIns="0" rIns="0" bIns="0" anchor="ctr">
             <a:spAutoFit/>
           </a:bodyPr>
           <a:lstStyle/>
@@ -8663,7 +8573,9 @@
         <p:txBody>
           <a:bodyPr rtlCol="0" anchor="ctr"/>
           <a:lstStyle/>
-          <a:p/>
+          <a:p>
+            <a:endParaRPr/>
+          </a:p>
         </p:txBody>
       </p:sp>
       <p:sp>
@@ -8683,7 +8595,7 @@
           <a:noFill/>
         </p:spPr>
         <p:txBody>
-          <a:bodyPr wrap="square" lIns="0" rIns="0" tIns="0" bIns="0" anchor="ctr">
+          <a:bodyPr wrap="square" lIns="0" tIns="0" rIns="0" bIns="0" anchor="ctr">
             <a:spAutoFit/>
           </a:bodyPr>
           <a:lstStyle/>
@@ -8725,7 +8637,7 @@
           <a:noFill/>
         </p:spPr>
         <p:txBody>
-          <a:bodyPr wrap="square" lIns="0" rIns="0" tIns="0" bIns="0" anchor="ctr">
+          <a:bodyPr wrap="square" lIns="0" tIns="0" rIns="0" bIns="0" anchor="ctr">
             <a:spAutoFit/>
           </a:bodyPr>
           <a:lstStyle/>
@@ -8791,6 +8703,7 @@
           <a:lstStyle/>
           <a:p>
             <a:pPr algn="ctr"/>
+            <a:endParaRPr/>
           </a:p>
         </p:txBody>
       </p:sp>
@@ -8837,6 +8750,7 @@
           <a:lstStyle/>
           <a:p>
             <a:pPr algn="ctr"/>
+            <a:endParaRPr/>
           </a:p>
         </p:txBody>
       </p:sp>
@@ -8881,6 +8795,7 @@
           <a:lstStyle/>
           <a:p>
             <a:pPr algn="ctr"/>
+            <a:endParaRPr/>
           </a:p>
         </p:txBody>
       </p:sp>
@@ -8927,6 +8842,7 @@
           <a:lstStyle/>
           <a:p>
             <a:pPr algn="ctr"/>
+            <a:endParaRPr/>
           </a:p>
         </p:txBody>
       </p:sp>
@@ -8969,7 +8885,9 @@
         <p:txBody>
           <a:bodyPr rtlCol="0" anchor="ctr"/>
           <a:lstStyle/>
-          <a:p/>
+          <a:p>
+            <a:endParaRPr/>
+          </a:p>
         </p:txBody>
       </p:sp>
       <p:sp>
@@ -8989,7 +8907,7 @@
           <a:noFill/>
         </p:spPr>
         <p:txBody>
-          <a:bodyPr wrap="square" lIns="0" rIns="0" tIns="0" bIns="0" anchor="ctr">
+          <a:bodyPr wrap="square" lIns="0" tIns="0" rIns="0" bIns="0" anchor="ctr">
             <a:spAutoFit/>
           </a:bodyPr>
           <a:lstStyle/>
@@ -9031,7 +8949,7 @@
           <a:noFill/>
         </p:spPr>
         <p:txBody>
-          <a:bodyPr wrap="square" lIns="0" rIns="0" tIns="0" bIns="0" anchor="ctr">
+          <a:bodyPr wrap="square" lIns="0" tIns="0" rIns="0" bIns="0" anchor="ctr">
             <a:spAutoFit/>
           </a:bodyPr>
           <a:lstStyle/>
@@ -9097,6 +9015,7 @@
           <a:lstStyle/>
           <a:p>
             <a:pPr algn="ctr"/>
+            <a:endParaRPr/>
           </a:p>
         </p:txBody>
       </p:sp>
@@ -9143,6 +9062,7 @@
           <a:lstStyle/>
           <a:p>
             <a:pPr algn="ctr"/>
+            <a:endParaRPr/>
           </a:p>
         </p:txBody>
       </p:sp>
@@ -9185,7 +9105,9 @@
         <p:txBody>
           <a:bodyPr rtlCol="0" anchor="ctr"/>
           <a:lstStyle/>
-          <a:p/>
+          <a:p>
+            <a:endParaRPr/>
+          </a:p>
         </p:txBody>
       </p:sp>
       <p:sp>
@@ -9231,6 +9153,7 @@
           <a:lstStyle/>
           <a:p>
             <a:pPr algn="ctr"/>
+            <a:endParaRPr/>
           </a:p>
         </p:txBody>
       </p:sp>
@@ -9275,6 +9198,7 @@
           <a:lstStyle/>
           <a:p>
             <a:pPr algn="ctr"/>
+            <a:endParaRPr/>
           </a:p>
         </p:txBody>
       </p:sp>
@@ -9317,7 +9241,9 @@
         <p:txBody>
           <a:bodyPr rtlCol="0" anchor="ctr"/>
           <a:lstStyle/>
-          <a:p/>
+          <a:p>
+            <a:endParaRPr/>
+          </a:p>
         </p:txBody>
       </p:sp>
       <p:sp>
@@ -9337,7 +9263,7 @@
           <a:noFill/>
         </p:spPr>
         <p:txBody>
-          <a:bodyPr wrap="square" lIns="0" rIns="0" tIns="0" bIns="0" anchor="ctr">
+          <a:bodyPr wrap="square" lIns="0" tIns="0" rIns="0" bIns="0" anchor="ctr">
             <a:spAutoFit/>
           </a:bodyPr>
           <a:lstStyle/>
@@ -9379,7 +9305,7 @@
           <a:noFill/>
         </p:spPr>
         <p:txBody>
-          <a:bodyPr wrap="square" lIns="0" rIns="0" tIns="0" bIns="0" anchor="ctr">
+          <a:bodyPr wrap="square" lIns="0" tIns="0" rIns="0" bIns="0" anchor="ctr">
             <a:spAutoFit/>
           </a:bodyPr>
           <a:lstStyle/>
@@ -9447,6 +9373,7 @@
           <a:lstStyle/>
           <a:p>
             <a:pPr algn="ctr"/>
+            <a:endParaRPr/>
           </a:p>
         </p:txBody>
       </p:sp>
@@ -9493,6 +9420,7 @@
           <a:lstStyle/>
           <a:p>
             <a:pPr algn="ctr"/>
+            <a:endParaRPr/>
           </a:p>
         </p:txBody>
       </p:sp>
@@ -9539,6 +9467,7 @@
           <a:lstStyle/>
           <a:p>
             <a:pPr algn="ctr"/>
+            <a:endParaRPr/>
           </a:p>
         </p:txBody>
       </p:sp>
@@ -9583,6 +9512,7 @@
           <a:lstStyle/>
           <a:p>
             <a:pPr algn="ctr"/>
+            <a:endParaRPr/>
           </a:p>
         </p:txBody>
       </p:sp>
@@ -9629,6 +9559,7 @@
           <a:lstStyle/>
           <a:p>
             <a:pPr algn="ctr"/>
+            <a:endParaRPr/>
           </a:p>
         </p:txBody>
       </p:sp>
@@ -9649,7 +9580,7 @@
           <a:noFill/>
         </p:spPr>
         <p:txBody>
-          <a:bodyPr wrap="square" lIns="0" rIns="0" tIns="0" bIns="0" anchor="ctr">
+          <a:bodyPr wrap="square" lIns="0" tIns="0" rIns="0" bIns="0" anchor="ctr">
             <a:spAutoFit/>
           </a:bodyPr>
           <a:lstStyle/>
@@ -9691,7 +9622,7 @@
           <a:noFill/>
         </p:spPr>
         <p:txBody>
-          <a:bodyPr wrap="square" lIns="0" rIns="0" tIns="0" bIns="0" anchor="ctr">
+          <a:bodyPr wrap="square" lIns="0" tIns="0" rIns="0" bIns="0" anchor="ctr">
             <a:spAutoFit/>
           </a:bodyPr>
           <a:lstStyle/>
@@ -9755,7 +9686,9 @@
         <p:txBody>
           <a:bodyPr rtlCol="0" anchor="ctr"/>
           <a:lstStyle/>
-          <a:p/>
+          <a:p>
+            <a:endParaRPr/>
+          </a:p>
         </p:txBody>
       </p:sp>
       <p:sp>
@@ -9799,6 +9732,7 @@
           <a:lstStyle/>
           <a:p>
             <a:pPr algn="ctr"/>
+            <a:endParaRPr/>
           </a:p>
         </p:txBody>
       </p:sp>
@@ -9843,6 +9777,7 @@
           <a:lstStyle/>
           <a:p>
             <a:pPr algn="ctr"/>
+            <a:endParaRPr/>
           </a:p>
         </p:txBody>
       </p:sp>
@@ -9887,6 +9822,7 @@
           <a:lstStyle/>
           <a:p>
             <a:pPr algn="ctr"/>
+            <a:endParaRPr/>
           </a:p>
         </p:txBody>
       </p:sp>
@@ -9933,6 +9869,7 @@
           <a:lstStyle/>
           <a:p>
             <a:pPr algn="ctr"/>
+            <a:endParaRPr/>
           </a:p>
         </p:txBody>
       </p:sp>
@@ -9979,6 +9916,7 @@
           <a:lstStyle/>
           <a:p>
             <a:pPr algn="ctr"/>
+            <a:endParaRPr/>
           </a:p>
         </p:txBody>
       </p:sp>
@@ -9999,7 +9937,7 @@
           <a:noFill/>
         </p:spPr>
         <p:txBody>
-          <a:bodyPr wrap="square" lIns="0" rIns="0" tIns="0" bIns="0" anchor="t">
+          <a:bodyPr wrap="square" lIns="0" tIns="0" rIns="0" bIns="0" anchor="t">
             <a:spAutoFit/>
           </a:bodyPr>
           <a:lstStyle/>
@@ -10065,6 +10003,7 @@
           <a:lstStyle/>
           <a:p>
             <a:pPr algn="ctr"/>
+            <a:endParaRPr/>
           </a:p>
         </p:txBody>
       </p:sp>
@@ -10085,7 +10024,7 @@
           <a:noFill/>
         </p:spPr>
         <p:txBody>
-          <a:bodyPr wrap="square" lIns="0" rIns="0" tIns="0" bIns="0" anchor="t">
+          <a:bodyPr wrap="square" lIns="0" tIns="0" rIns="0" bIns="0" anchor="t">
             <a:spAutoFit/>
           </a:bodyPr>
           <a:lstStyle/>
@@ -10149,7 +10088,9 @@
         <p:txBody>
           <a:bodyPr rtlCol="0" anchor="ctr"/>
           <a:lstStyle/>
-          <a:p/>
+          <a:p>
+            <a:endParaRPr/>
+          </a:p>
         </p:txBody>
       </p:sp>
       <p:sp>
@@ -10169,7 +10110,7 @@
           <a:noFill/>
         </p:spPr>
         <p:txBody>
-          <a:bodyPr wrap="square" lIns="0" rIns="0" tIns="0" bIns="0" anchor="t">
+          <a:bodyPr wrap="square" lIns="0" tIns="0" rIns="0" bIns="0" anchor="t">
             <a:spAutoFit/>
           </a:bodyPr>
           <a:lstStyle/>
@@ -10211,7 +10152,7 @@
           <a:noFill/>
         </p:spPr>
         <p:txBody>
-          <a:bodyPr wrap="square" lIns="0" rIns="0" tIns="0" bIns="0" anchor="t">
+          <a:bodyPr wrap="square" lIns="0" tIns="0" rIns="0" bIns="0" anchor="t">
             <a:spAutoFit/>
           </a:bodyPr>
           <a:lstStyle/>
@@ -10253,7 +10194,7 @@
           <a:noFill/>
         </p:spPr>
         <p:txBody>
-          <a:bodyPr wrap="square" lIns="0" rIns="0" tIns="0" bIns="0" anchor="t">
+          <a:bodyPr wrap="square" lIns="0" tIns="0" rIns="0" bIns="0" anchor="t">
             <a:spAutoFit/>
           </a:bodyPr>
           <a:lstStyle/>
@@ -10339,7 +10280,7 @@
           <a:noFill/>
         </p:spPr>
         <p:txBody>
-          <a:bodyPr wrap="square" lIns="0" rIns="0" tIns="0" bIns="0" anchor="t">
+          <a:bodyPr wrap="square" lIns="0" tIns="0" rIns="0" bIns="0" anchor="t">
             <a:spAutoFit/>
           </a:bodyPr>
           <a:lstStyle/>
@@ -10381,7 +10322,7 @@
           <a:noFill/>
         </p:spPr>
         <p:txBody>
-          <a:bodyPr wrap="square" lIns="0" rIns="0" tIns="0" bIns="0" anchor="t">
+          <a:bodyPr wrap="square" lIns="0" tIns="0" rIns="0" bIns="0" anchor="t">
             <a:spAutoFit/>
           </a:bodyPr>
           <a:lstStyle/>
@@ -10415,7 +10356,7 @@
 </file>
 
 <file path=ppt/slides/slide6.xml><?xml version="1.0" encoding="utf-8"?>
-<p:sld xmlns:a="http://schemas.openxmlformats.org/drawingml/2006/main" xmlns:p="http://schemas.openxmlformats.org/presentationml/2006/main" xmlns:r="http://schemas.openxmlformats.org/officeDocument/2006/relationships">
+<p:sld xmlns:a="http://schemas.openxmlformats.org/drawingml/2006/main" xmlns:r="http://schemas.openxmlformats.org/officeDocument/2006/relationships" xmlns:p="http://schemas.openxmlformats.org/presentationml/2006/main">
   <p:cSld>
     <p:spTree>
       <p:nvGrpSpPr>
@@ -10423,7 +10364,14 @@
         <p:cNvGrpSpPr/>
         <p:nvPr/>
       </p:nvGrpSpPr>
-      <p:grpSpPr/>
+      <p:grpSpPr>
+        <a:xfrm>
+          <a:off x="0" y="0"/>
+          <a:ext cx="0" cy="0"/>
+          <a:chOff x="0" y="0"/>
+          <a:chExt cx="0" cy="0"/>
+        </a:xfrm>
+      </p:grpSpPr>
       <p:sp>
         <p:nvSpPr>
           <p:cNvPr id="2" name="Rectangle 1"/>
@@ -10463,7 +10411,9 @@
         <p:txBody>
           <a:bodyPr rtlCol="0" anchor="ctr"/>
           <a:lstStyle/>
-          <a:p/>
+          <a:p>
+            <a:endParaRPr/>
+          </a:p>
         </p:txBody>
       </p:sp>
       <p:sp>
@@ -10483,7 +10433,7 @@
           <a:noFill/>
         </p:spPr>
         <p:txBody>
-          <a:bodyPr wrap="square" lIns="0" rIns="0" tIns="0" bIns="0" anchor="t">
+          <a:bodyPr wrap="square" lIns="0" tIns="0" rIns="0" bIns="0" anchor="t">
             <a:spAutoFit/>
           </a:bodyPr>
           <a:lstStyle/>
@@ -10525,7 +10475,7 @@
           <a:noFill/>
         </p:spPr>
         <p:txBody>
-          <a:bodyPr wrap="square" lIns="0" rIns="0" tIns="0" bIns="0" anchor="t">
+          <a:bodyPr wrap="square" lIns="0" tIns="0" rIns="0" bIns="0" anchor="t">
             <a:spAutoFit/>
           </a:bodyPr>
           <a:lstStyle/>
@@ -10567,7 +10517,7 @@
           <a:noFill/>
         </p:spPr>
         <p:txBody>
-          <a:bodyPr wrap="square" lIns="0" rIns="0" tIns="0" bIns="0" anchor="t">
+          <a:bodyPr wrap="square" lIns="0" tIns="0" rIns="0" bIns="0" anchor="t">
             <a:spAutoFit/>
           </a:bodyPr>
           <a:lstStyle/>
@@ -10609,7 +10559,7 @@
           <a:noFill/>
         </p:spPr>
         <p:txBody>
-          <a:bodyPr wrap="square" lIns="0" rIns="0" tIns="0" bIns="0" anchor="t">
+          <a:bodyPr wrap="square" lIns="0" tIns="0" rIns="0" bIns="0" anchor="t">
             <a:spAutoFit/>
           </a:bodyPr>
           <a:lstStyle/>
@@ -10629,25 +10579,7 @@
                 </a:solidFill>
                 <a:latin typeface="Calibri"/>
               </a:rPr>
-              <a:t>Learn what </a:t>
-            </a:r>
-            <a:r>
-              <a:rPr sz="1500" b="0" i="1">
-                <a:solidFill>
-                  <a:srgbClr val="1F2937"/>
-                </a:solidFill>
-                <a:latin typeface="Calibri"/>
-              </a:rPr>
-              <a:t>normal</a:t>
-            </a:r>
-            <a:r>
-              <a:rPr sz="1500" b="0" i="1">
-                <a:solidFill>
-                  <a:srgbClr val="1F2937"/>
-                </a:solidFill>
-                <a:latin typeface="Calibri"/>
-              </a:rPr>
-              <a:t> looks like; flag what does not fit.</a:t>
+              <a:t>Learn what normal looks like; flag what does not fit.</a:t>
             </a:r>
           </a:p>
         </p:txBody>
@@ -10669,7 +10601,7 @@
           <a:noFill/>
         </p:spPr>
         <p:txBody>
-          <a:bodyPr wrap="square" lIns="0" rIns="0" tIns="0" bIns="0">
+          <a:bodyPr wrap="square" lIns="0" tIns="0" rIns="0" bIns="0">
             <a:spAutoFit/>
           </a:bodyPr>
           <a:lstStyle/>
@@ -10848,7 +10780,9 @@
         <p:txBody>
           <a:bodyPr rtlCol="0" anchor="ctr"/>
           <a:lstStyle/>
-          <a:p/>
+          <a:p>
+            <a:endParaRPr/>
+          </a:p>
         </p:txBody>
       </p:sp>
       <p:sp>
@@ -10868,7 +10802,7 @@
           <a:noFill/>
         </p:spPr>
         <p:txBody>
-          <a:bodyPr wrap="square" lIns="0" rIns="0" tIns="0" bIns="0" anchor="t">
+          <a:bodyPr wrap="square" lIns="0" tIns="0" rIns="0" bIns="0" anchor="t">
             <a:spAutoFit/>
           </a:bodyPr>
           <a:lstStyle/>
@@ -10910,7 +10844,7 @@
           <a:noFill/>
         </p:spPr>
         <p:txBody>
-          <a:bodyPr wrap="square" lIns="0" rIns="0" tIns="0" bIns="0" anchor="t">
+          <a:bodyPr wrap="square" lIns="0" tIns="0" rIns="0" bIns="0" anchor="t">
             <a:spAutoFit/>
           </a:bodyPr>
           <a:lstStyle/>
@@ -11043,7 +10977,7 @@
           <a:noFill/>
         </p:spPr>
         <p:txBody>
-          <a:bodyPr wrap="square" lIns="0" rIns="0" tIns="0" bIns="0" anchor="t">
+          <a:bodyPr wrap="square" lIns="0" tIns="0" rIns="0" bIns="0" anchor="t">
             <a:spAutoFit/>
           </a:bodyPr>
           <a:lstStyle/>
@@ -11085,7 +11019,7 @@
           <a:noFill/>
         </p:spPr>
         <p:txBody>
-          <a:bodyPr wrap="square" lIns="0" rIns="0" tIns="0" bIns="0" anchor="t">
+          <a:bodyPr wrap="square" lIns="0" tIns="0" rIns="0" bIns="0" anchor="t">
             <a:spAutoFit/>
           </a:bodyPr>
           <a:lstStyle/>
@@ -11119,7 +11053,7 @@
 </file>
 
 <file path=ppt/slides/slide7.xml><?xml version="1.0" encoding="utf-8"?>
-<p:sld xmlns:a="http://schemas.openxmlformats.org/drawingml/2006/main" xmlns:p="http://schemas.openxmlformats.org/presentationml/2006/main" xmlns:r="http://schemas.openxmlformats.org/officeDocument/2006/relationships">
+<p:sld xmlns:a="http://schemas.openxmlformats.org/drawingml/2006/main" xmlns:r="http://schemas.openxmlformats.org/officeDocument/2006/relationships" xmlns:p="http://schemas.openxmlformats.org/presentationml/2006/main">
   <p:cSld>
     <p:spTree>
       <p:nvGrpSpPr>
@@ -11127,7 +11061,14 @@
         <p:cNvGrpSpPr/>
         <p:nvPr/>
       </p:nvGrpSpPr>
-      <p:grpSpPr/>
+      <p:grpSpPr>
+        <a:xfrm>
+          <a:off x="0" y="0"/>
+          <a:ext cx="0" cy="0"/>
+          <a:chOff x="0" y="0"/>
+          <a:chExt cx="0" cy="0"/>
+        </a:xfrm>
+      </p:grpSpPr>
       <p:sp>
         <p:nvSpPr>
           <p:cNvPr id="2" name="Rectangle 1"/>
@@ -11167,7 +11108,9 @@
         <p:txBody>
           <a:bodyPr rtlCol="0" anchor="ctr"/>
           <a:lstStyle/>
-          <a:p/>
+          <a:p>
+            <a:endParaRPr/>
+          </a:p>
         </p:txBody>
       </p:sp>
       <p:sp>
@@ -11187,7 +11130,7 @@
           <a:noFill/>
         </p:spPr>
         <p:txBody>
-          <a:bodyPr wrap="square" lIns="0" rIns="0" tIns="0" bIns="0" anchor="t">
+          <a:bodyPr wrap="square" lIns="0" tIns="0" rIns="0" bIns="0" anchor="t">
             <a:spAutoFit/>
           </a:bodyPr>
           <a:lstStyle/>
@@ -11229,7 +11172,7 @@
           <a:noFill/>
         </p:spPr>
         <p:txBody>
-          <a:bodyPr wrap="square" lIns="0" rIns="0" tIns="0" bIns="0" anchor="t">
+          <a:bodyPr wrap="square" lIns="0" tIns="0" rIns="0" bIns="0" anchor="t">
             <a:spAutoFit/>
           </a:bodyPr>
           <a:lstStyle/>
@@ -11295,7 +11238,9 @@
         <p:txBody>
           <a:bodyPr rtlCol="0" anchor="ctr"/>
           <a:lstStyle/>
-          <a:p/>
+          <a:p>
+            <a:endParaRPr/>
+          </a:p>
         </p:txBody>
       </p:sp>
       <p:sp>
@@ -11315,7 +11260,7 @@
           <a:noFill/>
         </p:spPr>
         <p:txBody>
-          <a:bodyPr wrap="square" lIns="0" rIns="0" tIns="0" bIns="0" anchor="t">
+          <a:bodyPr wrap="square" lIns="0" tIns="0" rIns="0" bIns="0" anchor="t">
             <a:spAutoFit/>
           </a:bodyPr>
           <a:lstStyle/>
@@ -11366,12 +11311,12 @@
           <a:noFill/>
         </p:spPr>
         <p:txBody>
-          <a:bodyPr wrap="square" lIns="0" rIns="0" tIns="0" bIns="0" anchor="t">
+          <a:bodyPr wrap="square" lIns="0" tIns="0" rIns="0" bIns="0" anchor="t">
             <a:spAutoFit/>
           </a:bodyPr>
           <a:lstStyle/>
           <a:p>
-            <a:pPr algn="l" marL="320040" indent="-320040">
+            <a:pPr marL="320040" indent="-320040" algn="l">
               <a:lnSpc>
                 <a:spcPct val="100000"/>
               </a:lnSpc>
@@ -11408,7 +11353,7 @@
             </a:r>
           </a:p>
           <a:p>
-            <a:pPr algn="l" marL="320040" indent="-320040">
+            <a:pPr marL="320040" indent="-320040" algn="l">
               <a:lnSpc>
                 <a:spcPct val="100000"/>
               </a:lnSpc>
@@ -11445,7 +11390,7 @@
             </a:r>
           </a:p>
           <a:p>
-            <a:pPr algn="l" marL="320040" indent="-320040">
+            <a:pPr marL="320040" indent="-320040" algn="l">
               <a:lnSpc>
                 <a:spcPct val="100000"/>
               </a:lnSpc>
@@ -11482,7 +11427,7 @@
             </a:r>
           </a:p>
           <a:p>
-            <a:pPr algn="l" marL="320040" indent="-320040">
+            <a:pPr marL="320040" indent="-320040" algn="l">
               <a:lnSpc>
                 <a:spcPct val="100000"/>
               </a:lnSpc>
@@ -11519,7 +11464,7 @@
             </a:r>
           </a:p>
           <a:p>
-            <a:pPr algn="l" marL="320040" indent="-320040">
+            <a:pPr marL="320040" indent="-320040" algn="l">
               <a:lnSpc>
                 <a:spcPct val="100000"/>
               </a:lnSpc>
@@ -11556,7 +11501,7 @@
             </a:r>
           </a:p>
           <a:p>
-            <a:pPr algn="l" marL="320040" indent="-320040">
+            <a:pPr marL="320040" indent="-320040" algn="l">
               <a:lnSpc>
                 <a:spcPct val="100000"/>
               </a:lnSpc>
@@ -11593,7 +11538,7 @@
             </a:r>
           </a:p>
           <a:p>
-            <a:pPr algn="l" marL="320040" indent="-320040">
+            <a:pPr marL="320040" indent="-320040" algn="l">
               <a:lnSpc>
                 <a:spcPct val="100000"/>
               </a:lnSpc>
@@ -11630,7 +11575,7 @@
             </a:r>
           </a:p>
           <a:p>
-            <a:pPr algn="l" marL="320040" indent="-320040">
+            <a:pPr marL="320040" indent="-320040" algn="l">
               <a:lnSpc>
                 <a:spcPct val="100000"/>
               </a:lnSpc>
@@ -11720,7 +11665,7 @@
           <a:noFill/>
         </p:spPr>
         <p:txBody>
-          <a:bodyPr wrap="square" lIns="0" rIns="0" tIns="0" bIns="0" anchor="t">
+          <a:bodyPr wrap="square" lIns="0" tIns="0" rIns="0" bIns="0" anchor="t">
             <a:spAutoFit/>
           </a:bodyPr>
           <a:lstStyle/>
@@ -11762,7 +11707,7 @@
           <a:noFill/>
         </p:spPr>
         <p:txBody>
-          <a:bodyPr wrap="square" lIns="0" rIns="0" tIns="0" bIns="0" anchor="t">
+          <a:bodyPr wrap="square" lIns="0" tIns="0" rIns="0" bIns="0" anchor="t">
             <a:spAutoFit/>
           </a:bodyPr>
           <a:lstStyle/>
@@ -12126,44 +12071,44 @@
         <a:sysClr val="window" lastClr="FFFFFF"/>
       </a:lt1>
       <a:dk2>
-        <a:srgbClr val="1F497D"/>
+        <a:srgbClr val="0E2841"/>
       </a:dk2>
       <a:lt2>
-        <a:srgbClr val="EEECE1"/>
+        <a:srgbClr val="E8E8E8"/>
       </a:lt2>
       <a:accent1>
-        <a:srgbClr val="4F81BD"/>
+        <a:srgbClr val="156082"/>
       </a:accent1>
       <a:accent2>
-        <a:srgbClr val="C0504D"/>
+        <a:srgbClr val="E97132"/>
       </a:accent2>
       <a:accent3>
-        <a:srgbClr val="9BBB59"/>
+        <a:srgbClr val="196B24"/>
       </a:accent3>
       <a:accent4>
-        <a:srgbClr val="8064A2"/>
+        <a:srgbClr val="0F9ED5"/>
       </a:accent4>
       <a:accent5>
-        <a:srgbClr val="4BACC6"/>
+        <a:srgbClr val="A02B93"/>
       </a:accent5>
       <a:accent6>
-        <a:srgbClr val="F79646"/>
+        <a:srgbClr val="4EA72E"/>
       </a:accent6>
       <a:hlink>
-        <a:srgbClr val="0000FF"/>
+        <a:srgbClr val="467886"/>
       </a:hlink>
       <a:folHlink>
-        <a:srgbClr val="800080"/>
+        <a:srgbClr val="96607D"/>
       </a:folHlink>
     </a:clrScheme>
     <a:fontScheme name="Office">
       <a:majorFont>
-        <a:latin typeface="Calibri"/>
+        <a:latin typeface="Aptos Display" panose="02110004020202020204"/>
         <a:ea typeface=""/>
         <a:cs typeface=""/>
-        <a:font script="Jpan" typeface="ＭＳ Ｐゴシック"/>
+        <a:font script="Jpan" typeface="游ゴシック Light"/>
         <a:font script="Hang" typeface="맑은 고딕"/>
-        <a:font script="Hans" typeface="宋体"/>
+        <a:font script="Hans" typeface="等线 Light"/>
         <a:font script="Hant" typeface="新細明體"/>
         <a:font script="Arab" typeface="Times New Roman"/>
         <a:font script="Hebr" typeface="Times New Roman"/>
@@ -12191,14 +12136,31 @@
         <a:font script="Viet" typeface="Times New Roman"/>
         <a:font script="Uigh" typeface="Microsoft Uighur"/>
         <a:font script="Geor" typeface="Sylfaen"/>
+        <a:font script="Armn" typeface="Arial"/>
+        <a:font script="Bugi" typeface="Leelawadee UI"/>
+        <a:font script="Bopo" typeface="Microsoft JhengHei"/>
+        <a:font script="Java" typeface="Javanese Text"/>
+        <a:font script="Lisu" typeface="Segoe UI"/>
+        <a:font script="Mymr" typeface="Myanmar Text"/>
+        <a:font script="Nkoo" typeface="Ebrima"/>
+        <a:font script="Olck" typeface="Nirmala UI"/>
+        <a:font script="Osma" typeface="Ebrima"/>
+        <a:font script="Phag" typeface="Phagspa"/>
+        <a:font script="Syrn" typeface="Estrangelo Edessa"/>
+        <a:font script="Syrj" typeface="Estrangelo Edessa"/>
+        <a:font script="Syre" typeface="Estrangelo Edessa"/>
+        <a:font script="Sora" typeface="Nirmala UI"/>
+        <a:font script="Tale" typeface="Microsoft Tai Le"/>
+        <a:font script="Talu" typeface="Microsoft New Tai Lue"/>
+        <a:font script="Tfng" typeface="Ebrima"/>
       </a:majorFont>
       <a:minorFont>
-        <a:latin typeface="Calibri"/>
+        <a:latin typeface="Aptos" panose="02110004020202020204"/>
         <a:ea typeface=""/>
         <a:cs typeface=""/>
-        <a:font script="Jpan" typeface="ＭＳ Ｐゴシック"/>
+        <a:font script="Jpan" typeface="游ゴシック"/>
         <a:font script="Hang" typeface="맑은 고딕"/>
-        <a:font script="Hans" typeface="宋体"/>
+        <a:font script="Hans" typeface="等线"/>
         <a:font script="Hant" typeface="新細明體"/>
         <a:font script="Arab" typeface="Arial"/>
         <a:font script="Hebr" typeface="Arial"/>
@@ -12226,6 +12188,23 @@
         <a:font script="Viet" typeface="Arial"/>
         <a:font script="Uigh" typeface="Microsoft Uighur"/>
         <a:font script="Geor" typeface="Sylfaen"/>
+        <a:font script="Armn" typeface="Arial"/>
+        <a:font script="Bugi" typeface="Leelawadee UI"/>
+        <a:font script="Bopo" typeface="Microsoft JhengHei"/>
+        <a:font script="Java" typeface="Javanese Text"/>
+        <a:font script="Lisu" typeface="Segoe UI"/>
+        <a:font script="Mymr" typeface="Myanmar Text"/>
+        <a:font script="Nkoo" typeface="Ebrima"/>
+        <a:font script="Olck" typeface="Nirmala UI"/>
+        <a:font script="Osma" typeface="Ebrima"/>
+        <a:font script="Phag" typeface="Phagspa"/>
+        <a:font script="Syrn" typeface="Estrangelo Edessa"/>
+        <a:font script="Syrj" typeface="Estrangelo Edessa"/>
+        <a:font script="Syre" typeface="Estrangelo Edessa"/>
+        <a:font script="Sora" typeface="Nirmala UI"/>
+        <a:font script="Tale" typeface="Microsoft Tai Le"/>
+        <a:font script="Talu" typeface="Microsoft New Tai Lue"/>
+        <a:font script="Tfng" typeface="Ebrima"/>
       </a:minorFont>
     </a:fontScheme>
     <a:fmtScheme name="Office">
@@ -12237,180 +12216,136 @@
           <a:gsLst>
             <a:gs pos="0">
               <a:schemeClr val="phClr">
-                <a:tint val="50000"/>
-                <a:satMod val="300000"/>
+                <a:lumMod val="110000"/>
+                <a:satMod val="105000"/>
+                <a:tint val="67000"/>
               </a:schemeClr>
             </a:gs>
-            <a:gs pos="35000">
+            <a:gs pos="50000">
               <a:schemeClr val="phClr">
-                <a:tint val="37000"/>
-                <a:satMod val="300000"/>
+                <a:lumMod val="105000"/>
+                <a:satMod val="103000"/>
+                <a:tint val="73000"/>
               </a:schemeClr>
             </a:gs>
             <a:gs pos="100000">
               <a:schemeClr val="phClr">
-                <a:tint val="15000"/>
-                <a:satMod val="350000"/>
+                <a:lumMod val="105000"/>
+                <a:satMod val="109000"/>
+                <a:tint val="81000"/>
               </a:schemeClr>
             </a:gs>
           </a:gsLst>
-          <a:lin ang="16200000" scaled="1"/>
+          <a:lin ang="5400000" scaled="0"/>
         </a:gradFill>
         <a:gradFill rotWithShape="1">
           <a:gsLst>
             <a:gs pos="0">
               <a:schemeClr val="phClr">
-                <a:tint val="100000"/>
+                <a:satMod val="103000"/>
+                <a:lumMod val="102000"/>
+                <a:tint val="94000"/>
+              </a:schemeClr>
+            </a:gs>
+            <a:gs pos="50000">
+              <a:schemeClr val="phClr">
+                <a:satMod val="110000"/>
+                <a:lumMod val="100000"/>
                 <a:shade val="100000"/>
-                <a:satMod val="130000"/>
               </a:schemeClr>
             </a:gs>
             <a:gs pos="100000">
               <a:schemeClr val="phClr">
-                <a:tint val="50000"/>
-                <a:shade val="100000"/>
-                <a:satMod val="350000"/>
+                <a:lumMod val="99000"/>
+                <a:satMod val="120000"/>
+                <a:shade val="78000"/>
               </a:schemeClr>
             </a:gs>
           </a:gsLst>
-          <a:lin ang="16200000" scaled="0"/>
+          <a:lin ang="5400000" scaled="0"/>
         </a:gradFill>
       </a:fillStyleLst>
       <a:lnStyleLst>
-        <a:ln w="9525" cap="flat" cmpd="sng" algn="ctr">
+        <a:ln w="12700" cap="flat" cmpd="sng" algn="ctr">
           <a:solidFill>
-            <a:schemeClr val="phClr">
-              <a:shade val="95000"/>
-              <a:satMod val="105000"/>
-            </a:schemeClr>
+            <a:schemeClr val="phClr"/>
           </a:solidFill>
           <a:prstDash val="solid"/>
+          <a:miter lim="800000"/>
+        </a:ln>
+        <a:ln w="19050" cap="flat" cmpd="sng" algn="ctr">
+          <a:solidFill>
+            <a:schemeClr val="phClr"/>
+          </a:solidFill>
+          <a:prstDash val="solid"/>
+          <a:miter lim="800000"/>
         </a:ln>
         <a:ln w="25400" cap="flat" cmpd="sng" algn="ctr">
           <a:solidFill>
             <a:schemeClr val="phClr"/>
           </a:solidFill>
           <a:prstDash val="solid"/>
-        </a:ln>
-        <a:ln w="38100" cap="flat" cmpd="sng" algn="ctr">
-          <a:solidFill>
-            <a:schemeClr val="phClr"/>
-          </a:solidFill>
-          <a:prstDash val="solid"/>
+          <a:miter lim="800000"/>
         </a:ln>
       </a:lnStyleLst>
       <a:effectStyleLst>
         <a:effectStyle>
+          <a:effectLst/>
+        </a:effectStyle>
+        <a:effectStyle>
+          <a:effectLst/>
+        </a:effectStyle>
+        <a:effectStyle>
           <a:effectLst>
-            <a:outerShdw blurRad="40000" dist="20000" dir="5400000" rotWithShape="0">
+            <a:outerShdw blurRad="57150" dist="19050" dir="5400000" algn="ctr" rotWithShape="0">
               <a:srgbClr val="000000">
-                <a:alpha val="38000"/>
+                <a:alpha val="63000"/>
               </a:srgbClr>
             </a:outerShdw>
           </a:effectLst>
-        </a:effectStyle>
-        <a:effectStyle>
-          <a:effectLst>
-            <a:outerShdw blurRad="40000" dist="23000" dir="5400000" rotWithShape="0">
-              <a:srgbClr val="000000">
-                <a:alpha val="35000"/>
-              </a:srgbClr>
-            </a:outerShdw>
-          </a:effectLst>
-        </a:effectStyle>
-        <a:effectStyle>
-          <a:effectLst>
-            <a:outerShdw blurRad="40000" dist="23000" dir="5400000" rotWithShape="0">
-              <a:srgbClr val="000000">
-                <a:alpha val="35000"/>
-              </a:srgbClr>
-            </a:outerShdw>
-          </a:effectLst>
-          <a:scene3d>
-            <a:camera prst="orthographicFront">
-              <a:rot lat="0" lon="0" rev="0"/>
-            </a:camera>
-            <a:lightRig rig="threePt" dir="t">
-              <a:rot lat="0" lon="0" rev="1200000"/>
-            </a:lightRig>
-          </a:scene3d>
-          <a:sp3d>
-            <a:bevelT w="63500" h="25400"/>
-          </a:sp3d>
         </a:effectStyle>
       </a:effectStyleLst>
       <a:bgFillStyleLst>
         <a:solidFill>
           <a:schemeClr val="phClr"/>
         </a:solidFill>
+        <a:solidFill>
+          <a:schemeClr val="phClr">
+            <a:tint val="95000"/>
+            <a:satMod val="170000"/>
+          </a:schemeClr>
+        </a:solidFill>
         <a:gradFill rotWithShape="1">
           <a:gsLst>
             <a:gs pos="0">
               <a:schemeClr val="phClr">
-                <a:tint val="40000"/>
-                <a:satMod val="350000"/>
+                <a:tint val="93000"/>
+                <a:satMod val="150000"/>
+                <a:shade val="98000"/>
+                <a:lumMod val="102000"/>
               </a:schemeClr>
             </a:gs>
-            <a:gs pos="40000">
+            <a:gs pos="50000">
               <a:schemeClr val="phClr">
-                <a:tint val="45000"/>
-                <a:shade val="99000"/>
-                <a:satMod val="350000"/>
+                <a:tint val="98000"/>
+                <a:satMod val="130000"/>
+                <a:shade val="90000"/>
+                <a:lumMod val="103000"/>
               </a:schemeClr>
             </a:gs>
             <a:gs pos="100000">
               <a:schemeClr val="phClr">
-                <a:shade val="20000"/>
-                <a:satMod val="255000"/>
+                <a:shade val="63000"/>
+                <a:satMod val="120000"/>
               </a:schemeClr>
             </a:gs>
           </a:gsLst>
-          <a:path path="circle">
-            <a:fillToRect l="50000" t="-80000" r="50000" b="180000"/>
-          </a:path>
-        </a:gradFill>
-        <a:gradFill rotWithShape="1">
-          <a:gsLst>
-            <a:gs pos="0">
-              <a:schemeClr val="phClr">
-                <a:tint val="80000"/>
-                <a:satMod val="300000"/>
-              </a:schemeClr>
-            </a:gs>
-            <a:gs pos="100000">
-              <a:schemeClr val="phClr">
-                <a:shade val="30000"/>
-                <a:satMod val="200000"/>
-              </a:schemeClr>
-            </a:gs>
-          </a:gsLst>
-          <a:path path="circle">
-            <a:fillToRect l="50000" t="50000" r="50000" b="50000"/>
-          </a:path>
+          <a:lin ang="5400000" scaled="0"/>
         </a:gradFill>
       </a:bgFillStyleLst>
     </a:fmtScheme>
   </a:themeElements>
   <a:objectDefaults>
-    <a:spDef>
-      <a:spPr/>
-      <a:bodyPr/>
-      <a:lstStyle/>
-      <a:style>
-        <a:lnRef idx="1">
-          <a:schemeClr val="accent1"/>
-        </a:lnRef>
-        <a:fillRef idx="3">
-          <a:schemeClr val="accent1"/>
-        </a:fillRef>
-        <a:effectRef idx="2">
-          <a:schemeClr val="accent1"/>
-        </a:effectRef>
-        <a:fontRef idx="minor">
-          <a:schemeClr val="lt1"/>
-        </a:fontRef>
-      </a:style>
-    </a:spDef>
     <a:lnDef>
       <a:spPr/>
       <a:bodyPr/>
@@ -12432,5 +12367,10 @@
     </a:lnDef>
   </a:objectDefaults>
   <a:extraClrSchemeLst/>
+  <a:extLst>
+    <a:ext uri="{05A4C25C-085E-4340-85A3-A5531E510DB2}">
+      <thm15:themeFamily xmlns:thm15="http://schemas.microsoft.com/office/thememl/2012/main" name="Office Theme" id="{2E142A2C-CD16-42D6-873A-C26D2A0506FA}" vid="{1BDDFF52-6CD6-40A5-AB3C-68EB2F1E4D0A}"/>
+    </a:ext>
+  </a:extLst>
 </a:theme>
 </file>
</xml_diff>